<commit_message>
Add badges/shields as a concrete OSS contribution example
Adds real stats (stars, license, contribution guidelines) for
github.com/badges/shields to the "contribute to other projects"
section, as a concrete, well-documented example project.

Co-Authored-By: Claude Sonnet 5 <noreply@anthropic.com>
Claude-Session: https://claude.ai/code/session_011KHa4MUwNn3SuV95WoncKQ
</commit_message>
<xml_diff>
--- a/github-strategy-guide.pptx
+++ b/github-strategy-guide.pptx
@@ -16,9 +16,10 @@
     <p:sldId id="264" r:id="rId10"/>
     <p:sldId id="265" r:id="rId11"/>
     <p:sldId id="266" r:id="rId12"/>
+    <p:sldId id="267" r:id="rId13"/>
   </p:sldIdLst>
   <p:notesMasterIdLst>
-    <p:notesMasterId r:id="rId13"/>
+    <p:notesMasterId r:id="rId14"/>
   </p:notesMasterIdLst>
   <p:sldSz cx="12192000" cy="6858000"/>
   <p:notesSz cx="6858000" cy="12192000"/>
@@ -712,6 +713,94 @@
             <a:fld id="{F7021451-1387-4CA6-816F-3879F97B5CBC}" type="slidenum">
               <a:rPr lang="en-US"/>
               <a:t>11</a:t>
+            </a:fld>
+            <a:endParaRPr lang="en-US"/>
+          </a:p>
+        </p:txBody>
+      </p:sp>
+    </p:spTree>
+    <p:extLst>
+      <p:ext uri="{BB962C8B-B14F-4D97-AF65-F5344CB8AC3E}">
+        <p14:creationId xmlns:p14="http://schemas.microsoft.com/office/powerpoint/2010/main" val="1024086991"/>
+      </p:ext>
+    </p:extLst>
+  </p:cSld>
+  <p:clrMapOvr>
+    <a:masterClrMapping/>
+  </p:clrMapOvr>
+</p:notes>
+</file>
+
+<file path=ppt/notesSlides/notesSlide12.xml><?xml version="1.0" encoding="utf-8"?>
+<p:notes xmlns:a="http://schemas.openxmlformats.org/drawingml/2006/main" xmlns:r="http://schemas.openxmlformats.org/officeDocument/2006/relationships" xmlns:p="http://schemas.openxmlformats.org/presentationml/2006/main">
+  <p:cSld>
+    <p:spTree>
+      <p:nvGrpSpPr>
+        <p:cNvPr id="1" name=""/>
+        <p:cNvGrpSpPr/>
+        <p:nvPr/>
+      </p:nvGrpSpPr>
+      <p:grpSpPr>
+        <a:xfrm>
+          <a:off x="0" y="0"/>
+          <a:ext cx="0" cy="0"/>
+          <a:chOff x="0" y="0"/>
+          <a:chExt cx="0" cy="0"/>
+        </a:xfrm>
+      </p:grpSpPr>
+      <p:sp>
+        <p:nvSpPr>
+          <p:cNvPr id="2" name="Slide Image Placeholder 1"/>
+          <p:cNvSpPr>
+            <a:spLocks noGrp="1" noRot="1" noChangeAspect="1"/>
+          </p:cNvSpPr>
+          <p:nvPr>
+            <p:ph type="sldImg"/>
+          </p:nvPr>
+        </p:nvSpPr>
+        <p:spPr/>
+      </p:sp>
+      <p:sp>
+        <p:nvSpPr>
+          <p:cNvPr id="3" name="Notes Placeholder 2"/>
+          <p:cNvSpPr>
+            <a:spLocks noGrp="1"/>
+          </p:cNvSpPr>
+          <p:nvPr>
+            <p:ph type="body" idx="1"/>
+          </p:nvPr>
+        </p:nvSpPr>
+        <p:spPr/>
+        <p:txBody>
+          <a:bodyPr/>
+          <a:lstStyle/>
+          <a:p>
+            <a:r>
+              <a:rPr lang="en-US" dirty="0"/>
+              <a:t/>
+            </a:r>
+            <a:endParaRPr lang="en-US" dirty="0"/>
+          </a:p>
+        </p:txBody>
+      </p:sp>
+      <p:sp>
+        <p:nvSpPr>
+          <p:cNvPr id="4" name="Slide Number Placeholder 3"/>
+          <p:cNvSpPr>
+            <a:spLocks noGrp="1"/>
+          </p:cNvSpPr>
+          <p:nvPr>
+            <p:ph type="sldNum" sz="quarter" idx="10"/>
+          </p:nvPr>
+        </p:nvSpPr>
+        <p:spPr/>
+        <p:txBody>
+          <a:bodyPr/>
+          <a:lstStyle/>
+          <a:p>
+            <a:fld id="{F7021451-1387-4CA6-816F-3879F97B5CBC}" type="slidenum">
+              <a:rPr lang="en-US"/>
+              <a:t>12</a:t>
             </a:fld>
             <a:endParaRPr lang="en-US"/>
           </a:p>
@@ -2030,7 +2119,7 @@
                 <a:ea typeface="Cambria" pitchFamily="34" charset="-122"/>
                 <a:cs typeface="Cambria" pitchFamily="34" charset="-120"/>
               </a:rPr>
-              <a:t>6</a:t>
+              <a:t>5</a:t>
             </a:r>
             <a:endParaRPr lang="en-US" sz="2800" dirty="0"/>
           </a:p>
@@ -2069,7 +2158,7 @@
                 <a:ea typeface="Cambria" pitchFamily="34" charset="-122"/>
                 <a:cs typeface="Cambria" pitchFamily="34" charset="-120"/>
               </a:rPr>
-              <a:t>リポジトリ運用のコツ</a:t>
+              <a:t>実証済み5ステップ(別の実例: npmライブラリ)</a:t>
             </a:r>
             <a:endParaRPr lang="en-US" sz="2600" dirty="0"/>
           </a:p>
@@ -2077,91 +2166,167 @@
       </p:sp>
       <p:sp>
         <p:nvSpPr>
-          <p:cNvPr id="4" name="Shape 2"/>
+          <p:cNvPr id="4" name="Text 2"/>
+          <p:cNvSpPr txBox="1"/>
+          <p:nvPr/>
+        </p:nvSpPr>
+        <p:spPr>
+          <a:xfrm>
+            <a:off x="548640" y="1417320"/>
+            <a:ext cx="10607040" cy="365760"/>
+          </a:xfrm>
+          <a:prstGeom prst="rect">
+            <a:avLst/>
+          </a:prstGeom>
+          <a:noFill/>
+          <a:ln/>
+        </p:spPr>
+        <p:txBody>
+          <a:bodyPr wrap="square" lIns="0" tIns="0" rIns="0" bIns="0" rtlCol="0" anchor="ctr"/>
+          <a:lstStyle/>
+          <a:p>
+            <a:pPr indent="0" marL="0">
+              <a:buNone/>
+            </a:pPr>
+            <a:r>
+              <a:rPr lang="en-US" sz="1250" i="1" dirty="0">
+                <a:solidFill>
+                  <a:srgbClr val="AEB7C4"/>
+                </a:solidFill>
+                <a:latin typeface="Calibri" pitchFamily="34" charset="0"/>
+                <a:ea typeface="Calibri" pitchFamily="34" charset="-122"/>
+                <a:cs typeface="Calibri" pitchFamily="34" charset="-120"/>
+              </a:rPr>
+              <a:t>SNSでの影響力がほぼ無い状態から、Githubスターを50まで伸ばした個人開発者の実例</a:t>
+            </a:r>
+            <a:endParaRPr lang="en-US" sz="1250" dirty="0"/>
+          </a:p>
+        </p:txBody>
+      </p:sp>
+      <p:sp>
+        <p:nvSpPr>
+          <p:cNvPr id="5" name="Shape 3"/>
           <p:cNvSpPr/>
           <p:nvPr/>
         </p:nvSpPr>
         <p:spPr>
           <a:xfrm>
-            <a:off x="548640" y="1737360"/>
-            <a:ext cx="3566160" cy="2377440"/>
-          </a:xfrm>
-          <a:prstGeom prst="roundRect">
-            <a:avLst>
-              <a:gd name="adj" fmla="val 4615"/>
-            </a:avLst>
+            <a:off x="548640" y="1965960"/>
+            <a:ext cx="384048" cy="384048"/>
+          </a:xfrm>
+          <a:prstGeom prst="ellipse">
+            <a:avLst/>
           </a:prstGeom>
           <a:solidFill>
-            <a:srgbClr val="232A34"/>
+            <a:srgbClr val="58D68D"/>
           </a:solidFill>
           <a:ln/>
         </p:spPr>
       </p:sp>
       <p:sp>
         <p:nvSpPr>
-          <p:cNvPr id="5" name="Text 3"/>
-          <p:cNvSpPr txBox="1"/>
-          <p:nvPr/>
-        </p:nvSpPr>
-        <p:spPr>
-          <a:xfrm>
-            <a:off x="822960" y="1965960"/>
-            <a:ext cx="3017520" cy="457200"/>
-          </a:xfrm>
-          <a:prstGeom prst="rect">
-            <a:avLst/>
-          </a:prstGeom>
-          <a:noFill/>
-          <a:ln/>
-        </p:spPr>
-        <p:txBody>
-          <a:bodyPr wrap="square" lIns="0" tIns="0" rIns="0" bIns="0" rtlCol="0" anchor="ctr"/>
-          <a:lstStyle/>
-          <a:p>
-            <a:pPr indent="0" marL="0">
-              <a:buNone/>
-            </a:pPr>
-            <a:r>
-              <a:rPr lang="en-US" sz="1600" b="1" dirty="0">
-                <a:solidFill>
-                  <a:srgbClr val="58D68D"/>
-                </a:solidFill>
-                <a:latin typeface="Calibri" pitchFamily="34" charset="0"/>
-                <a:ea typeface="Calibri" pitchFamily="34" charset="-122"/>
-                <a:cs typeface="Calibri" pitchFamily="34" charset="-120"/>
-              </a:rPr>
-              <a:t>コミット</a:t>
-            </a:r>
-            <a:endParaRPr lang="en-US" sz="1600" dirty="0"/>
-          </a:p>
-        </p:txBody>
-      </p:sp>
-      <p:sp>
-        <p:nvSpPr>
           <p:cNvPr id="6" name="Text 4"/>
           <p:cNvSpPr txBox="1"/>
           <p:nvPr/>
         </p:nvSpPr>
         <p:spPr>
           <a:xfrm>
-            <a:off x="822960" y="2468880"/>
-            <a:ext cx="3017520" cy="1463040"/>
-          </a:xfrm>
-          <a:prstGeom prst="rect">
-            <a:avLst/>
-          </a:prstGeom>
-          <a:noFill/>
-          <a:ln/>
-        </p:spPr>
-        <p:txBody>
-          <a:bodyPr wrap="square" lIns="0" tIns="0" rIns="0" bIns="0" rtlCol="0" anchor="ctr"/>
-          <a:lstStyle/>
-          <a:p>
-            <a:pPr indent="0" marL="0">
-              <a:buNone/>
-            </a:pPr>
-            <a:r>
-              <a:rPr lang="en-US" sz="1250" dirty="0">
+            <a:off x="548640" y="1965960"/>
+            <a:ext cx="384048" cy="384048"/>
+          </a:xfrm>
+          <a:prstGeom prst="rect">
+            <a:avLst/>
+          </a:prstGeom>
+          <a:noFill/>
+          <a:ln/>
+        </p:spPr>
+        <p:txBody>
+          <a:bodyPr wrap="square" lIns="0" tIns="0" rIns="0" bIns="0" rtlCol="0" anchor="ctr"/>
+          <a:lstStyle/>
+          <a:p>
+            <a:pPr algn="ctr" indent="0" marL="0">
+              <a:buNone/>
+            </a:pPr>
+            <a:r>
+              <a:rPr lang="en-US" sz="1300" b="1" dirty="0">
+                <a:solidFill>
+                  <a:srgbClr val="1A1F26"/>
+                </a:solidFill>
+                <a:latin typeface="Calibri" pitchFamily="34" charset="0"/>
+                <a:ea typeface="Calibri" pitchFamily="34" charset="-122"/>
+                <a:cs typeface="Calibri" pitchFamily="34" charset="-120"/>
+              </a:rPr>
+              <a:t>1</a:t>
+            </a:r>
+            <a:endParaRPr lang="en-US" sz="1300" dirty="0"/>
+          </a:p>
+        </p:txBody>
+      </p:sp>
+      <p:sp>
+        <p:nvSpPr>
+          <p:cNvPr id="7" name="Text 5"/>
+          <p:cNvSpPr txBox="1"/>
+          <p:nvPr/>
+        </p:nvSpPr>
+        <p:spPr>
+          <a:xfrm>
+            <a:off x="1097280" y="1920240"/>
+            <a:ext cx="2926080" cy="457200"/>
+          </a:xfrm>
+          <a:prstGeom prst="rect">
+            <a:avLst/>
+          </a:prstGeom>
+          <a:noFill/>
+          <a:ln/>
+        </p:spPr>
+        <p:txBody>
+          <a:bodyPr wrap="square" lIns="0" tIns="0" rIns="0" bIns="0" rtlCol="0" anchor="t"/>
+          <a:lstStyle/>
+          <a:p>
+            <a:pPr indent="0" marL="0">
+              <a:buNone/>
+            </a:pPr>
+            <a:r>
+              <a:rPr lang="en-US" sz="1300" b="1" dirty="0">
+                <a:solidFill>
+                  <a:srgbClr val="FFFFFF"/>
+                </a:solidFill>
+                <a:latin typeface="Calibri" pitchFamily="34" charset="0"/>
+                <a:ea typeface="Calibri" pitchFamily="34" charset="-122"/>
+                <a:cs typeface="Calibri" pitchFamily="34" charset="-120"/>
+              </a:rPr>
+              <a:t>英語で書く</a:t>
+            </a:r>
+            <a:endParaRPr lang="en-US" sz="1300" dirty="0"/>
+          </a:p>
+        </p:txBody>
+      </p:sp>
+      <p:sp>
+        <p:nvSpPr>
+          <p:cNvPr id="8" name="Text 6"/>
+          <p:cNvSpPr txBox="1"/>
+          <p:nvPr/>
+        </p:nvSpPr>
+        <p:spPr>
+          <a:xfrm>
+            <a:off x="4114800" y="1920240"/>
+            <a:ext cx="6858000" cy="777240"/>
+          </a:xfrm>
+          <a:prstGeom prst="rect">
+            <a:avLst/>
+          </a:prstGeom>
+          <a:noFill/>
+          <a:ln/>
+        </p:spPr>
+        <p:txBody>
+          <a:bodyPr wrap="square" lIns="0" tIns="0" rIns="0" bIns="0" rtlCol="0" anchor="ctr"/>
+          <a:lstStyle/>
+          <a:p>
+            <a:pPr indent="0" marL="0">
+              <a:buNone/>
+            </a:pPr>
+            <a:r>
+              <a:rPr lang="en-US" sz="1150" dirty="0">
                 <a:solidFill>
                   <a:srgbClr val="AEB7C4"/>
                 </a:solidFill>
@@ -2169,99 +2334,136 @@
                 <a:ea typeface="Calibri" pitchFamily="34" charset="-122"/>
                 <a:cs typeface="Calibri" pitchFamily="34" charset="-120"/>
               </a:rPr>
-              <a:t>小さく頻繁に。メッセージは「なぜ」を書く</a:t>
-            </a:r>
-            <a:endParaRPr lang="en-US" sz="1250" dirty="0"/>
-          </a:p>
-        </p:txBody>
-      </p:sp>
-      <p:sp>
-        <p:nvSpPr>
-          <p:cNvPr id="7" name="Shape 5"/>
+              <a:t>README・告知文はすべて英語にする。日本語のみだとリーチできる人数が大きく限定される</a:t>
+            </a:r>
+            <a:endParaRPr lang="en-US" sz="1150" dirty="0"/>
+          </a:p>
+        </p:txBody>
+      </p:sp>
+      <p:sp>
+        <p:nvSpPr>
+          <p:cNvPr id="9" name="Shape 7"/>
           <p:cNvSpPr/>
           <p:nvPr/>
         </p:nvSpPr>
         <p:spPr>
           <a:xfrm>
-            <a:off x="4343400" y="1737360"/>
-            <a:ext cx="3566160" cy="2377440"/>
-          </a:xfrm>
-          <a:prstGeom prst="roundRect">
-            <a:avLst>
-              <a:gd name="adj" fmla="val 4615"/>
-            </a:avLst>
+            <a:off x="548640" y="2807208"/>
+            <a:ext cx="384048" cy="384048"/>
+          </a:xfrm>
+          <a:prstGeom prst="ellipse">
+            <a:avLst/>
           </a:prstGeom>
           <a:solidFill>
-            <a:srgbClr val="232A34"/>
+            <a:srgbClr val="58D68D"/>
           </a:solidFill>
           <a:ln/>
         </p:spPr>
       </p:sp>
       <p:sp>
         <p:nvSpPr>
-          <p:cNvPr id="8" name="Text 6"/>
-          <p:cNvSpPr txBox="1"/>
-          <p:nvPr/>
-        </p:nvSpPr>
-        <p:spPr>
-          <a:xfrm>
-            <a:off x="4617720" y="1965960"/>
-            <a:ext cx="3017520" cy="457200"/>
-          </a:xfrm>
-          <a:prstGeom prst="rect">
-            <a:avLst/>
-          </a:prstGeom>
-          <a:noFill/>
-          <a:ln/>
-        </p:spPr>
-        <p:txBody>
-          <a:bodyPr wrap="square" lIns="0" tIns="0" rIns="0" bIns="0" rtlCol="0" anchor="ctr"/>
-          <a:lstStyle/>
-          <a:p>
-            <a:pPr indent="0" marL="0">
-              <a:buNone/>
-            </a:pPr>
-            <a:r>
-              <a:rPr lang="en-US" sz="1600" b="1" dirty="0">
-                <a:solidFill>
-                  <a:srgbClr val="58D68D"/>
-                </a:solidFill>
-                <a:latin typeface="Calibri" pitchFamily="34" charset="0"/>
-                <a:ea typeface="Calibri" pitchFamily="34" charset="-122"/>
-                <a:cs typeface="Calibri" pitchFamily="34" charset="-120"/>
-              </a:rPr>
-              <a:t>Issue/PR</a:t>
-            </a:r>
-            <a:endParaRPr lang="en-US" sz="1600" dirty="0"/>
-          </a:p>
-        </p:txBody>
-      </p:sp>
-      <p:sp>
-        <p:nvSpPr>
-          <p:cNvPr id="9" name="Text 7"/>
-          <p:cNvSpPr txBox="1"/>
-          <p:nvPr/>
-        </p:nvSpPr>
-        <p:spPr>
-          <a:xfrm>
-            <a:off x="4617720" y="2468880"/>
-            <a:ext cx="3017520" cy="1463040"/>
-          </a:xfrm>
-          <a:prstGeom prst="rect">
-            <a:avLst/>
-          </a:prstGeom>
-          <a:noFill/>
-          <a:ln/>
-        </p:spPr>
-        <p:txBody>
-          <a:bodyPr wrap="square" lIns="0" tIns="0" rIns="0" bIns="0" rtlCol="0" anchor="ctr"/>
-          <a:lstStyle/>
-          <a:p>
-            <a:pPr indent="0" marL="0">
-              <a:buNone/>
-            </a:pPr>
-            <a:r>
-              <a:rPr lang="en-US" sz="1250" dirty="0">
+          <p:cNvPr id="10" name="Text 8"/>
+          <p:cNvSpPr txBox="1"/>
+          <p:nvPr/>
+        </p:nvSpPr>
+        <p:spPr>
+          <a:xfrm>
+            <a:off x="548640" y="2807208"/>
+            <a:ext cx="384048" cy="384048"/>
+          </a:xfrm>
+          <a:prstGeom prst="rect">
+            <a:avLst/>
+          </a:prstGeom>
+          <a:noFill/>
+          <a:ln/>
+        </p:spPr>
+        <p:txBody>
+          <a:bodyPr wrap="square" lIns="0" tIns="0" rIns="0" bIns="0" rtlCol="0" anchor="ctr"/>
+          <a:lstStyle/>
+          <a:p>
+            <a:pPr algn="ctr" indent="0" marL="0">
+              <a:buNone/>
+            </a:pPr>
+            <a:r>
+              <a:rPr lang="en-US" sz="1300" b="1" dirty="0">
+                <a:solidFill>
+                  <a:srgbClr val="1A1F26"/>
+                </a:solidFill>
+                <a:latin typeface="Calibri" pitchFamily="34" charset="0"/>
+                <a:ea typeface="Calibri" pitchFamily="34" charset="-122"/>
+                <a:cs typeface="Calibri" pitchFamily="34" charset="-120"/>
+              </a:rPr>
+              <a:t>2</a:t>
+            </a:r>
+            <a:endParaRPr lang="en-US" sz="1300" dirty="0"/>
+          </a:p>
+        </p:txBody>
+      </p:sp>
+      <p:sp>
+        <p:nvSpPr>
+          <p:cNvPr id="11" name="Text 9"/>
+          <p:cNvSpPr txBox="1"/>
+          <p:nvPr/>
+        </p:nvSpPr>
+        <p:spPr>
+          <a:xfrm>
+            <a:off x="1097280" y="2761488"/>
+            <a:ext cx="2926080" cy="457200"/>
+          </a:xfrm>
+          <a:prstGeom prst="rect">
+            <a:avLst/>
+          </a:prstGeom>
+          <a:noFill/>
+          <a:ln/>
+        </p:spPr>
+        <p:txBody>
+          <a:bodyPr wrap="square" lIns="0" tIns="0" rIns="0" bIns="0" rtlCol="0" anchor="t"/>
+          <a:lstStyle/>
+          <a:p>
+            <a:pPr indent="0" marL="0">
+              <a:buNone/>
+            </a:pPr>
+            <a:r>
+              <a:rPr lang="en-US" sz="1300" b="1" dirty="0">
+                <a:solidFill>
+                  <a:srgbClr val="FFFFFF"/>
+                </a:solidFill>
+                <a:latin typeface="Calibri" pitchFamily="34" charset="0"/>
+                <a:ea typeface="Calibri" pitchFamily="34" charset="-122"/>
+                <a:cs typeface="Calibri" pitchFamily="34" charset="-120"/>
+              </a:rPr>
+              <a:t>アイキャッチ画像を作る</a:t>
+            </a:r>
+            <a:endParaRPr lang="en-US" sz="1300" dirty="0"/>
+          </a:p>
+        </p:txBody>
+      </p:sp>
+      <p:sp>
+        <p:nvSpPr>
+          <p:cNvPr id="12" name="Text 10"/>
+          <p:cNvSpPr txBox="1"/>
+          <p:nvPr/>
+        </p:nvSpPr>
+        <p:spPr>
+          <a:xfrm>
+            <a:off x="4114800" y="2761488"/>
+            <a:ext cx="6858000" cy="777240"/>
+          </a:xfrm>
+          <a:prstGeom prst="rect">
+            <a:avLst/>
+          </a:prstGeom>
+          <a:noFill/>
+          <a:ln/>
+        </p:spPr>
+        <p:txBody>
+          <a:bodyPr wrap="square" lIns="0" tIns="0" rIns="0" bIns="0" rtlCol="0" anchor="ctr"/>
+          <a:lstStyle/>
+          <a:p>
+            <a:pPr indent="0" marL="0">
+              <a:buNone/>
+            </a:pPr>
+            <a:r>
+              <a:rPr lang="en-US" sz="1150" dirty="0">
                 <a:solidFill>
                   <a:srgbClr val="AEB7C4"/>
                 </a:solidFill>
@@ -2269,99 +2471,136 @@
                 <a:ea typeface="Calibri" pitchFamily="34" charset="-122"/>
                 <a:cs typeface="Calibri" pitchFamily="34" charset="-120"/>
               </a:rPr>
-              <a:t>作業ログとして活用。後から経緯を追える</a:t>
-            </a:r>
-            <a:endParaRPr lang="en-US" sz="1250" dirty="0"/>
-          </a:p>
-        </p:txBody>
-      </p:sp>
-      <p:sp>
-        <p:nvSpPr>
-          <p:cNvPr id="10" name="Shape 8"/>
+              <a:t>Canva等でOGP画像を作成し、リポジトリのSocial preview設定に登録する(第一印象を左右する)</a:t>
+            </a:r>
+            <a:endParaRPr lang="en-US" sz="1150" dirty="0"/>
+          </a:p>
+        </p:txBody>
+      </p:sp>
+      <p:sp>
+        <p:nvSpPr>
+          <p:cNvPr id="13" name="Shape 11"/>
           <p:cNvSpPr/>
           <p:nvPr/>
         </p:nvSpPr>
         <p:spPr>
           <a:xfrm>
-            <a:off x="8138160" y="1737360"/>
-            <a:ext cx="3566160" cy="2377440"/>
-          </a:xfrm>
-          <a:prstGeom prst="roundRect">
-            <a:avLst>
-              <a:gd name="adj" fmla="val 4615"/>
-            </a:avLst>
+            <a:off x="548640" y="3648456"/>
+            <a:ext cx="384048" cy="384048"/>
+          </a:xfrm>
+          <a:prstGeom prst="ellipse">
+            <a:avLst/>
           </a:prstGeom>
           <a:solidFill>
-            <a:srgbClr val="232A34"/>
+            <a:srgbClr val="58D68D"/>
           </a:solidFill>
           <a:ln/>
         </p:spPr>
       </p:sp>
       <p:sp>
         <p:nvSpPr>
-          <p:cNvPr id="11" name="Text 9"/>
-          <p:cNvSpPr txBox="1"/>
-          <p:nvPr/>
-        </p:nvSpPr>
-        <p:spPr>
-          <a:xfrm>
-            <a:off x="8412480" y="1965960"/>
-            <a:ext cx="3017520" cy="457200"/>
-          </a:xfrm>
-          <a:prstGeom prst="rect">
-            <a:avLst/>
-          </a:prstGeom>
-          <a:noFill/>
-          <a:ln/>
-        </p:spPr>
-        <p:txBody>
-          <a:bodyPr wrap="square" lIns="0" tIns="0" rIns="0" bIns="0" rtlCol="0" anchor="ctr"/>
-          <a:lstStyle/>
-          <a:p>
-            <a:pPr indent="0" marL="0">
-              <a:buNone/>
-            </a:pPr>
-            <a:r>
-              <a:rPr lang="en-US" sz="1600" b="1" dirty="0">
-                <a:solidFill>
-                  <a:srgbClr val="58D68D"/>
-                </a:solidFill>
-                <a:latin typeface="Calibri" pitchFamily="34" charset="0"/>
-                <a:ea typeface="Calibri" pitchFamily="34" charset="-122"/>
-                <a:cs typeface="Calibri" pitchFamily="34" charset="-120"/>
-              </a:rPr>
-              <a:t>ブランチ運用</a:t>
-            </a:r>
-            <a:endParaRPr lang="en-US" sz="1600" dirty="0"/>
-          </a:p>
-        </p:txBody>
-      </p:sp>
-      <p:sp>
-        <p:nvSpPr>
-          <p:cNvPr id="12" name="Text 10"/>
-          <p:cNvSpPr txBox="1"/>
-          <p:nvPr/>
-        </p:nvSpPr>
-        <p:spPr>
-          <a:xfrm>
-            <a:off x="8412480" y="2468880"/>
-            <a:ext cx="3017520" cy="1463040"/>
-          </a:xfrm>
-          <a:prstGeom prst="rect">
-            <a:avLst/>
-          </a:prstGeom>
-          <a:noFill/>
-          <a:ln/>
-        </p:spPr>
-        <p:txBody>
-          <a:bodyPr wrap="square" lIns="0" tIns="0" rIns="0" bIns="0" rtlCol="0" anchor="ctr"/>
-          <a:lstStyle/>
-          <a:p>
-            <a:pPr indent="0" marL="0">
-              <a:buNone/>
-            </a:pPr>
-            <a:r>
-              <a:rPr lang="en-US" sz="1250" dirty="0">
+          <p:cNvPr id="14" name="Text 12"/>
+          <p:cNvSpPr txBox="1"/>
+          <p:nvPr/>
+        </p:nvSpPr>
+        <p:spPr>
+          <a:xfrm>
+            <a:off x="548640" y="3648456"/>
+            <a:ext cx="384048" cy="384048"/>
+          </a:xfrm>
+          <a:prstGeom prst="rect">
+            <a:avLst/>
+          </a:prstGeom>
+          <a:noFill/>
+          <a:ln/>
+        </p:spPr>
+        <p:txBody>
+          <a:bodyPr wrap="square" lIns="0" tIns="0" rIns="0" bIns="0" rtlCol="0" anchor="ctr"/>
+          <a:lstStyle/>
+          <a:p>
+            <a:pPr algn="ctr" indent="0" marL="0">
+              <a:buNone/>
+            </a:pPr>
+            <a:r>
+              <a:rPr lang="en-US" sz="1300" b="1" dirty="0">
+                <a:solidFill>
+                  <a:srgbClr val="1A1F26"/>
+                </a:solidFill>
+                <a:latin typeface="Calibri" pitchFamily="34" charset="0"/>
+                <a:ea typeface="Calibri" pitchFamily="34" charset="-122"/>
+                <a:cs typeface="Calibri" pitchFamily="34" charset="-120"/>
+              </a:rPr>
+              <a:t>3</a:t>
+            </a:r>
+            <a:endParaRPr lang="en-US" sz="1300" dirty="0"/>
+          </a:p>
+        </p:txBody>
+      </p:sp>
+      <p:sp>
+        <p:nvSpPr>
+          <p:cNvPr id="15" name="Text 13"/>
+          <p:cNvSpPr txBox="1"/>
+          <p:nvPr/>
+        </p:nvSpPr>
+        <p:spPr>
+          <a:xfrm>
+            <a:off x="1097280" y="3602736"/>
+            <a:ext cx="2926080" cy="457200"/>
+          </a:xfrm>
+          <a:prstGeom prst="rect">
+            <a:avLst/>
+          </a:prstGeom>
+          <a:noFill/>
+          <a:ln/>
+        </p:spPr>
+        <p:txBody>
+          <a:bodyPr wrap="square" lIns="0" tIns="0" rIns="0" bIns="0" rtlCol="0" anchor="t"/>
+          <a:lstStyle/>
+          <a:p>
+            <a:pPr indent="0" marL="0">
+              <a:buNone/>
+            </a:pPr>
+            <a:r>
+              <a:rPr lang="en-US" sz="1300" b="1" dirty="0">
+                <a:solidFill>
+                  <a:srgbClr val="FFFFFF"/>
+                </a:solidFill>
+                <a:latin typeface="Calibri" pitchFamily="34" charset="0"/>
+                <a:ea typeface="Calibri" pitchFamily="34" charset="-122"/>
+                <a:cs typeface="Calibri" pitchFamily="34" charset="-120"/>
+              </a:rPr>
+              <a:t>README/公式サイトをグラフィカルに</a:t>
+            </a:r>
+            <a:endParaRPr lang="en-US" sz="1300" dirty="0"/>
+          </a:p>
+        </p:txBody>
+      </p:sp>
+      <p:sp>
+        <p:nvSpPr>
+          <p:cNvPr id="16" name="Text 14"/>
+          <p:cNvSpPr txBox="1"/>
+          <p:nvPr/>
+        </p:nvSpPr>
+        <p:spPr>
+          <a:xfrm>
+            <a:off x="4114800" y="3602736"/>
+            <a:ext cx="6858000" cy="777240"/>
+          </a:xfrm>
+          <a:prstGeom prst="rect">
+            <a:avLst/>
+          </a:prstGeom>
+          <a:noFill/>
+          <a:ln/>
+        </p:spPr>
+        <p:txBody>
+          <a:bodyPr wrap="square" lIns="0" tIns="0" rIns="0" bIns="0" rtlCol="0" anchor="ctr"/>
+          <a:lstStyle/>
+          <a:p>
+            <a:pPr indent="0" marL="0">
+              <a:buNone/>
+            </a:pPr>
+            <a:r>
+              <a:rPr lang="en-US" sz="1150" dirty="0">
                 <a:solidFill>
                   <a:srgbClr val="AEB7C4"/>
                 </a:solidFill>
@@ -2369,15 +2608,328 @@
                 <a:ea typeface="Calibri" pitchFamily="34" charset="-122"/>
                 <a:cs typeface="Calibri" pitchFamily="34" charset="-120"/>
               </a:rPr>
-              <a:t>featureブランチを切り、mainは常に安定させる</a:t>
-            </a:r>
-            <a:endParaRPr lang="en-US" sz="1250" dirty="0"/>
-          </a:p>
-        </p:txBody>
-      </p:sp>
-      <p:sp>
-        <p:nvSpPr>
-          <p:cNvPr id="13" name="Text 11"/>
+              <a:t>デモ・使い方が伝わるREADMEにする。GitHub Pages等で簡易な公式サイトを作るのも有効</a:t>
+            </a:r>
+            <a:endParaRPr lang="en-US" sz="1150" dirty="0"/>
+          </a:p>
+        </p:txBody>
+      </p:sp>
+      <p:sp>
+        <p:nvSpPr>
+          <p:cNvPr id="17" name="Shape 15"/>
+          <p:cNvSpPr/>
+          <p:nvPr/>
+        </p:nvSpPr>
+        <p:spPr>
+          <a:xfrm>
+            <a:off x="548640" y="4489704"/>
+            <a:ext cx="384048" cy="384048"/>
+          </a:xfrm>
+          <a:prstGeom prst="ellipse">
+            <a:avLst/>
+          </a:prstGeom>
+          <a:solidFill>
+            <a:srgbClr val="58D68D"/>
+          </a:solidFill>
+          <a:ln/>
+        </p:spPr>
+      </p:sp>
+      <p:sp>
+        <p:nvSpPr>
+          <p:cNvPr id="18" name="Text 16"/>
+          <p:cNvSpPr txBox="1"/>
+          <p:nvPr/>
+        </p:nvSpPr>
+        <p:spPr>
+          <a:xfrm>
+            <a:off x="548640" y="4489704"/>
+            <a:ext cx="384048" cy="384048"/>
+          </a:xfrm>
+          <a:prstGeom prst="rect">
+            <a:avLst/>
+          </a:prstGeom>
+          <a:noFill/>
+          <a:ln/>
+        </p:spPr>
+        <p:txBody>
+          <a:bodyPr wrap="square" lIns="0" tIns="0" rIns="0" bIns="0" rtlCol="0" anchor="ctr"/>
+          <a:lstStyle/>
+          <a:p>
+            <a:pPr algn="ctr" indent="0" marL="0">
+              <a:buNone/>
+            </a:pPr>
+            <a:r>
+              <a:rPr lang="en-US" sz="1300" b="1" dirty="0">
+                <a:solidFill>
+                  <a:srgbClr val="1A1F26"/>
+                </a:solidFill>
+                <a:latin typeface="Calibri" pitchFamily="34" charset="0"/>
+                <a:ea typeface="Calibri" pitchFamily="34" charset="-122"/>
+                <a:cs typeface="Calibri" pitchFamily="34" charset="-120"/>
+              </a:rPr>
+              <a:t>4</a:t>
+            </a:r>
+            <a:endParaRPr lang="en-US" sz="1300" dirty="0"/>
+          </a:p>
+        </p:txBody>
+      </p:sp>
+      <p:sp>
+        <p:nvSpPr>
+          <p:cNvPr id="19" name="Text 17"/>
+          <p:cNvSpPr txBox="1"/>
+          <p:nvPr/>
+        </p:nvSpPr>
+        <p:spPr>
+          <a:xfrm>
+            <a:off x="1097280" y="4443984"/>
+            <a:ext cx="2926080" cy="457200"/>
+          </a:xfrm>
+          <a:prstGeom prst="rect">
+            <a:avLst/>
+          </a:prstGeom>
+          <a:noFill/>
+          <a:ln/>
+        </p:spPr>
+        <p:txBody>
+          <a:bodyPr wrap="square" lIns="0" tIns="0" rIns="0" bIns="0" rtlCol="0" anchor="t"/>
+          <a:lstStyle/>
+          <a:p>
+            <a:pPr indent="0" marL="0">
+              <a:buNone/>
+            </a:pPr>
+            <a:r>
+              <a:rPr lang="en-US" sz="1300" b="1" dirty="0">
+                <a:solidFill>
+                  <a:srgbClr val="FFFFFF"/>
+                </a:solidFill>
+                <a:latin typeface="Calibri" pitchFamily="34" charset="0"/>
+                <a:ea typeface="Calibri" pitchFamily="34" charset="-122"/>
+                <a:cs typeface="Calibri" pitchFamily="34" charset="-120"/>
+              </a:rPr>
+              <a:t>告知する</a:t>
+            </a:r>
+            <a:endParaRPr lang="en-US" sz="1300" dirty="0"/>
+          </a:p>
+        </p:txBody>
+      </p:sp>
+      <p:sp>
+        <p:nvSpPr>
+          <p:cNvPr id="20" name="Text 18"/>
+          <p:cNvSpPr txBox="1"/>
+          <p:nvPr/>
+        </p:nvSpPr>
+        <p:spPr>
+          <a:xfrm>
+            <a:off x="4114800" y="4443984"/>
+            <a:ext cx="6858000" cy="777240"/>
+          </a:xfrm>
+          <a:prstGeom prst="rect">
+            <a:avLst/>
+          </a:prstGeom>
+          <a:noFill/>
+          <a:ln/>
+        </p:spPr>
+        <p:txBody>
+          <a:bodyPr wrap="square" lIns="0" tIns="0" rIns="0" bIns="0" rtlCol="0" anchor="ctr"/>
+          <a:lstStyle/>
+          <a:p>
+            <a:pPr indent="0" marL="0">
+              <a:buNone/>
+            </a:pPr>
+            <a:r>
+              <a:rPr lang="en-US" sz="1150" dirty="0">
+                <a:solidFill>
+                  <a:srgbClr val="AEB7C4"/>
+                </a:solidFill>
+                <a:latin typeface="Calibri" pitchFamily="34" charset="0"/>
+                <a:ea typeface="Calibri" pitchFamily="34" charset="-122"/>
+                <a:cs typeface="Calibri" pitchFamily="34" charset="-120"/>
+              </a:rPr>
+              <a:t>Product Hunt・Zenn・Qiita・Dev.to等で公開を告知する。ただし効果は一時的(数日)</a:t>
+            </a:r>
+            <a:endParaRPr lang="en-US" sz="1150" dirty="0"/>
+          </a:p>
+        </p:txBody>
+      </p:sp>
+      <p:sp>
+        <p:nvSpPr>
+          <p:cNvPr id="21" name="Shape 19"/>
+          <p:cNvSpPr/>
+          <p:nvPr/>
+        </p:nvSpPr>
+        <p:spPr>
+          <a:xfrm>
+            <a:off x="548640" y="5330952"/>
+            <a:ext cx="384048" cy="384048"/>
+          </a:xfrm>
+          <a:prstGeom prst="ellipse">
+            <a:avLst/>
+          </a:prstGeom>
+          <a:solidFill>
+            <a:srgbClr val="58D68D"/>
+          </a:solidFill>
+          <a:ln/>
+        </p:spPr>
+      </p:sp>
+      <p:sp>
+        <p:nvSpPr>
+          <p:cNvPr id="22" name="Text 20"/>
+          <p:cNvSpPr txBox="1"/>
+          <p:nvPr/>
+        </p:nvSpPr>
+        <p:spPr>
+          <a:xfrm>
+            <a:off x="548640" y="5330952"/>
+            <a:ext cx="384048" cy="384048"/>
+          </a:xfrm>
+          <a:prstGeom prst="rect">
+            <a:avLst/>
+          </a:prstGeom>
+          <a:noFill/>
+          <a:ln/>
+        </p:spPr>
+        <p:txBody>
+          <a:bodyPr wrap="square" lIns="0" tIns="0" rIns="0" bIns="0" rtlCol="0" anchor="ctr"/>
+          <a:lstStyle/>
+          <a:p>
+            <a:pPr algn="ctr" indent="0" marL="0">
+              <a:buNone/>
+            </a:pPr>
+            <a:r>
+              <a:rPr lang="en-US" sz="1300" b="1" dirty="0">
+                <a:solidFill>
+                  <a:srgbClr val="1A1F26"/>
+                </a:solidFill>
+                <a:latin typeface="Calibri" pitchFamily="34" charset="0"/>
+                <a:ea typeface="Calibri" pitchFamily="34" charset="-122"/>
+                <a:cs typeface="Calibri" pitchFamily="34" charset="-120"/>
+              </a:rPr>
+              <a:t>5</a:t>
+            </a:r>
+            <a:endParaRPr lang="en-US" sz="1300" dirty="0"/>
+          </a:p>
+        </p:txBody>
+      </p:sp>
+      <p:sp>
+        <p:nvSpPr>
+          <p:cNvPr id="23" name="Text 21"/>
+          <p:cNvSpPr txBox="1"/>
+          <p:nvPr/>
+        </p:nvSpPr>
+        <p:spPr>
+          <a:xfrm>
+            <a:off x="1097280" y="5285232"/>
+            <a:ext cx="2926080" cy="457200"/>
+          </a:xfrm>
+          <a:prstGeom prst="rect">
+            <a:avLst/>
+          </a:prstGeom>
+          <a:noFill/>
+          <a:ln/>
+        </p:spPr>
+        <p:txBody>
+          <a:bodyPr wrap="square" lIns="0" tIns="0" rIns="0" bIns="0" rtlCol="0" anchor="t"/>
+          <a:lstStyle/>
+          <a:p>
+            <a:pPr indent="0" marL="0">
+              <a:buNone/>
+            </a:pPr>
+            <a:r>
+              <a:rPr lang="en-US" sz="1300" b="1" dirty="0">
+                <a:solidFill>
+                  <a:srgbClr val="FFFFFF"/>
+                </a:solidFill>
+                <a:latin typeface="Calibri" pitchFamily="34" charset="0"/>
+                <a:ea typeface="Calibri" pitchFamily="34" charset="-122"/>
+                <a:cs typeface="Calibri" pitchFamily="34" charset="-120"/>
+              </a:rPr>
+              <a:t>検索される記事を作る</a:t>
+            </a:r>
+            <a:endParaRPr lang="en-US" sz="1300" dirty="0"/>
+          </a:p>
+        </p:txBody>
+      </p:sp>
+      <p:sp>
+        <p:nvSpPr>
+          <p:cNvPr id="24" name="Text 22"/>
+          <p:cNvSpPr txBox="1"/>
+          <p:nvPr/>
+        </p:nvSpPr>
+        <p:spPr>
+          <a:xfrm>
+            <a:off x="4114800" y="5285232"/>
+            <a:ext cx="6858000" cy="777240"/>
+          </a:xfrm>
+          <a:prstGeom prst="rect">
+            <a:avLst/>
+          </a:prstGeom>
+          <a:noFill/>
+          <a:ln/>
+        </p:spPr>
+        <p:txBody>
+          <a:bodyPr wrap="square" lIns="0" tIns="0" rIns="0" bIns="0" rtlCol="0" anchor="ctr"/>
+          <a:lstStyle/>
+          <a:p>
+            <a:pPr indent="0" marL="0">
+              <a:buNone/>
+            </a:pPr>
+            <a:r>
+              <a:rPr lang="en-US" sz="1150" dirty="0">
+                <a:solidFill>
+                  <a:srgbClr val="AEB7C4"/>
+                </a:solidFill>
+                <a:latin typeface="Calibri" pitchFamily="34" charset="0"/>
+                <a:ea typeface="Calibri" pitchFamily="34" charset="-122"/>
+                <a:cs typeface="Calibri" pitchFamily="34" charset="-120"/>
+              </a:rPr>
+              <a:t>想定ユーザーが検索するキーワードでブログ記事を書く。即効性は無いが継続的な流入源になる</a:t>
+            </a:r>
+            <a:endParaRPr lang="en-US" sz="1150" dirty="0"/>
+          </a:p>
+        </p:txBody>
+      </p:sp>
+      <p:sp>
+        <p:nvSpPr>
+          <p:cNvPr id="25" name="Text 23"/>
+          <p:cNvSpPr txBox="1"/>
+          <p:nvPr/>
+        </p:nvSpPr>
+        <p:spPr>
+          <a:xfrm>
+            <a:off x="548640" y="6400800"/>
+            <a:ext cx="10424160" cy="320040"/>
+          </a:xfrm>
+          <a:prstGeom prst="rect">
+            <a:avLst/>
+          </a:prstGeom>
+          <a:noFill/>
+          <a:ln/>
+        </p:spPr>
+        <p:txBody>
+          <a:bodyPr wrap="square" lIns="0" tIns="0" rIns="0" bIns="0" rtlCol="0" anchor="ctr"/>
+          <a:lstStyle/>
+          <a:p>
+            <a:pPr indent="0" marL="0">
+              <a:buNone/>
+            </a:pPr>
+            <a:r>
+              <a:rPr lang="en-US" sz="1000" i="1" dirty="0">
+                <a:solidFill>
+                  <a:srgbClr val="AEB7C4"/>
+                </a:solidFill>
+                <a:latin typeface="Calibri" pitchFamily="34" charset="0"/>
+                <a:ea typeface="Calibri" pitchFamily="34" charset="-122"/>
+                <a:cs typeface="Calibri" pitchFamily="34" charset="-120"/>
+              </a:rPr>
+              <a:t>出典: npmのPDF作成ライブラリ(labelmake)の開発者によるブログ記事(1事例の実体験)</a:t>
+            </a:r>
+            <a:endParaRPr lang="en-US" sz="1000" dirty="0"/>
+          </a:p>
+        </p:txBody>
+      </p:sp>
+      <p:sp>
+        <p:nvSpPr>
+          <p:cNvPr id="26" name="Text 24"/>
           <p:cNvSpPr txBox="1"/>
           <p:nvPr/>
         </p:nvSpPr>
@@ -2425,6 +2977,455 @@
 <file path=ppt/slides/slide11.xml><?xml version="1.0" encoding="utf-8"?>
 <p:sld xmlns:a="http://schemas.openxmlformats.org/drawingml/2006/main" xmlns:r="http://schemas.openxmlformats.org/officeDocument/2006/relationships" xmlns:p="http://schemas.openxmlformats.org/presentationml/2006/main">
   <p:cSld name="Slide 11">
+    <p:bg>
+      <p:bgPr>
+        <a:solidFill>
+          <a:srgbClr val="1A1F26"/>
+        </a:solidFill>
+      </p:bgPr>
+    </p:bg>
+    <p:spTree>
+      <p:nvGrpSpPr>
+        <p:cNvPr id="1" name=""/>
+        <p:cNvGrpSpPr/>
+        <p:nvPr/>
+      </p:nvGrpSpPr>
+      <p:grpSpPr>
+        <a:xfrm>
+          <a:off x="0" y="0"/>
+          <a:ext cx="0" cy="0"/>
+          <a:chOff x="0" y="0"/>
+          <a:chExt cx="0" cy="0"/>
+        </a:xfrm>
+      </p:grpSpPr>
+      <p:sp>
+        <p:nvSpPr>
+          <p:cNvPr id="2" name="Text 0"/>
+          <p:cNvSpPr txBox="1"/>
+          <p:nvPr/>
+        </p:nvSpPr>
+        <p:spPr>
+          <a:xfrm>
+            <a:off x="548640" y="457200"/>
+            <a:ext cx="731520" cy="731520"/>
+          </a:xfrm>
+          <a:prstGeom prst="rect">
+            <a:avLst/>
+          </a:prstGeom>
+          <a:noFill/>
+          <a:ln/>
+        </p:spPr>
+        <p:txBody>
+          <a:bodyPr wrap="square" lIns="0" tIns="0" rIns="0" bIns="0" rtlCol="0" anchor="ctr"/>
+          <a:lstStyle/>
+          <a:p>
+            <a:pPr indent="0" marL="0">
+              <a:buNone/>
+            </a:pPr>
+            <a:r>
+              <a:rPr lang="en-US" sz="2800" b="1" dirty="0">
+                <a:solidFill>
+                  <a:srgbClr val="58D68D"/>
+                </a:solidFill>
+                <a:latin typeface="Cambria" pitchFamily="34" charset="0"/>
+                <a:ea typeface="Cambria" pitchFamily="34" charset="-122"/>
+                <a:cs typeface="Cambria" pitchFamily="34" charset="-120"/>
+              </a:rPr>
+              <a:t>6</a:t>
+            </a:r>
+            <a:endParaRPr lang="en-US" sz="2800" dirty="0"/>
+          </a:p>
+        </p:txBody>
+      </p:sp>
+      <p:sp>
+        <p:nvSpPr>
+          <p:cNvPr id="3" name="Text 1"/>
+          <p:cNvSpPr txBox="1"/>
+          <p:nvPr/>
+        </p:nvSpPr>
+        <p:spPr>
+          <a:xfrm>
+            <a:off x="1280160" y="502920"/>
+            <a:ext cx="9784080" cy="640080"/>
+          </a:xfrm>
+          <a:prstGeom prst="rect">
+            <a:avLst/>
+          </a:prstGeom>
+          <a:noFill/>
+          <a:ln/>
+        </p:spPr>
+        <p:txBody>
+          <a:bodyPr wrap="square" lIns="0" tIns="0" rIns="0" bIns="0" rtlCol="0" anchor="ctr"/>
+          <a:lstStyle/>
+          <a:p>
+            <a:pPr indent="0" marL="0">
+              <a:buNone/>
+            </a:pPr>
+            <a:r>
+              <a:rPr lang="en-US" sz="2600" b="1" dirty="0">
+                <a:solidFill>
+                  <a:srgbClr val="FFFFFF"/>
+                </a:solidFill>
+                <a:latin typeface="Cambria" pitchFamily="34" charset="0"/>
+                <a:ea typeface="Cambria" pitchFamily="34" charset="-122"/>
+                <a:cs typeface="Cambria" pitchFamily="34" charset="-120"/>
+              </a:rPr>
+              <a:t>リポジトリ運用のコツ</a:t>
+            </a:r>
+            <a:endParaRPr lang="en-US" sz="2600" dirty="0"/>
+          </a:p>
+        </p:txBody>
+      </p:sp>
+      <p:sp>
+        <p:nvSpPr>
+          <p:cNvPr id="4" name="Shape 2"/>
+          <p:cNvSpPr/>
+          <p:nvPr/>
+        </p:nvSpPr>
+        <p:spPr>
+          <a:xfrm>
+            <a:off x="548640" y="1737360"/>
+            <a:ext cx="3566160" cy="2377440"/>
+          </a:xfrm>
+          <a:prstGeom prst="roundRect">
+            <a:avLst>
+              <a:gd name="adj" fmla="val 4615"/>
+            </a:avLst>
+          </a:prstGeom>
+          <a:solidFill>
+            <a:srgbClr val="232A34"/>
+          </a:solidFill>
+          <a:ln/>
+        </p:spPr>
+      </p:sp>
+      <p:sp>
+        <p:nvSpPr>
+          <p:cNvPr id="5" name="Text 3"/>
+          <p:cNvSpPr txBox="1"/>
+          <p:nvPr/>
+        </p:nvSpPr>
+        <p:spPr>
+          <a:xfrm>
+            <a:off x="822960" y="1965960"/>
+            <a:ext cx="3017520" cy="457200"/>
+          </a:xfrm>
+          <a:prstGeom prst="rect">
+            <a:avLst/>
+          </a:prstGeom>
+          <a:noFill/>
+          <a:ln/>
+        </p:spPr>
+        <p:txBody>
+          <a:bodyPr wrap="square" lIns="0" tIns="0" rIns="0" bIns="0" rtlCol="0" anchor="ctr"/>
+          <a:lstStyle/>
+          <a:p>
+            <a:pPr indent="0" marL="0">
+              <a:buNone/>
+            </a:pPr>
+            <a:r>
+              <a:rPr lang="en-US" sz="1600" b="1" dirty="0">
+                <a:solidFill>
+                  <a:srgbClr val="58D68D"/>
+                </a:solidFill>
+                <a:latin typeface="Calibri" pitchFamily="34" charset="0"/>
+                <a:ea typeface="Calibri" pitchFamily="34" charset="-122"/>
+                <a:cs typeface="Calibri" pitchFamily="34" charset="-120"/>
+              </a:rPr>
+              <a:t>コミット</a:t>
+            </a:r>
+            <a:endParaRPr lang="en-US" sz="1600" dirty="0"/>
+          </a:p>
+        </p:txBody>
+      </p:sp>
+      <p:sp>
+        <p:nvSpPr>
+          <p:cNvPr id="6" name="Text 4"/>
+          <p:cNvSpPr txBox="1"/>
+          <p:nvPr/>
+        </p:nvSpPr>
+        <p:spPr>
+          <a:xfrm>
+            <a:off x="822960" y="2468880"/>
+            <a:ext cx="3017520" cy="1463040"/>
+          </a:xfrm>
+          <a:prstGeom prst="rect">
+            <a:avLst/>
+          </a:prstGeom>
+          <a:noFill/>
+          <a:ln/>
+        </p:spPr>
+        <p:txBody>
+          <a:bodyPr wrap="square" lIns="0" tIns="0" rIns="0" bIns="0" rtlCol="0" anchor="ctr"/>
+          <a:lstStyle/>
+          <a:p>
+            <a:pPr indent="0" marL="0">
+              <a:buNone/>
+            </a:pPr>
+            <a:r>
+              <a:rPr lang="en-US" sz="1250" dirty="0">
+                <a:solidFill>
+                  <a:srgbClr val="AEB7C4"/>
+                </a:solidFill>
+                <a:latin typeface="Calibri" pitchFamily="34" charset="0"/>
+                <a:ea typeface="Calibri" pitchFamily="34" charset="-122"/>
+                <a:cs typeface="Calibri" pitchFamily="34" charset="-120"/>
+              </a:rPr>
+              <a:t>小さく頻繁に。メッセージは「なぜ」を書く</a:t>
+            </a:r>
+            <a:endParaRPr lang="en-US" sz="1250" dirty="0"/>
+          </a:p>
+        </p:txBody>
+      </p:sp>
+      <p:sp>
+        <p:nvSpPr>
+          <p:cNvPr id="7" name="Shape 5"/>
+          <p:cNvSpPr/>
+          <p:nvPr/>
+        </p:nvSpPr>
+        <p:spPr>
+          <a:xfrm>
+            <a:off x="4343400" y="1737360"/>
+            <a:ext cx="3566160" cy="2377440"/>
+          </a:xfrm>
+          <a:prstGeom prst="roundRect">
+            <a:avLst>
+              <a:gd name="adj" fmla="val 4615"/>
+            </a:avLst>
+          </a:prstGeom>
+          <a:solidFill>
+            <a:srgbClr val="232A34"/>
+          </a:solidFill>
+          <a:ln/>
+        </p:spPr>
+      </p:sp>
+      <p:sp>
+        <p:nvSpPr>
+          <p:cNvPr id="8" name="Text 6"/>
+          <p:cNvSpPr txBox="1"/>
+          <p:nvPr/>
+        </p:nvSpPr>
+        <p:spPr>
+          <a:xfrm>
+            <a:off x="4617720" y="1965960"/>
+            <a:ext cx="3017520" cy="457200"/>
+          </a:xfrm>
+          <a:prstGeom prst="rect">
+            <a:avLst/>
+          </a:prstGeom>
+          <a:noFill/>
+          <a:ln/>
+        </p:spPr>
+        <p:txBody>
+          <a:bodyPr wrap="square" lIns="0" tIns="0" rIns="0" bIns="0" rtlCol="0" anchor="ctr"/>
+          <a:lstStyle/>
+          <a:p>
+            <a:pPr indent="0" marL="0">
+              <a:buNone/>
+            </a:pPr>
+            <a:r>
+              <a:rPr lang="en-US" sz="1600" b="1" dirty="0">
+                <a:solidFill>
+                  <a:srgbClr val="58D68D"/>
+                </a:solidFill>
+                <a:latin typeface="Calibri" pitchFamily="34" charset="0"/>
+                <a:ea typeface="Calibri" pitchFamily="34" charset="-122"/>
+                <a:cs typeface="Calibri" pitchFamily="34" charset="-120"/>
+              </a:rPr>
+              <a:t>Issue/PR</a:t>
+            </a:r>
+            <a:endParaRPr lang="en-US" sz="1600" dirty="0"/>
+          </a:p>
+        </p:txBody>
+      </p:sp>
+      <p:sp>
+        <p:nvSpPr>
+          <p:cNvPr id="9" name="Text 7"/>
+          <p:cNvSpPr txBox="1"/>
+          <p:nvPr/>
+        </p:nvSpPr>
+        <p:spPr>
+          <a:xfrm>
+            <a:off x="4617720" y="2468880"/>
+            <a:ext cx="3017520" cy="1463040"/>
+          </a:xfrm>
+          <a:prstGeom prst="rect">
+            <a:avLst/>
+          </a:prstGeom>
+          <a:noFill/>
+          <a:ln/>
+        </p:spPr>
+        <p:txBody>
+          <a:bodyPr wrap="square" lIns="0" tIns="0" rIns="0" bIns="0" rtlCol="0" anchor="ctr"/>
+          <a:lstStyle/>
+          <a:p>
+            <a:pPr indent="0" marL="0">
+              <a:buNone/>
+            </a:pPr>
+            <a:r>
+              <a:rPr lang="en-US" sz="1250" dirty="0">
+                <a:solidFill>
+                  <a:srgbClr val="AEB7C4"/>
+                </a:solidFill>
+                <a:latin typeface="Calibri" pitchFamily="34" charset="0"/>
+                <a:ea typeface="Calibri" pitchFamily="34" charset="-122"/>
+                <a:cs typeface="Calibri" pitchFamily="34" charset="-120"/>
+              </a:rPr>
+              <a:t>作業ログとして活用。後から経緯を追える</a:t>
+            </a:r>
+            <a:endParaRPr lang="en-US" sz="1250" dirty="0"/>
+          </a:p>
+        </p:txBody>
+      </p:sp>
+      <p:sp>
+        <p:nvSpPr>
+          <p:cNvPr id="10" name="Shape 8"/>
+          <p:cNvSpPr/>
+          <p:nvPr/>
+        </p:nvSpPr>
+        <p:spPr>
+          <a:xfrm>
+            <a:off x="8138160" y="1737360"/>
+            <a:ext cx="3566160" cy="2377440"/>
+          </a:xfrm>
+          <a:prstGeom prst="roundRect">
+            <a:avLst>
+              <a:gd name="adj" fmla="val 4615"/>
+            </a:avLst>
+          </a:prstGeom>
+          <a:solidFill>
+            <a:srgbClr val="232A34"/>
+          </a:solidFill>
+          <a:ln/>
+        </p:spPr>
+      </p:sp>
+      <p:sp>
+        <p:nvSpPr>
+          <p:cNvPr id="11" name="Text 9"/>
+          <p:cNvSpPr txBox="1"/>
+          <p:nvPr/>
+        </p:nvSpPr>
+        <p:spPr>
+          <a:xfrm>
+            <a:off x="8412480" y="1965960"/>
+            <a:ext cx="3017520" cy="457200"/>
+          </a:xfrm>
+          <a:prstGeom prst="rect">
+            <a:avLst/>
+          </a:prstGeom>
+          <a:noFill/>
+          <a:ln/>
+        </p:spPr>
+        <p:txBody>
+          <a:bodyPr wrap="square" lIns="0" tIns="0" rIns="0" bIns="0" rtlCol="0" anchor="ctr"/>
+          <a:lstStyle/>
+          <a:p>
+            <a:pPr indent="0" marL="0">
+              <a:buNone/>
+            </a:pPr>
+            <a:r>
+              <a:rPr lang="en-US" sz="1600" b="1" dirty="0">
+                <a:solidFill>
+                  <a:srgbClr val="58D68D"/>
+                </a:solidFill>
+                <a:latin typeface="Calibri" pitchFamily="34" charset="0"/>
+                <a:ea typeface="Calibri" pitchFamily="34" charset="-122"/>
+                <a:cs typeface="Calibri" pitchFamily="34" charset="-120"/>
+              </a:rPr>
+              <a:t>ブランチ運用</a:t>
+            </a:r>
+            <a:endParaRPr lang="en-US" sz="1600" dirty="0"/>
+          </a:p>
+        </p:txBody>
+      </p:sp>
+      <p:sp>
+        <p:nvSpPr>
+          <p:cNvPr id="12" name="Text 10"/>
+          <p:cNvSpPr txBox="1"/>
+          <p:nvPr/>
+        </p:nvSpPr>
+        <p:spPr>
+          <a:xfrm>
+            <a:off x="8412480" y="2468880"/>
+            <a:ext cx="3017520" cy="1463040"/>
+          </a:xfrm>
+          <a:prstGeom prst="rect">
+            <a:avLst/>
+          </a:prstGeom>
+          <a:noFill/>
+          <a:ln/>
+        </p:spPr>
+        <p:txBody>
+          <a:bodyPr wrap="square" lIns="0" tIns="0" rIns="0" bIns="0" rtlCol="0" anchor="ctr"/>
+          <a:lstStyle/>
+          <a:p>
+            <a:pPr indent="0" marL="0">
+              <a:buNone/>
+            </a:pPr>
+            <a:r>
+              <a:rPr lang="en-US" sz="1250" dirty="0">
+                <a:solidFill>
+                  <a:srgbClr val="AEB7C4"/>
+                </a:solidFill>
+                <a:latin typeface="Calibri" pitchFamily="34" charset="0"/>
+                <a:ea typeface="Calibri" pitchFamily="34" charset="-122"/>
+                <a:cs typeface="Calibri" pitchFamily="34" charset="-120"/>
+              </a:rPr>
+              <a:t>featureブランチを切り、mainは常に安定させる</a:t>
+            </a:r>
+            <a:endParaRPr lang="en-US" sz="1250" dirty="0"/>
+          </a:p>
+        </p:txBody>
+      </p:sp>
+      <p:sp>
+        <p:nvSpPr>
+          <p:cNvPr id="13" name="Text 11"/>
+          <p:cNvSpPr txBox="1"/>
+          <p:nvPr/>
+        </p:nvSpPr>
+        <p:spPr>
+          <a:xfrm>
+            <a:off x="11521440" y="6492240"/>
+            <a:ext cx="457200" cy="274320"/>
+          </a:xfrm>
+          <a:prstGeom prst="rect">
+            <a:avLst/>
+          </a:prstGeom>
+          <a:noFill/>
+          <a:ln/>
+        </p:spPr>
+        <p:txBody>
+          <a:bodyPr wrap="square" lIns="0" tIns="0" rIns="0" bIns="0" rtlCol="0" anchor="ctr"/>
+          <a:lstStyle/>
+          <a:p>
+            <a:pPr algn="r" indent="0" marL="0">
+              <a:buNone/>
+            </a:pPr>
+            <a:r>
+              <a:rPr lang="en-US" sz="1000" dirty="0">
+                <a:solidFill>
+                  <a:srgbClr val="5B6472"/>
+                </a:solidFill>
+                <a:latin typeface="Calibri" pitchFamily="34" charset="0"/>
+                <a:ea typeface="Calibri" pitchFamily="34" charset="-122"/>
+                <a:cs typeface="Calibri" pitchFamily="34" charset="-120"/>
+              </a:rPr>
+              <a:t>11</a:t>
+            </a:r>
+            <a:endParaRPr lang="en-US" sz="1000" dirty="0"/>
+          </a:p>
+        </p:txBody>
+      </p:sp>
+    </p:spTree>
+  </p:cSld>
+  <p:clrMapOvr>
+    <a:masterClrMapping/>
+  </p:clrMapOvr>
+</p:sld>
+</file>
+
+<file path=ppt/slides/slide12.xml><?xml version="1.0" encoding="utf-8"?>
+<p:sld xmlns:a="http://schemas.openxmlformats.org/drawingml/2006/main" xmlns:r="http://schemas.openxmlformats.org/officeDocument/2006/relationships" xmlns:p="http://schemas.openxmlformats.org/presentationml/2006/main">
+  <p:cSld name="Slide 12">
     <p:bg>
       <p:bgPr>
         <a:solidFill>
@@ -2903,7 +3904,7 @@
                 <a:ea typeface="Calibri" pitchFamily="34" charset="-122"/>
                 <a:cs typeface="Calibri" pitchFamily="34" charset="-120"/>
               </a:rPr>
-              <a:t>11</a:t>
+              <a:t>12</a:t>
             </a:r>
             <a:endParaRPr lang="en-US" sz="1000" dirty="0"/>
           </a:p>
@@ -3522,7 +4523,7 @@
                 <a:ea typeface="Calibri" pitchFamily="34" charset="-122"/>
                 <a:cs typeface="Calibri" pitchFamily="34" charset="-120"/>
               </a:rPr>
-              <a:t>Issue/PR・good first issue・コミュニティの実感</a:t>
+              <a:t>Issue/PR・good first issue・shields.io実例・コミュニティの実感</a:t>
             </a:r>
             <a:endParaRPr lang="en-US" sz="1100" dirty="0"/>
           </a:p>
@@ -6974,7 +7975,7 @@
                 <a:ea typeface="Cambria" pitchFamily="34" charset="-122"/>
                 <a:cs typeface="Cambria" pitchFamily="34" charset="-120"/>
               </a:rPr>
-              <a:t>5</a:t>
+              <a:t>4</a:t>
             </a:r>
             <a:endParaRPr lang="en-US" sz="2800" dirty="0"/>
           </a:p>
@@ -7013,7 +8014,7 @@
                 <a:ea typeface="Cambria" pitchFamily="34" charset="-122"/>
                 <a:cs typeface="Cambria" pitchFamily="34" charset="-120"/>
               </a:rPr>
-              <a:t>宣伝チャネルの効果(実例ケーススタディ)</a:t>
+              <a:t>貢献先の実例: badges/shields (shields.io)</a:t>
             </a:r>
             <a:endParaRPr lang="en-US" sz="2600" dirty="0"/>
           </a:p>
@@ -7052,7 +8053,7 @@
                 <a:ea typeface="Calibri" pitchFamily="34" charset="-122"/>
                 <a:cs typeface="Calibri" pitchFamily="34" charset="-120"/>
               </a:rPr>
-              <a:t>個人OSS開発者が、公開後数ヶ月で400+スターを集めた際の実測データ(1事例)</a:t>
+              <a:t>READMEでよく見るバッジサービス「shields.io」も、実は誰でも貢献できるOSS</a:t>
             </a:r>
             <a:endParaRPr lang="en-US" sz="1250" dirty="0"/>
           </a:p>
@@ -7067,11 +8068,11 @@
         <p:spPr>
           <a:xfrm>
             <a:off x="548640" y="1920240"/>
-            <a:ext cx="5212080" cy="3931920"/>
+            <a:ext cx="3429000" cy="1371600"/>
           </a:xfrm>
           <a:prstGeom prst="roundRect">
             <a:avLst>
-              <a:gd name="adj" fmla="val 2326"/>
+              <a:gd name="adj" fmla="val 6667"/>
             </a:avLst>
           </a:prstGeom>
           <a:solidFill>
@@ -7083,6 +8084,13 @@
             </a:solidFill>
             <a:prstDash val="solid"/>
           </a:ln>
+          <a:effectLst>
+            <a:outerShdw sx="100000" sy="100000" kx="0" ky="0" algn="bl" rotWithShape="0" blurRad="76200" dist="25400" dir="5400000">
+              <a:srgbClr val="000000">
+                <a:alpha val="10000"/>
+              </a:srgbClr>
+            </a:outerShdw>
+          </a:effectLst>
         </p:spPr>
       </p:sp>
       <p:sp>
@@ -7093,34 +8101,34 @@
         </p:nvSpPr>
         <p:spPr>
           <a:xfrm>
-            <a:off x="822960" y="2103120"/>
-            <a:ext cx="4754880" cy="365760"/>
-          </a:xfrm>
-          <a:prstGeom prst="rect">
-            <a:avLst/>
-          </a:prstGeom>
-          <a:noFill/>
-          <a:ln/>
-        </p:spPr>
-        <p:txBody>
-          <a:bodyPr wrap="square" lIns="0" tIns="0" rIns="0" bIns="0" rtlCol="0" anchor="ctr"/>
-          <a:lstStyle/>
-          <a:p>
-            <a:pPr indent="0" marL="0">
-              <a:buNone/>
-            </a:pPr>
-            <a:r>
-              <a:rPr lang="en-US" sz="1400" b="1" dirty="0">
-                <a:solidFill>
-                  <a:srgbClr val="58D68D"/>
-                </a:solidFill>
-                <a:latin typeface="Calibri" pitchFamily="34" charset="0"/>
-                <a:ea typeface="Calibri" pitchFamily="34" charset="-122"/>
-                <a:cs typeface="Calibri" pitchFamily="34" charset="-120"/>
-              </a:rPr>
-              <a:t>🚀 効果があったチャネル</a:t>
-            </a:r>
-            <a:endParaRPr lang="en-US" sz="1400" dirty="0"/>
+            <a:off x="731520" y="2057400"/>
+            <a:ext cx="3063240" cy="594360"/>
+          </a:xfrm>
+          <a:prstGeom prst="rect">
+            <a:avLst/>
+          </a:prstGeom>
+          <a:noFill/>
+          <a:ln/>
+        </p:spPr>
+        <p:txBody>
+          <a:bodyPr wrap="square" lIns="0" tIns="0" rIns="0" bIns="0" rtlCol="0" anchor="ctr"/>
+          <a:lstStyle/>
+          <a:p>
+            <a:pPr indent="0" marL="0">
+              <a:buNone/>
+            </a:pPr>
+            <a:r>
+              <a:rPr lang="en-US" sz="2400" b="1" dirty="0">
+                <a:solidFill>
+                  <a:srgbClr val="B084F5"/>
+                </a:solidFill>
+                <a:latin typeface="Calibri" pitchFamily="34" charset="0"/>
+                <a:ea typeface="Calibri" pitchFamily="34" charset="-122"/>
+                <a:cs typeface="Calibri" pitchFamily="34" charset="-120"/>
+              </a:rPr>
+              <a:t>27.2k</a:t>
+            </a:r>
+            <a:endParaRPr lang="en-US" sz="2400" dirty="0"/>
           </a:p>
         </p:txBody>
       </p:sp>
@@ -7132,63 +8140,24 @@
         </p:nvSpPr>
         <p:spPr>
           <a:xfrm>
-            <a:off x="822960" y="2560320"/>
-            <a:ext cx="4663440" cy="274320"/>
-          </a:xfrm>
-          <a:prstGeom prst="rect">
-            <a:avLst/>
-          </a:prstGeom>
-          <a:noFill/>
-          <a:ln/>
-        </p:spPr>
-        <p:txBody>
-          <a:bodyPr wrap="square" lIns="0" tIns="0" rIns="0" bIns="0" rtlCol="0" anchor="ctr"/>
-          <a:lstStyle/>
-          <a:p>
-            <a:pPr indent="0" marL="0">
-              <a:buNone/>
-            </a:pPr>
-            <a:r>
-              <a:rPr lang="en-US" sz="1250" b="1" dirty="0">
-                <a:solidFill>
-                  <a:srgbClr val="1A1F26"/>
-                </a:solidFill>
-                <a:latin typeface="Calibri" pitchFamily="34" charset="0"/>
-                <a:ea typeface="Calibri" pitchFamily="34" charset="-122"/>
-                <a:cs typeface="Calibri" pitchFamily="34" charset="-120"/>
-              </a:rPr>
-              <a:t>Hacker News</a:t>
-            </a:r>
-            <a:endParaRPr lang="en-US" sz="1250" dirty="0"/>
-          </a:p>
-        </p:txBody>
-      </p:sp>
-      <p:sp>
-        <p:nvSpPr>
-          <p:cNvPr id="8" name="Text 6"/>
-          <p:cNvSpPr txBox="1"/>
-          <p:nvPr/>
-        </p:nvSpPr>
-        <p:spPr>
-          <a:xfrm>
-            <a:off x="822960" y="2834640"/>
-            <a:ext cx="4663440" cy="640080"/>
-          </a:xfrm>
-          <a:prstGeom prst="rect">
-            <a:avLst/>
-          </a:prstGeom>
-          <a:noFill/>
-          <a:ln/>
-        </p:spPr>
-        <p:txBody>
-          <a:bodyPr wrap="square" lIns="0" tIns="0" rIns="0" bIns="0" rtlCol="0" anchor="ctr"/>
-          <a:lstStyle/>
-          <a:p>
-            <a:pPr indent="0" marL="0">
-              <a:buNone/>
-            </a:pPr>
-            <a:r>
-              <a:rPr lang="en-US" sz="1050" dirty="0">
+            <a:off x="731520" y="2697480"/>
+            <a:ext cx="3063240" cy="457200"/>
+          </a:xfrm>
+          <a:prstGeom prst="rect">
+            <a:avLst/>
+          </a:prstGeom>
+          <a:noFill/>
+          <a:ln/>
+        </p:spPr>
+        <p:txBody>
+          <a:bodyPr wrap="square" lIns="0" tIns="0" rIns="0" bIns="0" rtlCol="0" anchor="ctr"/>
+          <a:lstStyle/>
+          <a:p>
+            <a:pPr indent="0" marL="0">
+              <a:buNone/>
+            </a:pPr>
+            <a:r>
+              <a:rPr lang="en-US" sz="1150" dirty="0">
                 <a:solidFill>
                   <a:srgbClr val="5B6472"/>
                 </a:solidFill>
@@ -7196,260 +8165,26 @@
                 <a:ea typeface="Calibri" pitchFamily="34" charset="-122"/>
                 <a:cs typeface="Calibri" pitchFamily="34" charset="-120"/>
               </a:rPr>
-              <a:t>「Show HN:」プレフィックスを付けて投稿する文化があり、Showタブ・トップページに掲載。最も効果大</a:t>
-            </a:r>
-            <a:endParaRPr lang="en-US" sz="1050" dirty="0"/>
-          </a:p>
-        </p:txBody>
-      </p:sp>
-      <p:sp>
-        <p:nvSpPr>
-          <p:cNvPr id="9" name="Text 7"/>
-          <p:cNvSpPr txBox="1"/>
-          <p:nvPr/>
-        </p:nvSpPr>
-        <p:spPr>
-          <a:xfrm>
-            <a:off x="822960" y="3383280"/>
-            <a:ext cx="4663440" cy="274320"/>
-          </a:xfrm>
-          <a:prstGeom prst="rect">
-            <a:avLst/>
-          </a:prstGeom>
-          <a:noFill/>
-          <a:ln/>
-        </p:spPr>
-        <p:txBody>
-          <a:bodyPr wrap="square" lIns="0" tIns="0" rIns="0" bIns="0" rtlCol="0" anchor="ctr"/>
-          <a:lstStyle/>
-          <a:p>
-            <a:pPr indent="0" marL="0">
-              <a:buNone/>
-            </a:pPr>
-            <a:r>
-              <a:rPr lang="en-US" sz="1250" b="1" dirty="0">
-                <a:solidFill>
-                  <a:srgbClr val="1A1F26"/>
-                </a:solidFill>
-                <a:latin typeface="Calibri" pitchFamily="34" charset="0"/>
-                <a:ea typeface="Calibri" pitchFamily="34" charset="-122"/>
-                <a:cs typeface="Calibri" pitchFamily="34" charset="-120"/>
-              </a:rPr>
-              <a:t>Twitter/X</a:t>
-            </a:r>
-            <a:endParaRPr lang="en-US" sz="1250" dirty="0"/>
-          </a:p>
-        </p:txBody>
-      </p:sp>
-      <p:sp>
-        <p:nvSpPr>
-          <p:cNvPr id="10" name="Text 8"/>
-          <p:cNvSpPr txBox="1"/>
-          <p:nvPr/>
-        </p:nvSpPr>
-        <p:spPr>
-          <a:xfrm>
-            <a:off x="822960" y="3657600"/>
-            <a:ext cx="4663440" cy="640080"/>
-          </a:xfrm>
-          <a:prstGeom prst="rect">
-            <a:avLst/>
-          </a:prstGeom>
-          <a:noFill/>
-          <a:ln/>
-        </p:spPr>
-        <p:txBody>
-          <a:bodyPr wrap="square" lIns="0" tIns="0" rIns="0" bIns="0" rtlCol="0" anchor="ctr"/>
-          <a:lstStyle/>
-          <a:p>
-            <a:pPr indent="0" marL="0">
-              <a:buNone/>
-            </a:pPr>
-            <a:r>
-              <a:rPr lang="en-US" sz="1050" dirty="0">
-                <a:solidFill>
-                  <a:srgbClr val="5B6472"/>
-                </a:solidFill>
-                <a:latin typeface="Calibri" pitchFamily="34" charset="0"/>
-                <a:ea typeface="Calibri" pitchFamily="34" charset="-122"/>
-                <a:cs typeface="Calibri" pitchFamily="34" charset="-120"/>
-              </a:rPr>
-              <a:t>自分の発信単独では弱いが、フォロワーの多いインフルエンサーが拡散すると効果大</a:t>
-            </a:r>
-            <a:endParaRPr lang="en-US" sz="1050" dirty="0"/>
-          </a:p>
-        </p:txBody>
-      </p:sp>
-      <p:sp>
-        <p:nvSpPr>
-          <p:cNvPr id="11" name="Text 9"/>
-          <p:cNvSpPr txBox="1"/>
-          <p:nvPr/>
-        </p:nvSpPr>
-        <p:spPr>
-          <a:xfrm>
-            <a:off x="822960" y="4206240"/>
-            <a:ext cx="4663440" cy="274320"/>
-          </a:xfrm>
-          <a:prstGeom prst="rect">
-            <a:avLst/>
-          </a:prstGeom>
-          <a:noFill/>
-          <a:ln/>
-        </p:spPr>
-        <p:txBody>
-          <a:bodyPr wrap="square" lIns="0" tIns="0" rIns="0" bIns="0" rtlCol="0" anchor="ctr"/>
-          <a:lstStyle/>
-          <a:p>
-            <a:pPr indent="0" marL="0">
-              <a:buNone/>
-            </a:pPr>
-            <a:r>
-              <a:rPr lang="en-US" sz="1250" b="1" dirty="0">
-                <a:solidFill>
-                  <a:srgbClr val="1A1F26"/>
-                </a:solidFill>
-                <a:latin typeface="Calibri" pitchFamily="34" charset="0"/>
-                <a:ea typeface="Calibri" pitchFamily="34" charset="-122"/>
-                <a:cs typeface="Calibri" pitchFamily="34" charset="-120"/>
-              </a:rPr>
-              <a:t>GitHub内の連鎖</a:t>
-            </a:r>
-            <a:endParaRPr lang="en-US" sz="1250" dirty="0"/>
-          </a:p>
-        </p:txBody>
-      </p:sp>
-      <p:sp>
-        <p:nvSpPr>
-          <p:cNvPr id="12" name="Text 10"/>
-          <p:cNvSpPr txBox="1"/>
-          <p:nvPr/>
-        </p:nvSpPr>
-        <p:spPr>
-          <a:xfrm>
-            <a:off x="822960" y="4480560"/>
-            <a:ext cx="4663440" cy="640080"/>
-          </a:xfrm>
-          <a:prstGeom prst="rect">
-            <a:avLst/>
-          </a:prstGeom>
-          <a:noFill/>
-          <a:ln/>
-        </p:spPr>
-        <p:txBody>
-          <a:bodyPr wrap="square" lIns="0" tIns="0" rIns="0" bIns="0" rtlCol="0" anchor="ctr"/>
-          <a:lstStyle/>
-          <a:p>
-            <a:pPr indent="0" marL="0">
-              <a:buNone/>
-            </a:pPr>
-            <a:r>
-              <a:rPr lang="en-US" sz="1050" dirty="0">
-                <a:solidFill>
-                  <a:srgbClr val="5B6472"/>
-                </a:solidFill>
-                <a:latin typeface="Calibri" pitchFamily="34" charset="0"/>
-                <a:ea typeface="Calibri" pitchFamily="34" charset="-122"/>
-                <a:cs typeface="Calibri" pitchFamily="34" charset="-120"/>
-              </a:rPr>
-              <a:t>フォロー中ユーザーがStarしたリポジトリがフィードに流れる仕組みがあり、フォロワーの多い人がStarすると連鎖的に増える</a:t>
-            </a:r>
-            <a:endParaRPr lang="en-US" sz="1050" dirty="0"/>
-          </a:p>
-        </p:txBody>
-      </p:sp>
-      <p:sp>
-        <p:nvSpPr>
-          <p:cNvPr id="13" name="Text 11"/>
-          <p:cNvSpPr txBox="1"/>
-          <p:nvPr/>
-        </p:nvSpPr>
-        <p:spPr>
-          <a:xfrm>
-            <a:off x="822960" y="5029200"/>
-            <a:ext cx="4663440" cy="274320"/>
-          </a:xfrm>
-          <a:prstGeom prst="rect">
-            <a:avLst/>
-          </a:prstGeom>
-          <a:noFill/>
-          <a:ln/>
-        </p:spPr>
-        <p:txBody>
-          <a:bodyPr wrap="square" lIns="0" tIns="0" rIns="0" bIns="0" rtlCol="0" anchor="ctr"/>
-          <a:lstStyle/>
-          <a:p>
-            <a:pPr indent="0" marL="0">
-              <a:buNone/>
-            </a:pPr>
-            <a:r>
-              <a:rPr lang="en-US" sz="1250" b="1" dirty="0">
-                <a:solidFill>
-                  <a:srgbClr val="1A1F26"/>
-                </a:solidFill>
-                <a:latin typeface="Calibri" pitchFamily="34" charset="0"/>
-                <a:ea typeface="Calibri" pitchFamily="34" charset="-122"/>
-                <a:cs typeface="Calibri" pitchFamily="34" charset="-120"/>
-              </a:rPr>
-              <a:t>韓国版HN(news.hada.io)</a:t>
-            </a:r>
-            <a:endParaRPr lang="en-US" sz="1250" dirty="0"/>
-          </a:p>
-        </p:txBody>
-      </p:sp>
-      <p:sp>
-        <p:nvSpPr>
-          <p:cNvPr id="14" name="Text 12"/>
-          <p:cNvSpPr txBox="1"/>
-          <p:nvPr/>
-        </p:nvSpPr>
-        <p:spPr>
-          <a:xfrm>
-            <a:off x="822960" y="5303520"/>
-            <a:ext cx="4663440" cy="640080"/>
-          </a:xfrm>
-          <a:prstGeom prst="rect">
-            <a:avLst/>
-          </a:prstGeom>
-          <a:noFill/>
-          <a:ln/>
-        </p:spPr>
-        <p:txBody>
-          <a:bodyPr wrap="square" lIns="0" tIns="0" rIns="0" bIns="0" rtlCol="0" anchor="ctr"/>
-          <a:lstStyle/>
-          <a:p>
-            <a:pPr indent="0" marL="0">
-              <a:buNone/>
-            </a:pPr>
-            <a:r>
-              <a:rPr lang="en-US" sz="1050" dirty="0">
-                <a:solidFill>
-                  <a:srgbClr val="5B6472"/>
-                </a:solidFill>
-                <a:latin typeface="Calibri" pitchFamily="34" charset="0"/>
-                <a:ea typeface="Calibri" pitchFamily="34" charset="-122"/>
-                <a:cs typeface="Calibri" pitchFamily="34" charset="-120"/>
-              </a:rPr>
-              <a:t>現地の誰かが投稿したことで、そこから約40スターが集まった</a:t>
-            </a:r>
-            <a:endParaRPr lang="en-US" sz="1050" dirty="0"/>
-          </a:p>
-        </p:txBody>
-      </p:sp>
-      <p:sp>
-        <p:nvSpPr>
-          <p:cNvPr id="15" name="Shape 13"/>
+              <a:t>GitHub Stars</a:t>
+            </a:r>
+            <a:endParaRPr lang="en-US" sz="1150" dirty="0"/>
+          </a:p>
+        </p:txBody>
+      </p:sp>
+      <p:sp>
+        <p:nvSpPr>
+          <p:cNvPr id="8" name="Shape 6"/>
           <p:cNvSpPr/>
           <p:nvPr/>
         </p:nvSpPr>
         <p:spPr>
           <a:xfrm>
-            <a:off x="6035040" y="1920240"/>
-            <a:ext cx="5212080" cy="3931920"/>
+            <a:off x="4206240" y="1920240"/>
+            <a:ext cx="3429000" cy="1371600"/>
           </a:xfrm>
           <a:prstGeom prst="roundRect">
             <a:avLst>
-              <a:gd name="adj" fmla="val 2326"/>
+              <a:gd name="adj" fmla="val 6667"/>
             </a:avLst>
           </a:prstGeom>
           <a:solidFill>
@@ -7461,362 +8196,353 @@
             </a:solidFill>
             <a:prstDash val="solid"/>
           </a:ln>
-        </p:spPr>
+          <a:effectLst>
+            <a:outerShdw sx="100000" sy="100000" kx="0" ky="0" algn="bl" rotWithShape="0" blurRad="76200" dist="25400" dir="5400000">
+              <a:srgbClr val="000000">
+                <a:alpha val="10000"/>
+              </a:srgbClr>
+            </a:outerShdw>
+          </a:effectLst>
+        </p:spPr>
+      </p:sp>
+      <p:sp>
+        <p:nvSpPr>
+          <p:cNvPr id="9" name="Text 7"/>
+          <p:cNvSpPr txBox="1"/>
+          <p:nvPr/>
+        </p:nvSpPr>
+        <p:spPr>
+          <a:xfrm>
+            <a:off x="4389120" y="2057400"/>
+            <a:ext cx="3063240" cy="594360"/>
+          </a:xfrm>
+          <a:prstGeom prst="rect">
+            <a:avLst/>
+          </a:prstGeom>
+          <a:noFill/>
+          <a:ln/>
+        </p:spPr>
+        <p:txBody>
+          <a:bodyPr wrap="square" lIns="0" tIns="0" rIns="0" bIns="0" rtlCol="0" anchor="ctr"/>
+          <a:lstStyle/>
+          <a:p>
+            <a:pPr indent="0" marL="0">
+              <a:buNone/>
+            </a:pPr>
+            <a:r>
+              <a:rPr lang="en-US" sz="2400" b="1" dirty="0">
+                <a:solidFill>
+                  <a:srgbClr val="B084F5"/>
+                </a:solidFill>
+                <a:latin typeface="Calibri" pitchFamily="34" charset="0"/>
+                <a:ea typeface="Calibri" pitchFamily="34" charset="-122"/>
+                <a:cs typeface="Calibri" pitchFamily="34" charset="-120"/>
+              </a:rPr>
+              <a:t>1.6B+/月</a:t>
+            </a:r>
+            <a:endParaRPr lang="en-US" sz="2400" dirty="0"/>
+          </a:p>
+        </p:txBody>
+      </p:sp>
+      <p:sp>
+        <p:nvSpPr>
+          <p:cNvPr id="10" name="Text 8"/>
+          <p:cNvSpPr txBox="1"/>
+          <p:nvPr/>
+        </p:nvSpPr>
+        <p:spPr>
+          <a:xfrm>
+            <a:off x="4389120" y="2697480"/>
+            <a:ext cx="3063240" cy="457200"/>
+          </a:xfrm>
+          <a:prstGeom prst="rect">
+            <a:avLst/>
+          </a:prstGeom>
+          <a:noFill/>
+          <a:ln/>
+        </p:spPr>
+        <p:txBody>
+          <a:bodyPr wrap="square" lIns="0" tIns="0" rIns="0" bIns="0" rtlCol="0" anchor="ctr"/>
+          <a:lstStyle/>
+          <a:p>
+            <a:pPr indent="0" marL="0">
+              <a:buNone/>
+            </a:pPr>
+            <a:r>
+              <a:rPr lang="en-US" sz="1150" dirty="0">
+                <a:solidFill>
+                  <a:srgbClr val="5B6472"/>
+                </a:solidFill>
+                <a:latin typeface="Calibri" pitchFamily="34" charset="0"/>
+                <a:ea typeface="Calibri" pitchFamily="34" charset="-122"/>
+                <a:cs typeface="Calibri" pitchFamily="34" charset="-120"/>
+              </a:rPr>
+              <a:t>配信バッジ画像数</a:t>
+            </a:r>
+            <a:endParaRPr lang="en-US" sz="1150" dirty="0"/>
+          </a:p>
+        </p:txBody>
+      </p:sp>
+      <p:sp>
+        <p:nvSpPr>
+          <p:cNvPr id="11" name="Shape 9"/>
+          <p:cNvSpPr/>
+          <p:nvPr/>
+        </p:nvSpPr>
+        <p:spPr>
+          <a:xfrm>
+            <a:off x="7863840" y="1920240"/>
+            <a:ext cx="3429000" cy="1371600"/>
+          </a:xfrm>
+          <a:prstGeom prst="roundRect">
+            <a:avLst>
+              <a:gd name="adj" fmla="val 6667"/>
+            </a:avLst>
+          </a:prstGeom>
+          <a:solidFill>
+            <a:srgbClr val="FFFFFF"/>
+          </a:solidFill>
+          <a:ln w="12700">
+            <a:solidFill>
+              <a:srgbClr val="E3E6EA"/>
+            </a:solidFill>
+            <a:prstDash val="solid"/>
+          </a:ln>
+          <a:effectLst>
+            <a:outerShdw sx="100000" sy="100000" kx="0" ky="0" algn="bl" rotWithShape="0" blurRad="76200" dist="25400" dir="5400000">
+              <a:srgbClr val="000000">
+                <a:alpha val="10000"/>
+              </a:srgbClr>
+            </a:outerShdw>
+          </a:effectLst>
+        </p:spPr>
+      </p:sp>
+      <p:sp>
+        <p:nvSpPr>
+          <p:cNvPr id="12" name="Text 10"/>
+          <p:cNvSpPr txBox="1"/>
+          <p:nvPr/>
+        </p:nvSpPr>
+        <p:spPr>
+          <a:xfrm>
+            <a:off x="8046720" y="2057400"/>
+            <a:ext cx="3063240" cy="594360"/>
+          </a:xfrm>
+          <a:prstGeom prst="rect">
+            <a:avLst/>
+          </a:prstGeom>
+          <a:noFill/>
+          <a:ln/>
+        </p:spPr>
+        <p:txBody>
+          <a:bodyPr wrap="square" lIns="0" tIns="0" rIns="0" bIns="0" rtlCol="0" anchor="ctr"/>
+          <a:lstStyle/>
+          <a:p>
+            <a:pPr indent="0" marL="0">
+              <a:buNone/>
+            </a:pPr>
+            <a:r>
+              <a:rPr lang="en-US" sz="2400" b="1" dirty="0">
+                <a:solidFill>
+                  <a:srgbClr val="B084F5"/>
+                </a:solidFill>
+                <a:latin typeface="Calibri" pitchFamily="34" charset="0"/>
+                <a:ea typeface="Calibri" pitchFamily="34" charset="-122"/>
+                <a:cs typeface="Calibri" pitchFamily="34" charset="-120"/>
+              </a:rPr>
+              <a:t>MIT / Apache 2.0</a:t>
+            </a:r>
+            <a:endParaRPr lang="en-US" sz="2400" dirty="0"/>
+          </a:p>
+        </p:txBody>
+      </p:sp>
+      <p:sp>
+        <p:nvSpPr>
+          <p:cNvPr id="13" name="Text 11"/>
+          <p:cNvSpPr txBox="1"/>
+          <p:nvPr/>
+        </p:nvSpPr>
+        <p:spPr>
+          <a:xfrm>
+            <a:off x="8046720" y="2697480"/>
+            <a:ext cx="3063240" cy="457200"/>
+          </a:xfrm>
+          <a:prstGeom prst="rect">
+            <a:avLst/>
+          </a:prstGeom>
+          <a:noFill/>
+          <a:ln/>
+        </p:spPr>
+        <p:txBody>
+          <a:bodyPr wrap="square" lIns="0" tIns="0" rIns="0" bIns="0" rtlCol="0" anchor="ctr"/>
+          <a:lstStyle/>
+          <a:p>
+            <a:pPr indent="0" marL="0">
+              <a:buNone/>
+            </a:pPr>
+            <a:r>
+              <a:rPr lang="en-US" sz="1150" dirty="0">
+                <a:solidFill>
+                  <a:srgbClr val="5B6472"/>
+                </a:solidFill>
+                <a:latin typeface="Calibri" pitchFamily="34" charset="0"/>
+                <a:ea typeface="Calibri" pitchFamily="34" charset="-122"/>
+                <a:cs typeface="Calibri" pitchFamily="34" charset="-120"/>
+              </a:rPr>
+              <a:t>デュアルライセンス</a:t>
+            </a:r>
+            <a:endParaRPr lang="en-US" sz="1150" dirty="0"/>
+          </a:p>
+        </p:txBody>
+      </p:sp>
+      <p:sp>
+        <p:nvSpPr>
+          <p:cNvPr id="14" name="Text 12"/>
+          <p:cNvSpPr txBox="1"/>
+          <p:nvPr/>
+        </p:nvSpPr>
+        <p:spPr>
+          <a:xfrm>
+            <a:off x="548640" y="3566160"/>
+            <a:ext cx="10607040" cy="365760"/>
+          </a:xfrm>
+          <a:prstGeom prst="rect">
+            <a:avLst/>
+          </a:prstGeom>
+          <a:noFill/>
+          <a:ln/>
+        </p:spPr>
+        <p:txBody>
+          <a:bodyPr wrap="square" lIns="0" tIns="0" rIns="0" bIns="0" rtlCol="0" anchor="ctr"/>
+          <a:lstStyle/>
+          <a:p>
+            <a:pPr indent="0" marL="0">
+              <a:buNone/>
+            </a:pPr>
+            <a:r>
+              <a:rPr lang="en-US" sz="1400" b="1" dirty="0">
+                <a:solidFill>
+                  <a:srgbClr val="1A1F26"/>
+                </a:solidFill>
+                <a:latin typeface="Calibri" pitchFamily="34" charset="0"/>
+                <a:ea typeface="Calibri" pitchFamily="34" charset="-122"/>
+                <a:cs typeface="Calibri" pitchFamily="34" charset="-120"/>
+              </a:rPr>
+              <a:t>貢献のしやすさ(実際に確認できる情報)</a:t>
+            </a:r>
+            <a:endParaRPr lang="en-US" sz="1400" dirty="0"/>
+          </a:p>
+        </p:txBody>
+      </p:sp>
+      <p:sp>
+        <p:nvSpPr>
+          <p:cNvPr id="15" name="Text 13"/>
+          <p:cNvSpPr txBox="1"/>
+          <p:nvPr/>
+        </p:nvSpPr>
+        <p:spPr>
+          <a:xfrm>
+            <a:off x="548640" y="3977640"/>
+            <a:ext cx="10607040" cy="1737360"/>
+          </a:xfrm>
+          <a:prstGeom prst="rect">
+            <a:avLst/>
+          </a:prstGeom>
+          <a:noFill/>
+          <a:ln/>
+        </p:spPr>
+        <p:txBody>
+          <a:bodyPr wrap="square" lIns="0" tIns="0" rIns="0" bIns="0" rtlCol="0" anchor="ctr"/>
+          <a:lstStyle/>
+          <a:p>
+            <a:pPr marL="342900" indent="-342900">
+              <a:spcAft>
+                <a:spcPts val="600"/>
+              </a:spcAft>
+              <a:buSzPct val="100000"/>
+              <a:buChar char="•"/>
+            </a:pPr>
+            <a:r>
+              <a:rPr lang="en-US" sz="1250" dirty="0">
+                <a:solidFill>
+                  <a:srgbClr val="5B6472"/>
+                </a:solidFill>
+                <a:latin typeface="Calibri" pitchFamily="34" charset="0"/>
+                <a:ea typeface="Calibri" pitchFamily="34" charset="-122"/>
+                <a:cs typeface="Calibri" pitchFamily="34" charset="-120"/>
+              </a:rPr>
+              <a:t>CONTRIBUTING.md に貢献ガイドラインが整備されている</a:t>
+            </a:r>
+            <a:endParaRPr lang="en-US" sz="1250" dirty="0"/>
+          </a:p>
+          <a:p>
+            <a:pPr marL="342900" indent="-342900">
+              <a:spcAft>
+                <a:spcPts val="600"/>
+              </a:spcAft>
+              <a:buSzPct val="100000"/>
+              <a:buChar char="•"/>
+            </a:pPr>
+            <a:r>
+              <a:rPr lang="en-US" sz="1250" dirty="0">
+                <a:solidFill>
+                  <a:srgbClr val="5B6472"/>
+                </a:solidFill>
+                <a:latin typeface="Calibri" pitchFamily="34" charset="0"/>
+                <a:ea typeface="Calibri" pitchFamily="34" charset="-122"/>
+                <a:cs typeface="Calibri" pitchFamily="34" charset="-120"/>
+              </a:rPr>
+              <a:t>good-first-issue ラベルの付いた初心者向けタスクがある</a:t>
+            </a:r>
+            <a:endParaRPr lang="en-US" sz="1250" dirty="0"/>
+          </a:p>
+          <a:p>
+            <a:pPr marL="342900" indent="-342900">
+              <a:spcAft>
+                <a:spcPts val="600"/>
+              </a:spcAft>
+              <a:buSzPct val="100000"/>
+              <a:buChar char="•"/>
+            </a:pPr>
+            <a:r>
+              <a:rPr lang="en-US" sz="1250" dirty="0">
+                <a:solidFill>
+                  <a:srgbClr val="5B6472"/>
+                </a:solidFill>
+                <a:latin typeface="Calibri" pitchFamily="34" charset="0"/>
+                <a:ea typeface="Calibri" pitchFamily="34" charset="-122"/>
+                <a:cs typeface="Calibri" pitchFamily="34" charset="-120"/>
+              </a:rPr>
+              <a:t>新しいバッジ追加のチュートリアルも用意されている(VS Code・Vue.js・Bootstrap等の著名プロジェクトも利用)</a:t>
+            </a:r>
+            <a:endParaRPr lang="en-US" sz="1250" dirty="0"/>
+          </a:p>
+          <a:p>
+            <a:pPr marL="342900" indent="-342900">
+              <a:spcAft>
+                <a:spcPts val="600"/>
+              </a:spcAft>
+              <a:buSzPct val="100000"/>
+              <a:buChar char="•"/>
+            </a:pPr>
+            <a:r>
+              <a:rPr lang="en-US" sz="1250" dirty="0">
+                <a:solidFill>
+                  <a:srgbClr val="5B6472"/>
+                </a:solidFill>
+                <a:latin typeface="Calibri" pitchFamily="34" charset="0"/>
+                <a:ea typeface="Calibri" pitchFamily="34" charset="-122"/>
+                <a:cs typeface="Calibri" pitchFamily="34" charset="-120"/>
+              </a:rPr>
+              <a:t>SECURITY.md による脆弱性報告ポリシーも整備済み(セキュリティ関連の貢献も歓迎)</a:t>
+            </a:r>
+            <a:endParaRPr lang="en-US" sz="1250" dirty="0"/>
+          </a:p>
+        </p:txBody>
       </p:sp>
       <p:sp>
         <p:nvSpPr>
           <p:cNvPr id="16" name="Text 14"/>
-          <p:cNvSpPr txBox="1"/>
-          <p:nvPr/>
-        </p:nvSpPr>
-        <p:spPr>
-          <a:xfrm>
-            <a:off x="6309360" y="2103120"/>
-            <a:ext cx="4754880" cy="365760"/>
-          </a:xfrm>
-          <a:prstGeom prst="rect">
-            <a:avLst/>
-          </a:prstGeom>
-          <a:noFill/>
-          <a:ln/>
-        </p:spPr>
-        <p:txBody>
-          <a:bodyPr wrap="square" lIns="0" tIns="0" rIns="0" bIns="0" rtlCol="0" anchor="ctr"/>
-          <a:lstStyle/>
-          <a:p>
-            <a:pPr indent="0" marL="0">
-              <a:buNone/>
-            </a:pPr>
-            <a:r>
-              <a:rPr lang="en-US" sz="1400" b="1" dirty="0">
-                <a:solidFill>
-                  <a:srgbClr val="6B7280"/>
-                </a:solidFill>
-                <a:latin typeface="Calibri" pitchFamily="34" charset="0"/>
-                <a:ea typeface="Calibri" pitchFamily="34" charset="-122"/>
-                <a:cs typeface="Calibri" pitchFamily="34" charset="-120"/>
-              </a:rPr>
-              <a:t>🪦 効果が薄かったチャネル</a:t>
-            </a:r>
-            <a:endParaRPr lang="en-US" sz="1400" dirty="0"/>
-          </a:p>
-        </p:txBody>
-      </p:sp>
-      <p:sp>
-        <p:nvSpPr>
-          <p:cNvPr id="17" name="Text 15"/>
-          <p:cNvSpPr txBox="1"/>
-          <p:nvPr/>
-        </p:nvSpPr>
-        <p:spPr>
-          <a:xfrm>
-            <a:off x="6309360" y="2560320"/>
-            <a:ext cx="4663440" cy="274320"/>
-          </a:xfrm>
-          <a:prstGeom prst="rect">
-            <a:avLst/>
-          </a:prstGeom>
-          <a:noFill/>
-          <a:ln/>
-        </p:spPr>
-        <p:txBody>
-          <a:bodyPr wrap="square" lIns="0" tIns="0" rIns="0" bIns="0" rtlCol="0" anchor="ctr"/>
-          <a:lstStyle/>
-          <a:p>
-            <a:pPr indent="0" marL="0">
-              <a:buNone/>
-            </a:pPr>
-            <a:r>
-              <a:rPr lang="en-US" sz="1250" b="1" dirty="0">
-                <a:solidFill>
-                  <a:srgbClr val="1A1F26"/>
-                </a:solidFill>
-                <a:latin typeface="Calibri" pitchFamily="34" charset="0"/>
-                <a:ea typeface="Calibri" pitchFamily="34" charset="-122"/>
-                <a:cs typeface="Calibri" pitchFamily="34" charset="-120"/>
-              </a:rPr>
-              <a:t>Reddit</a:t>
-            </a:r>
-            <a:endParaRPr lang="en-US" sz="1250" dirty="0"/>
-          </a:p>
-        </p:txBody>
-      </p:sp>
-      <p:sp>
-        <p:nvSpPr>
-          <p:cNvPr id="18" name="Text 16"/>
-          <p:cNvSpPr txBox="1"/>
-          <p:nvPr/>
-        </p:nvSpPr>
-        <p:spPr>
-          <a:xfrm>
-            <a:off x="6309360" y="2834640"/>
-            <a:ext cx="4663440" cy="640080"/>
-          </a:xfrm>
-          <a:prstGeom prst="rect">
-            <a:avLst/>
-          </a:prstGeom>
-          <a:noFill/>
-          <a:ln/>
-        </p:spPr>
-        <p:txBody>
-          <a:bodyPr wrap="square" lIns="0" tIns="0" rIns="0" bIns="0" rtlCol="0" anchor="ctr"/>
-          <a:lstStyle/>
-          <a:p>
-            <a:pPr indent="0" marL="0">
-              <a:buNone/>
-            </a:pPr>
-            <a:r>
-              <a:rPr lang="en-US" sz="1050" dirty="0">
-                <a:solidFill>
-                  <a:srgbClr val="5B6472"/>
-                </a:solidFill>
-                <a:latin typeface="Calibri" pitchFamily="34" charset="0"/>
-                <a:ea typeface="Calibri" pitchFamily="34" charset="-122"/>
-                <a:cs typeface="Calibri" pitchFamily="34" charset="-120"/>
-              </a:rPr>
-              <a:t>投稿は伸びにくいことが多い(閲覧2.4kでUpvote6等)。ただしやり方次第で化ける可能性はある</a:t>
-            </a:r>
-            <a:endParaRPr lang="en-US" sz="1050" dirty="0"/>
-          </a:p>
-        </p:txBody>
-      </p:sp>
-      <p:sp>
-        <p:nvSpPr>
-          <p:cNvPr id="19" name="Text 17"/>
-          <p:cNvSpPr txBox="1"/>
-          <p:nvPr/>
-        </p:nvSpPr>
-        <p:spPr>
-          <a:xfrm>
-            <a:off x="6309360" y="3383280"/>
-            <a:ext cx="4663440" cy="274320"/>
-          </a:xfrm>
-          <a:prstGeom prst="rect">
-            <a:avLst/>
-          </a:prstGeom>
-          <a:noFill/>
-          <a:ln/>
-        </p:spPr>
-        <p:txBody>
-          <a:bodyPr wrap="square" lIns="0" tIns="0" rIns="0" bIns="0" rtlCol="0" anchor="ctr"/>
-          <a:lstStyle/>
-          <a:p>
-            <a:pPr indent="0" marL="0">
-              <a:buNone/>
-            </a:pPr>
-            <a:r>
-              <a:rPr lang="en-US" sz="1250" b="1" dirty="0">
-                <a:solidFill>
-                  <a:srgbClr val="1A1F26"/>
-                </a:solidFill>
-                <a:latin typeface="Calibri" pitchFamily="34" charset="0"/>
-                <a:ea typeface="Calibri" pitchFamily="34" charset="-122"/>
-                <a:cs typeface="Calibri" pitchFamily="34" charset="-120"/>
-              </a:rPr>
-              <a:t>Product Hunt</a:t>
-            </a:r>
-            <a:endParaRPr lang="en-US" sz="1250" dirty="0"/>
-          </a:p>
-        </p:txBody>
-      </p:sp>
-      <p:sp>
-        <p:nvSpPr>
-          <p:cNvPr id="20" name="Text 18"/>
-          <p:cNvSpPr txBox="1"/>
-          <p:nvPr/>
-        </p:nvSpPr>
-        <p:spPr>
-          <a:xfrm>
-            <a:off x="6309360" y="3657600"/>
-            <a:ext cx="4663440" cy="640080"/>
-          </a:xfrm>
-          <a:prstGeom prst="rect">
-            <a:avLst/>
-          </a:prstGeom>
-          <a:noFill/>
-          <a:ln/>
-        </p:spPr>
-        <p:txBody>
-          <a:bodyPr wrap="square" lIns="0" tIns="0" rIns="0" bIns="0" rtlCol="0" anchor="ctr"/>
-          <a:lstStyle/>
-          <a:p>
-            <a:pPr indent="0" marL="0">
-              <a:buNone/>
-            </a:pPr>
-            <a:r>
-              <a:rPr lang="en-US" sz="1050" dirty="0">
-                <a:solidFill>
-                  <a:srgbClr val="5B6472"/>
-                </a:solidFill>
-                <a:latin typeface="Calibri" pitchFamily="34" charset="0"/>
-                <a:ea typeface="Calibri" pitchFamily="34" charset="-122"/>
-                <a:cs typeface="Calibri" pitchFamily="34" charset="-120"/>
-              </a:rPr>
-              <a:t>AI関連プロダクトが多く、その他のプロダクトは埋もれやすい</a:t>
-            </a:r>
-            <a:endParaRPr lang="en-US" sz="1050" dirty="0"/>
-          </a:p>
-        </p:txBody>
-      </p:sp>
-      <p:sp>
-        <p:nvSpPr>
-          <p:cNvPr id="21" name="Text 19"/>
-          <p:cNvSpPr txBox="1"/>
-          <p:nvPr/>
-        </p:nvSpPr>
-        <p:spPr>
-          <a:xfrm>
-            <a:off x="6309360" y="4206240"/>
-            <a:ext cx="4663440" cy="274320"/>
-          </a:xfrm>
-          <a:prstGeom prst="rect">
-            <a:avLst/>
-          </a:prstGeom>
-          <a:noFill/>
-          <a:ln/>
-        </p:spPr>
-        <p:txBody>
-          <a:bodyPr wrap="square" lIns="0" tIns="0" rIns="0" bIns="0" rtlCol="0" anchor="ctr"/>
-          <a:lstStyle/>
-          <a:p>
-            <a:pPr indent="0" marL="0">
-              <a:buNone/>
-            </a:pPr>
-            <a:r>
-              <a:rPr lang="en-US" sz="1250" b="1" dirty="0">
-                <a:solidFill>
-                  <a:srgbClr val="1A1F26"/>
-                </a:solidFill>
-                <a:latin typeface="Calibri" pitchFamily="34" charset="0"/>
-                <a:ea typeface="Calibri" pitchFamily="34" charset="-122"/>
-                <a:cs typeface="Calibri" pitchFamily="34" charset="-120"/>
-              </a:rPr>
-              <a:t>Awesomeリストへの追加PR</a:t>
-            </a:r>
-            <a:endParaRPr lang="en-US" sz="1250" dirty="0"/>
-          </a:p>
-        </p:txBody>
-      </p:sp>
-      <p:sp>
-        <p:nvSpPr>
-          <p:cNvPr id="22" name="Text 20"/>
-          <p:cNvSpPr txBox="1"/>
-          <p:nvPr/>
-        </p:nvSpPr>
-        <p:spPr>
-          <a:xfrm>
-            <a:off x="6309360" y="4480560"/>
-            <a:ext cx="4663440" cy="640080"/>
-          </a:xfrm>
-          <a:prstGeom prst="rect">
-            <a:avLst/>
-          </a:prstGeom>
-          <a:noFill/>
-          <a:ln/>
-        </p:spPr>
-        <p:txBody>
-          <a:bodyPr wrap="square" lIns="0" tIns="0" rIns="0" bIns="0" rtlCol="0" anchor="ctr"/>
-          <a:lstStyle/>
-          <a:p>
-            <a:pPr indent="0" marL="0">
-              <a:buNone/>
-            </a:pPr>
-            <a:r>
-              <a:rPr lang="en-US" sz="1050" dirty="0">
-                <a:solidFill>
-                  <a:srgbClr val="5B6472"/>
-                </a:solidFill>
-                <a:latin typeface="Calibri" pitchFamily="34" charset="0"/>
-                <a:ea typeface="Calibri" pitchFamily="34" charset="-122"/>
-                <a:cs typeface="Calibri" pitchFamily="34" charset="-120"/>
-              </a:rPr>
-              <a:t>掲載されても閲覧者自体が少ない</a:t>
-            </a:r>
-            <a:endParaRPr lang="en-US" sz="1050" dirty="0"/>
-          </a:p>
-        </p:txBody>
-      </p:sp>
-      <p:sp>
-        <p:nvSpPr>
-          <p:cNvPr id="23" name="Text 21"/>
-          <p:cNvSpPr txBox="1"/>
-          <p:nvPr/>
-        </p:nvSpPr>
-        <p:spPr>
-          <a:xfrm>
-            <a:off x="6309360" y="5029200"/>
-            <a:ext cx="4663440" cy="274320"/>
-          </a:xfrm>
-          <a:prstGeom prst="rect">
-            <a:avLst/>
-          </a:prstGeom>
-          <a:noFill/>
-          <a:ln/>
-        </p:spPr>
-        <p:txBody>
-          <a:bodyPr wrap="square" lIns="0" tIns="0" rIns="0" bIns="0" rtlCol="0" anchor="ctr"/>
-          <a:lstStyle/>
-          <a:p>
-            <a:pPr indent="0" marL="0">
-              <a:buNone/>
-            </a:pPr>
-            <a:r>
-              <a:rPr lang="en-US" sz="1250" b="1" dirty="0">
-                <a:solidFill>
-                  <a:srgbClr val="1A1F26"/>
-                </a:solidFill>
-                <a:latin typeface="Calibri" pitchFamily="34" charset="0"/>
-                <a:ea typeface="Calibri" pitchFamily="34" charset="-122"/>
-                <a:cs typeface="Calibri" pitchFamily="34" charset="-120"/>
-              </a:rPr>
-              <a:t>個人ブログ</a:t>
-            </a:r>
-            <a:endParaRPr lang="en-US" sz="1250" dirty="0"/>
-          </a:p>
-        </p:txBody>
-      </p:sp>
-      <p:sp>
-        <p:nvSpPr>
-          <p:cNvPr id="24" name="Text 22"/>
-          <p:cNvSpPr txBox="1"/>
-          <p:nvPr/>
-        </p:nvSpPr>
-        <p:spPr>
-          <a:xfrm>
-            <a:off x="6309360" y="5303520"/>
-            <a:ext cx="4663440" cy="640080"/>
-          </a:xfrm>
-          <a:prstGeom prst="rect">
-            <a:avLst/>
-          </a:prstGeom>
-          <a:noFill/>
-          <a:ln/>
-        </p:spPr>
-        <p:txBody>
-          <a:bodyPr wrap="square" lIns="0" tIns="0" rIns="0" bIns="0" rtlCol="0" anchor="ctr"/>
-          <a:lstStyle/>
-          <a:p>
-            <a:pPr indent="0" marL="0">
-              <a:buNone/>
-            </a:pPr>
-            <a:r>
-              <a:rPr lang="en-US" sz="1050" dirty="0">
-                <a:solidFill>
-                  <a:srgbClr val="5B6472"/>
-                </a:solidFill>
-                <a:latin typeface="Calibri" pitchFamily="34" charset="0"/>
-                <a:ea typeface="Calibri" pitchFamily="34" charset="-122"/>
-                <a:cs typeface="Calibri" pitchFamily="34" charset="-120"/>
-              </a:rPr>
-              <a:t>Qiita/Zenn等の媒体力があるプラットフォームでないと、Twitter投稿とあまり変わらない手応え</a:t>
-            </a:r>
-            <a:endParaRPr lang="en-US" sz="1050" dirty="0"/>
-          </a:p>
-        </p:txBody>
-      </p:sp>
-      <p:sp>
-        <p:nvSpPr>
-          <p:cNvPr id="25" name="Text 23"/>
           <p:cNvSpPr txBox="1"/>
           <p:nvPr/>
         </p:nvSpPr>
@@ -7847,7 +8573,7 @@
                 <a:ea typeface="Calibri" pitchFamily="34" charset="-122"/>
                 <a:cs typeface="Calibri" pitchFamily="34" charset="-120"/>
               </a:rPr>
-              <a:t>出典: 個人開発者によるOSSプロジェクト「Ephe」のブログ記事(1事例の実測値。分野・タイミングにより結果は変動しうる)</a:t>
+              <a:t>出典: github.com/badges/shields(取得時点のスター数。日々変動するため参考値)</a:t>
             </a:r>
             <a:endParaRPr lang="en-US" sz="1000" dirty="0"/>
           </a:p>
@@ -7855,7 +8581,7 @@
       </p:sp>
       <p:sp>
         <p:nvSpPr>
-          <p:cNvPr id="26" name="Text 24"/>
+          <p:cNvPr id="17" name="Text 15"/>
           <p:cNvSpPr txBox="1"/>
           <p:nvPr/>
         </p:nvSpPr>
@@ -7906,7 +8632,7 @@
     <p:bg>
       <p:bgPr>
         <a:solidFill>
-          <a:srgbClr val="1A1F26"/>
+          <a:srgbClr val="F5F6F8"/>
         </a:solidFill>
       </p:bgPr>
     </p:bg>
@@ -7951,7 +8677,7 @@
             <a:r>
               <a:rPr lang="en-US" sz="2800" b="1" dirty="0">
                 <a:solidFill>
-                  <a:srgbClr val="58D68D"/>
+                  <a:srgbClr val="B084F5"/>
                 </a:solidFill>
                 <a:latin typeface="Cambria" pitchFamily="34" charset="0"/>
                 <a:ea typeface="Cambria" pitchFamily="34" charset="-122"/>
@@ -7990,13 +8716,13 @@
             <a:r>
               <a:rPr lang="en-US" sz="2600" b="1" dirty="0">
                 <a:solidFill>
-                  <a:srgbClr val="FFFFFF"/>
+                  <a:srgbClr val="1A1F26"/>
                 </a:solidFill>
                 <a:latin typeface="Cambria" pitchFamily="34" charset="0"/>
                 <a:ea typeface="Cambria" pitchFamily="34" charset="-122"/>
                 <a:cs typeface="Cambria" pitchFamily="34" charset="-120"/>
               </a:rPr>
-              <a:t>実証済み5ステップ(別の実例: npmライブラリ)</a:t>
+              <a:t>宣伝チャネルの効果(実例ケーススタディ)</a:t>
             </a:r>
             <a:endParaRPr lang="en-US" sz="2600" dirty="0"/>
           </a:p>
@@ -8029,13 +8755,13 @@
             <a:r>
               <a:rPr lang="en-US" sz="1250" i="1" dirty="0">
                 <a:solidFill>
-                  <a:srgbClr val="AEB7C4"/>
-                </a:solidFill>
-                <a:latin typeface="Calibri" pitchFamily="34" charset="0"/>
-                <a:ea typeface="Calibri" pitchFamily="34" charset="-122"/>
-                <a:cs typeface="Calibri" pitchFamily="34" charset="-120"/>
-              </a:rPr>
-              <a:t>SNSでの影響力がほぼ無い状態から、Githubスターを50まで伸ばした個人開発者の実例</a:t>
+                  <a:srgbClr val="5B6472"/>
+                </a:solidFill>
+                <a:latin typeface="Calibri" pitchFamily="34" charset="0"/>
+                <a:ea typeface="Calibri" pitchFamily="34" charset="-122"/>
+                <a:cs typeface="Calibri" pitchFamily="34" charset="-120"/>
+              </a:rPr>
+              <a:t>個人OSS開発者が、公開後数ヶ月で400+スターを集めた際の実測データ(1事例)</a:t>
             </a:r>
             <a:endParaRPr lang="en-US" sz="1250" dirty="0"/>
           </a:p>
@@ -8049,16 +8775,23 @@
         </p:nvSpPr>
         <p:spPr>
           <a:xfrm>
-            <a:off x="548640" y="1965960"/>
-            <a:ext cx="384048" cy="384048"/>
-          </a:xfrm>
-          <a:prstGeom prst="ellipse">
-            <a:avLst/>
+            <a:off x="548640" y="1920240"/>
+            <a:ext cx="5212080" cy="3931920"/>
+          </a:xfrm>
+          <a:prstGeom prst="roundRect">
+            <a:avLst>
+              <a:gd name="adj" fmla="val 2326"/>
+            </a:avLst>
           </a:prstGeom>
           <a:solidFill>
-            <a:srgbClr val="58D68D"/>
+            <a:srgbClr val="FFFFFF"/>
           </a:solidFill>
-          <a:ln/>
+          <a:ln w="12700">
+            <a:solidFill>
+              <a:srgbClr val="E3E6EA"/>
+            </a:solidFill>
+            <a:prstDash val="solid"/>
+          </a:ln>
         </p:spPr>
       </p:sp>
       <p:sp>
@@ -8069,24 +8802,63 @@
         </p:nvSpPr>
         <p:spPr>
           <a:xfrm>
-            <a:off x="548640" y="1965960"/>
-            <a:ext cx="384048" cy="384048"/>
-          </a:xfrm>
-          <a:prstGeom prst="rect">
-            <a:avLst/>
-          </a:prstGeom>
-          <a:noFill/>
-          <a:ln/>
-        </p:spPr>
-        <p:txBody>
-          <a:bodyPr wrap="square" lIns="0" tIns="0" rIns="0" bIns="0" rtlCol="0" anchor="ctr"/>
-          <a:lstStyle/>
-          <a:p>
-            <a:pPr algn="ctr" indent="0" marL="0">
-              <a:buNone/>
-            </a:pPr>
-            <a:r>
-              <a:rPr lang="en-US" sz="1300" b="1" dirty="0">
+            <a:off x="822960" y="2103120"/>
+            <a:ext cx="4754880" cy="365760"/>
+          </a:xfrm>
+          <a:prstGeom prst="rect">
+            <a:avLst/>
+          </a:prstGeom>
+          <a:noFill/>
+          <a:ln/>
+        </p:spPr>
+        <p:txBody>
+          <a:bodyPr wrap="square" lIns="0" tIns="0" rIns="0" bIns="0" rtlCol="0" anchor="ctr"/>
+          <a:lstStyle/>
+          <a:p>
+            <a:pPr indent="0" marL="0">
+              <a:buNone/>
+            </a:pPr>
+            <a:r>
+              <a:rPr lang="en-US" sz="1400" b="1" dirty="0">
+                <a:solidFill>
+                  <a:srgbClr val="58D68D"/>
+                </a:solidFill>
+                <a:latin typeface="Calibri" pitchFamily="34" charset="0"/>
+                <a:ea typeface="Calibri" pitchFamily="34" charset="-122"/>
+                <a:cs typeface="Calibri" pitchFamily="34" charset="-120"/>
+              </a:rPr>
+              <a:t>🚀 効果があったチャネル</a:t>
+            </a:r>
+            <a:endParaRPr lang="en-US" sz="1400" dirty="0"/>
+          </a:p>
+        </p:txBody>
+      </p:sp>
+      <p:sp>
+        <p:nvSpPr>
+          <p:cNvPr id="7" name="Text 5"/>
+          <p:cNvSpPr txBox="1"/>
+          <p:nvPr/>
+        </p:nvSpPr>
+        <p:spPr>
+          <a:xfrm>
+            <a:off x="822960" y="2560320"/>
+            <a:ext cx="4663440" cy="274320"/>
+          </a:xfrm>
+          <a:prstGeom prst="rect">
+            <a:avLst/>
+          </a:prstGeom>
+          <a:noFill/>
+          <a:ln/>
+        </p:spPr>
+        <p:txBody>
+          <a:bodyPr wrap="square" lIns="0" tIns="0" rIns="0" bIns="0" rtlCol="0" anchor="ctr"/>
+          <a:lstStyle/>
+          <a:p>
+            <a:pPr indent="0" marL="0">
+              <a:buNone/>
+            </a:pPr>
+            <a:r>
+              <a:rPr lang="en-US" sz="1250" b="1" dirty="0">
                 <a:solidFill>
                   <a:srgbClr val="1A1F26"/>
                 </a:solidFill>
@@ -8094,48 +8866,9 @@
                 <a:ea typeface="Calibri" pitchFamily="34" charset="-122"/>
                 <a:cs typeface="Calibri" pitchFamily="34" charset="-120"/>
               </a:rPr>
-              <a:t>1</a:t>
-            </a:r>
-            <a:endParaRPr lang="en-US" sz="1300" dirty="0"/>
-          </a:p>
-        </p:txBody>
-      </p:sp>
-      <p:sp>
-        <p:nvSpPr>
-          <p:cNvPr id="7" name="Text 5"/>
-          <p:cNvSpPr txBox="1"/>
-          <p:nvPr/>
-        </p:nvSpPr>
-        <p:spPr>
-          <a:xfrm>
-            <a:off x="1097280" y="1920240"/>
-            <a:ext cx="2926080" cy="457200"/>
-          </a:xfrm>
-          <a:prstGeom prst="rect">
-            <a:avLst/>
-          </a:prstGeom>
-          <a:noFill/>
-          <a:ln/>
-        </p:spPr>
-        <p:txBody>
-          <a:bodyPr wrap="square" lIns="0" tIns="0" rIns="0" bIns="0" rtlCol="0" anchor="t"/>
-          <a:lstStyle/>
-          <a:p>
-            <a:pPr indent="0" marL="0">
-              <a:buNone/>
-            </a:pPr>
-            <a:r>
-              <a:rPr lang="en-US" sz="1300" b="1" dirty="0">
-                <a:solidFill>
-                  <a:srgbClr val="FFFFFF"/>
-                </a:solidFill>
-                <a:latin typeface="Calibri" pitchFamily="34" charset="0"/>
-                <a:ea typeface="Calibri" pitchFamily="34" charset="-122"/>
-                <a:cs typeface="Calibri" pitchFamily="34" charset="-120"/>
-              </a:rPr>
-              <a:t>英語で書く</a:t>
-            </a:r>
-            <a:endParaRPr lang="en-US" sz="1300" dirty="0"/>
+              <a:t>Hacker News</a:t>
+            </a:r>
+            <a:endParaRPr lang="en-US" sz="1250" dirty="0"/>
           </a:p>
         </p:txBody>
       </p:sp>
@@ -8147,83 +8880,363 @@
         </p:nvSpPr>
         <p:spPr>
           <a:xfrm>
-            <a:off x="4114800" y="1920240"/>
-            <a:ext cx="6858000" cy="777240"/>
-          </a:xfrm>
-          <a:prstGeom prst="rect">
-            <a:avLst/>
-          </a:prstGeom>
-          <a:noFill/>
-          <a:ln/>
-        </p:spPr>
-        <p:txBody>
-          <a:bodyPr wrap="square" lIns="0" tIns="0" rIns="0" bIns="0" rtlCol="0" anchor="ctr"/>
-          <a:lstStyle/>
-          <a:p>
-            <a:pPr indent="0" marL="0">
-              <a:buNone/>
-            </a:pPr>
-            <a:r>
-              <a:rPr lang="en-US" sz="1150" dirty="0">
-                <a:solidFill>
-                  <a:srgbClr val="AEB7C4"/>
-                </a:solidFill>
-                <a:latin typeface="Calibri" pitchFamily="34" charset="0"/>
-                <a:ea typeface="Calibri" pitchFamily="34" charset="-122"/>
-                <a:cs typeface="Calibri" pitchFamily="34" charset="-120"/>
-              </a:rPr>
-              <a:t>README・告知文はすべて英語にする。日本語のみだとリーチできる人数が大きく限定される</a:t>
-            </a:r>
-            <a:endParaRPr lang="en-US" sz="1150" dirty="0"/>
-          </a:p>
-        </p:txBody>
-      </p:sp>
-      <p:sp>
-        <p:nvSpPr>
-          <p:cNvPr id="9" name="Shape 7"/>
+            <a:off x="822960" y="2834640"/>
+            <a:ext cx="4663440" cy="640080"/>
+          </a:xfrm>
+          <a:prstGeom prst="rect">
+            <a:avLst/>
+          </a:prstGeom>
+          <a:noFill/>
+          <a:ln/>
+        </p:spPr>
+        <p:txBody>
+          <a:bodyPr wrap="square" lIns="0" tIns="0" rIns="0" bIns="0" rtlCol="0" anchor="ctr"/>
+          <a:lstStyle/>
+          <a:p>
+            <a:pPr indent="0" marL="0">
+              <a:buNone/>
+            </a:pPr>
+            <a:r>
+              <a:rPr lang="en-US" sz="1050" dirty="0">
+                <a:solidFill>
+                  <a:srgbClr val="5B6472"/>
+                </a:solidFill>
+                <a:latin typeface="Calibri" pitchFamily="34" charset="0"/>
+                <a:ea typeface="Calibri" pitchFamily="34" charset="-122"/>
+                <a:cs typeface="Calibri" pitchFamily="34" charset="-120"/>
+              </a:rPr>
+              <a:t>「Show HN:」プレフィックスを付けて投稿する文化があり、Showタブ・トップページに掲載。最も効果大</a:t>
+            </a:r>
+            <a:endParaRPr lang="en-US" sz="1050" dirty="0"/>
+          </a:p>
+        </p:txBody>
+      </p:sp>
+      <p:sp>
+        <p:nvSpPr>
+          <p:cNvPr id="9" name="Text 7"/>
+          <p:cNvSpPr txBox="1"/>
+          <p:nvPr/>
+        </p:nvSpPr>
+        <p:spPr>
+          <a:xfrm>
+            <a:off x="822960" y="3383280"/>
+            <a:ext cx="4663440" cy="274320"/>
+          </a:xfrm>
+          <a:prstGeom prst="rect">
+            <a:avLst/>
+          </a:prstGeom>
+          <a:noFill/>
+          <a:ln/>
+        </p:spPr>
+        <p:txBody>
+          <a:bodyPr wrap="square" lIns="0" tIns="0" rIns="0" bIns="0" rtlCol="0" anchor="ctr"/>
+          <a:lstStyle/>
+          <a:p>
+            <a:pPr indent="0" marL="0">
+              <a:buNone/>
+            </a:pPr>
+            <a:r>
+              <a:rPr lang="en-US" sz="1250" b="1" dirty="0">
+                <a:solidFill>
+                  <a:srgbClr val="1A1F26"/>
+                </a:solidFill>
+                <a:latin typeface="Calibri" pitchFamily="34" charset="0"/>
+                <a:ea typeface="Calibri" pitchFamily="34" charset="-122"/>
+                <a:cs typeface="Calibri" pitchFamily="34" charset="-120"/>
+              </a:rPr>
+              <a:t>Twitter/X</a:t>
+            </a:r>
+            <a:endParaRPr lang="en-US" sz="1250" dirty="0"/>
+          </a:p>
+        </p:txBody>
+      </p:sp>
+      <p:sp>
+        <p:nvSpPr>
+          <p:cNvPr id="10" name="Text 8"/>
+          <p:cNvSpPr txBox="1"/>
+          <p:nvPr/>
+        </p:nvSpPr>
+        <p:spPr>
+          <a:xfrm>
+            <a:off x="822960" y="3657600"/>
+            <a:ext cx="4663440" cy="640080"/>
+          </a:xfrm>
+          <a:prstGeom prst="rect">
+            <a:avLst/>
+          </a:prstGeom>
+          <a:noFill/>
+          <a:ln/>
+        </p:spPr>
+        <p:txBody>
+          <a:bodyPr wrap="square" lIns="0" tIns="0" rIns="0" bIns="0" rtlCol="0" anchor="ctr"/>
+          <a:lstStyle/>
+          <a:p>
+            <a:pPr indent="0" marL="0">
+              <a:buNone/>
+            </a:pPr>
+            <a:r>
+              <a:rPr lang="en-US" sz="1050" dirty="0">
+                <a:solidFill>
+                  <a:srgbClr val="5B6472"/>
+                </a:solidFill>
+                <a:latin typeface="Calibri" pitchFamily="34" charset="0"/>
+                <a:ea typeface="Calibri" pitchFamily="34" charset="-122"/>
+                <a:cs typeface="Calibri" pitchFamily="34" charset="-120"/>
+              </a:rPr>
+              <a:t>自分の発信単独では弱いが、フォロワーの多いインフルエンサーが拡散すると効果大</a:t>
+            </a:r>
+            <a:endParaRPr lang="en-US" sz="1050" dirty="0"/>
+          </a:p>
+        </p:txBody>
+      </p:sp>
+      <p:sp>
+        <p:nvSpPr>
+          <p:cNvPr id="11" name="Text 9"/>
+          <p:cNvSpPr txBox="1"/>
+          <p:nvPr/>
+        </p:nvSpPr>
+        <p:spPr>
+          <a:xfrm>
+            <a:off x="822960" y="4206240"/>
+            <a:ext cx="4663440" cy="274320"/>
+          </a:xfrm>
+          <a:prstGeom prst="rect">
+            <a:avLst/>
+          </a:prstGeom>
+          <a:noFill/>
+          <a:ln/>
+        </p:spPr>
+        <p:txBody>
+          <a:bodyPr wrap="square" lIns="0" tIns="0" rIns="0" bIns="0" rtlCol="0" anchor="ctr"/>
+          <a:lstStyle/>
+          <a:p>
+            <a:pPr indent="0" marL="0">
+              <a:buNone/>
+            </a:pPr>
+            <a:r>
+              <a:rPr lang="en-US" sz="1250" b="1" dirty="0">
+                <a:solidFill>
+                  <a:srgbClr val="1A1F26"/>
+                </a:solidFill>
+                <a:latin typeface="Calibri" pitchFamily="34" charset="0"/>
+                <a:ea typeface="Calibri" pitchFamily="34" charset="-122"/>
+                <a:cs typeface="Calibri" pitchFamily="34" charset="-120"/>
+              </a:rPr>
+              <a:t>GitHub内の連鎖</a:t>
+            </a:r>
+            <a:endParaRPr lang="en-US" sz="1250" dirty="0"/>
+          </a:p>
+        </p:txBody>
+      </p:sp>
+      <p:sp>
+        <p:nvSpPr>
+          <p:cNvPr id="12" name="Text 10"/>
+          <p:cNvSpPr txBox="1"/>
+          <p:nvPr/>
+        </p:nvSpPr>
+        <p:spPr>
+          <a:xfrm>
+            <a:off x="822960" y="4480560"/>
+            <a:ext cx="4663440" cy="640080"/>
+          </a:xfrm>
+          <a:prstGeom prst="rect">
+            <a:avLst/>
+          </a:prstGeom>
+          <a:noFill/>
+          <a:ln/>
+        </p:spPr>
+        <p:txBody>
+          <a:bodyPr wrap="square" lIns="0" tIns="0" rIns="0" bIns="0" rtlCol="0" anchor="ctr"/>
+          <a:lstStyle/>
+          <a:p>
+            <a:pPr indent="0" marL="0">
+              <a:buNone/>
+            </a:pPr>
+            <a:r>
+              <a:rPr lang="en-US" sz="1050" dirty="0">
+                <a:solidFill>
+                  <a:srgbClr val="5B6472"/>
+                </a:solidFill>
+                <a:latin typeface="Calibri" pitchFamily="34" charset="0"/>
+                <a:ea typeface="Calibri" pitchFamily="34" charset="-122"/>
+                <a:cs typeface="Calibri" pitchFamily="34" charset="-120"/>
+              </a:rPr>
+              <a:t>フォロー中ユーザーがStarしたリポジトリがフィードに流れる仕組みがあり、フォロワーの多い人がStarすると連鎖的に増える</a:t>
+            </a:r>
+            <a:endParaRPr lang="en-US" sz="1050" dirty="0"/>
+          </a:p>
+        </p:txBody>
+      </p:sp>
+      <p:sp>
+        <p:nvSpPr>
+          <p:cNvPr id="13" name="Text 11"/>
+          <p:cNvSpPr txBox="1"/>
+          <p:nvPr/>
+        </p:nvSpPr>
+        <p:spPr>
+          <a:xfrm>
+            <a:off x="822960" y="5029200"/>
+            <a:ext cx="4663440" cy="274320"/>
+          </a:xfrm>
+          <a:prstGeom prst="rect">
+            <a:avLst/>
+          </a:prstGeom>
+          <a:noFill/>
+          <a:ln/>
+        </p:spPr>
+        <p:txBody>
+          <a:bodyPr wrap="square" lIns="0" tIns="0" rIns="0" bIns="0" rtlCol="0" anchor="ctr"/>
+          <a:lstStyle/>
+          <a:p>
+            <a:pPr indent="0" marL="0">
+              <a:buNone/>
+            </a:pPr>
+            <a:r>
+              <a:rPr lang="en-US" sz="1250" b="1" dirty="0">
+                <a:solidFill>
+                  <a:srgbClr val="1A1F26"/>
+                </a:solidFill>
+                <a:latin typeface="Calibri" pitchFamily="34" charset="0"/>
+                <a:ea typeface="Calibri" pitchFamily="34" charset="-122"/>
+                <a:cs typeface="Calibri" pitchFamily="34" charset="-120"/>
+              </a:rPr>
+              <a:t>韓国版HN(news.hada.io)</a:t>
+            </a:r>
+            <a:endParaRPr lang="en-US" sz="1250" dirty="0"/>
+          </a:p>
+        </p:txBody>
+      </p:sp>
+      <p:sp>
+        <p:nvSpPr>
+          <p:cNvPr id="14" name="Text 12"/>
+          <p:cNvSpPr txBox="1"/>
+          <p:nvPr/>
+        </p:nvSpPr>
+        <p:spPr>
+          <a:xfrm>
+            <a:off x="822960" y="5303520"/>
+            <a:ext cx="4663440" cy="640080"/>
+          </a:xfrm>
+          <a:prstGeom prst="rect">
+            <a:avLst/>
+          </a:prstGeom>
+          <a:noFill/>
+          <a:ln/>
+        </p:spPr>
+        <p:txBody>
+          <a:bodyPr wrap="square" lIns="0" tIns="0" rIns="0" bIns="0" rtlCol="0" anchor="ctr"/>
+          <a:lstStyle/>
+          <a:p>
+            <a:pPr indent="0" marL="0">
+              <a:buNone/>
+            </a:pPr>
+            <a:r>
+              <a:rPr lang="en-US" sz="1050" dirty="0">
+                <a:solidFill>
+                  <a:srgbClr val="5B6472"/>
+                </a:solidFill>
+                <a:latin typeface="Calibri" pitchFamily="34" charset="0"/>
+                <a:ea typeface="Calibri" pitchFamily="34" charset="-122"/>
+                <a:cs typeface="Calibri" pitchFamily="34" charset="-120"/>
+              </a:rPr>
+              <a:t>現地の誰かが投稿したことで、そこから約40スターが集まった</a:t>
+            </a:r>
+            <a:endParaRPr lang="en-US" sz="1050" dirty="0"/>
+          </a:p>
+        </p:txBody>
+      </p:sp>
+      <p:sp>
+        <p:nvSpPr>
+          <p:cNvPr id="15" name="Shape 13"/>
           <p:cNvSpPr/>
           <p:nvPr/>
         </p:nvSpPr>
         <p:spPr>
           <a:xfrm>
-            <a:off x="548640" y="2807208"/>
-            <a:ext cx="384048" cy="384048"/>
-          </a:xfrm>
-          <a:prstGeom prst="ellipse">
-            <a:avLst/>
+            <a:off x="6035040" y="1920240"/>
+            <a:ext cx="5212080" cy="3931920"/>
+          </a:xfrm>
+          <a:prstGeom prst="roundRect">
+            <a:avLst>
+              <a:gd name="adj" fmla="val 2326"/>
+            </a:avLst>
           </a:prstGeom>
           <a:solidFill>
-            <a:srgbClr val="58D68D"/>
+            <a:srgbClr val="FFFFFF"/>
           </a:solidFill>
-          <a:ln/>
-        </p:spPr>
-      </p:sp>
-      <p:sp>
-        <p:nvSpPr>
-          <p:cNvPr id="10" name="Text 8"/>
-          <p:cNvSpPr txBox="1"/>
-          <p:nvPr/>
-        </p:nvSpPr>
-        <p:spPr>
-          <a:xfrm>
-            <a:off x="548640" y="2807208"/>
-            <a:ext cx="384048" cy="384048"/>
-          </a:xfrm>
-          <a:prstGeom prst="rect">
-            <a:avLst/>
-          </a:prstGeom>
-          <a:noFill/>
-          <a:ln/>
-        </p:spPr>
-        <p:txBody>
-          <a:bodyPr wrap="square" lIns="0" tIns="0" rIns="0" bIns="0" rtlCol="0" anchor="ctr"/>
-          <a:lstStyle/>
-          <a:p>
-            <a:pPr algn="ctr" indent="0" marL="0">
-              <a:buNone/>
-            </a:pPr>
-            <a:r>
-              <a:rPr lang="en-US" sz="1300" b="1" dirty="0">
+          <a:ln w="12700">
+            <a:solidFill>
+              <a:srgbClr val="E3E6EA"/>
+            </a:solidFill>
+            <a:prstDash val="solid"/>
+          </a:ln>
+        </p:spPr>
+      </p:sp>
+      <p:sp>
+        <p:nvSpPr>
+          <p:cNvPr id="16" name="Text 14"/>
+          <p:cNvSpPr txBox="1"/>
+          <p:nvPr/>
+        </p:nvSpPr>
+        <p:spPr>
+          <a:xfrm>
+            <a:off x="6309360" y="2103120"/>
+            <a:ext cx="4754880" cy="365760"/>
+          </a:xfrm>
+          <a:prstGeom prst="rect">
+            <a:avLst/>
+          </a:prstGeom>
+          <a:noFill/>
+          <a:ln/>
+        </p:spPr>
+        <p:txBody>
+          <a:bodyPr wrap="square" lIns="0" tIns="0" rIns="0" bIns="0" rtlCol="0" anchor="ctr"/>
+          <a:lstStyle/>
+          <a:p>
+            <a:pPr indent="0" marL="0">
+              <a:buNone/>
+            </a:pPr>
+            <a:r>
+              <a:rPr lang="en-US" sz="1400" b="1" dirty="0">
+                <a:solidFill>
+                  <a:srgbClr val="6B7280"/>
+                </a:solidFill>
+                <a:latin typeface="Calibri" pitchFamily="34" charset="0"/>
+                <a:ea typeface="Calibri" pitchFamily="34" charset="-122"/>
+                <a:cs typeface="Calibri" pitchFamily="34" charset="-120"/>
+              </a:rPr>
+              <a:t>🪦 効果が薄かったチャネル</a:t>
+            </a:r>
+            <a:endParaRPr lang="en-US" sz="1400" dirty="0"/>
+          </a:p>
+        </p:txBody>
+      </p:sp>
+      <p:sp>
+        <p:nvSpPr>
+          <p:cNvPr id="17" name="Text 15"/>
+          <p:cNvSpPr txBox="1"/>
+          <p:nvPr/>
+        </p:nvSpPr>
+        <p:spPr>
+          <a:xfrm>
+            <a:off x="6309360" y="2560320"/>
+            <a:ext cx="4663440" cy="274320"/>
+          </a:xfrm>
+          <a:prstGeom prst="rect">
+            <a:avLst/>
+          </a:prstGeom>
+          <a:noFill/>
+          <a:ln/>
+        </p:spPr>
+        <p:txBody>
+          <a:bodyPr wrap="square" lIns="0" tIns="0" rIns="0" bIns="0" rtlCol="0" anchor="ctr"/>
+          <a:lstStyle/>
+          <a:p>
+            <a:pPr indent="0" marL="0">
+              <a:buNone/>
+            </a:pPr>
+            <a:r>
+              <a:rPr lang="en-US" sz="1250" b="1" dirty="0">
                 <a:solidFill>
                   <a:srgbClr val="1A1F26"/>
                 </a:solidFill>
@@ -8231,136 +9244,77 @@
                 <a:ea typeface="Calibri" pitchFamily="34" charset="-122"/>
                 <a:cs typeface="Calibri" pitchFamily="34" charset="-120"/>
               </a:rPr>
-              <a:t>2</a:t>
-            </a:r>
-            <a:endParaRPr lang="en-US" sz="1300" dirty="0"/>
-          </a:p>
-        </p:txBody>
-      </p:sp>
-      <p:sp>
-        <p:nvSpPr>
-          <p:cNvPr id="11" name="Text 9"/>
-          <p:cNvSpPr txBox="1"/>
-          <p:nvPr/>
-        </p:nvSpPr>
-        <p:spPr>
-          <a:xfrm>
-            <a:off x="1097280" y="2761488"/>
-            <a:ext cx="2926080" cy="457200"/>
-          </a:xfrm>
-          <a:prstGeom prst="rect">
-            <a:avLst/>
-          </a:prstGeom>
-          <a:noFill/>
-          <a:ln/>
-        </p:spPr>
-        <p:txBody>
-          <a:bodyPr wrap="square" lIns="0" tIns="0" rIns="0" bIns="0" rtlCol="0" anchor="t"/>
-          <a:lstStyle/>
-          <a:p>
-            <a:pPr indent="0" marL="0">
-              <a:buNone/>
-            </a:pPr>
-            <a:r>
-              <a:rPr lang="en-US" sz="1300" b="1" dirty="0">
-                <a:solidFill>
-                  <a:srgbClr val="FFFFFF"/>
-                </a:solidFill>
-                <a:latin typeface="Calibri" pitchFamily="34" charset="0"/>
-                <a:ea typeface="Calibri" pitchFamily="34" charset="-122"/>
-                <a:cs typeface="Calibri" pitchFamily="34" charset="-120"/>
-              </a:rPr>
-              <a:t>アイキャッチ画像を作る</a:t>
-            </a:r>
-            <a:endParaRPr lang="en-US" sz="1300" dirty="0"/>
-          </a:p>
-        </p:txBody>
-      </p:sp>
-      <p:sp>
-        <p:nvSpPr>
-          <p:cNvPr id="12" name="Text 10"/>
-          <p:cNvSpPr txBox="1"/>
-          <p:nvPr/>
-        </p:nvSpPr>
-        <p:spPr>
-          <a:xfrm>
-            <a:off x="4114800" y="2761488"/>
-            <a:ext cx="6858000" cy="777240"/>
-          </a:xfrm>
-          <a:prstGeom prst="rect">
-            <a:avLst/>
-          </a:prstGeom>
-          <a:noFill/>
-          <a:ln/>
-        </p:spPr>
-        <p:txBody>
-          <a:bodyPr wrap="square" lIns="0" tIns="0" rIns="0" bIns="0" rtlCol="0" anchor="ctr"/>
-          <a:lstStyle/>
-          <a:p>
-            <a:pPr indent="0" marL="0">
-              <a:buNone/>
-            </a:pPr>
-            <a:r>
-              <a:rPr lang="en-US" sz="1150" dirty="0">
-                <a:solidFill>
-                  <a:srgbClr val="AEB7C4"/>
-                </a:solidFill>
-                <a:latin typeface="Calibri" pitchFamily="34" charset="0"/>
-                <a:ea typeface="Calibri" pitchFamily="34" charset="-122"/>
-                <a:cs typeface="Calibri" pitchFamily="34" charset="-120"/>
-              </a:rPr>
-              <a:t>Canva等でOGP画像を作成し、リポジトリのSocial preview設定に登録する(第一印象を左右する)</a:t>
-            </a:r>
-            <a:endParaRPr lang="en-US" sz="1150" dirty="0"/>
-          </a:p>
-        </p:txBody>
-      </p:sp>
-      <p:sp>
-        <p:nvSpPr>
-          <p:cNvPr id="13" name="Shape 11"/>
-          <p:cNvSpPr/>
-          <p:nvPr/>
-        </p:nvSpPr>
-        <p:spPr>
-          <a:xfrm>
-            <a:off x="548640" y="3648456"/>
-            <a:ext cx="384048" cy="384048"/>
-          </a:xfrm>
-          <a:prstGeom prst="ellipse">
-            <a:avLst/>
-          </a:prstGeom>
-          <a:solidFill>
-            <a:srgbClr val="58D68D"/>
-          </a:solidFill>
-          <a:ln/>
-        </p:spPr>
-      </p:sp>
-      <p:sp>
-        <p:nvSpPr>
-          <p:cNvPr id="14" name="Text 12"/>
-          <p:cNvSpPr txBox="1"/>
-          <p:nvPr/>
-        </p:nvSpPr>
-        <p:spPr>
-          <a:xfrm>
-            <a:off x="548640" y="3648456"/>
-            <a:ext cx="384048" cy="384048"/>
-          </a:xfrm>
-          <a:prstGeom prst="rect">
-            <a:avLst/>
-          </a:prstGeom>
-          <a:noFill/>
-          <a:ln/>
-        </p:spPr>
-        <p:txBody>
-          <a:bodyPr wrap="square" lIns="0" tIns="0" rIns="0" bIns="0" rtlCol="0" anchor="ctr"/>
-          <a:lstStyle/>
-          <a:p>
-            <a:pPr algn="ctr" indent="0" marL="0">
-              <a:buNone/>
-            </a:pPr>
-            <a:r>
-              <a:rPr lang="en-US" sz="1300" b="1" dirty="0">
+              <a:t>Reddit</a:t>
+            </a:r>
+            <a:endParaRPr lang="en-US" sz="1250" dirty="0"/>
+          </a:p>
+        </p:txBody>
+      </p:sp>
+      <p:sp>
+        <p:nvSpPr>
+          <p:cNvPr id="18" name="Text 16"/>
+          <p:cNvSpPr txBox="1"/>
+          <p:nvPr/>
+        </p:nvSpPr>
+        <p:spPr>
+          <a:xfrm>
+            <a:off x="6309360" y="2834640"/>
+            <a:ext cx="4663440" cy="640080"/>
+          </a:xfrm>
+          <a:prstGeom prst="rect">
+            <a:avLst/>
+          </a:prstGeom>
+          <a:noFill/>
+          <a:ln/>
+        </p:spPr>
+        <p:txBody>
+          <a:bodyPr wrap="square" lIns="0" tIns="0" rIns="0" bIns="0" rtlCol="0" anchor="ctr"/>
+          <a:lstStyle/>
+          <a:p>
+            <a:pPr indent="0" marL="0">
+              <a:buNone/>
+            </a:pPr>
+            <a:r>
+              <a:rPr lang="en-US" sz="1050" dirty="0">
+                <a:solidFill>
+                  <a:srgbClr val="5B6472"/>
+                </a:solidFill>
+                <a:latin typeface="Calibri" pitchFamily="34" charset="0"/>
+                <a:ea typeface="Calibri" pitchFamily="34" charset="-122"/>
+                <a:cs typeface="Calibri" pitchFamily="34" charset="-120"/>
+              </a:rPr>
+              <a:t>投稿は伸びにくいことが多い(閲覧2.4kでUpvote6等)。ただしやり方次第で化ける可能性はある</a:t>
+            </a:r>
+            <a:endParaRPr lang="en-US" sz="1050" dirty="0"/>
+          </a:p>
+        </p:txBody>
+      </p:sp>
+      <p:sp>
+        <p:nvSpPr>
+          <p:cNvPr id="19" name="Text 17"/>
+          <p:cNvSpPr txBox="1"/>
+          <p:nvPr/>
+        </p:nvSpPr>
+        <p:spPr>
+          <a:xfrm>
+            <a:off x="6309360" y="3383280"/>
+            <a:ext cx="4663440" cy="274320"/>
+          </a:xfrm>
+          <a:prstGeom prst="rect">
+            <a:avLst/>
+          </a:prstGeom>
+          <a:noFill/>
+          <a:ln/>
+        </p:spPr>
+        <p:txBody>
+          <a:bodyPr wrap="square" lIns="0" tIns="0" rIns="0" bIns="0" rtlCol="0" anchor="ctr"/>
+          <a:lstStyle/>
+          <a:p>
+            <a:pPr indent="0" marL="0">
+              <a:buNone/>
+            </a:pPr>
+            <a:r>
+              <a:rPr lang="en-US" sz="1250" b="1" dirty="0">
                 <a:solidFill>
                   <a:srgbClr val="1A1F26"/>
                 </a:solidFill>
@@ -8368,136 +9322,77 @@
                 <a:ea typeface="Calibri" pitchFamily="34" charset="-122"/>
                 <a:cs typeface="Calibri" pitchFamily="34" charset="-120"/>
               </a:rPr>
-              <a:t>3</a:t>
-            </a:r>
-            <a:endParaRPr lang="en-US" sz="1300" dirty="0"/>
-          </a:p>
-        </p:txBody>
-      </p:sp>
-      <p:sp>
-        <p:nvSpPr>
-          <p:cNvPr id="15" name="Text 13"/>
-          <p:cNvSpPr txBox="1"/>
-          <p:nvPr/>
-        </p:nvSpPr>
-        <p:spPr>
-          <a:xfrm>
-            <a:off x="1097280" y="3602736"/>
-            <a:ext cx="2926080" cy="457200"/>
-          </a:xfrm>
-          <a:prstGeom prst="rect">
-            <a:avLst/>
-          </a:prstGeom>
-          <a:noFill/>
-          <a:ln/>
-        </p:spPr>
-        <p:txBody>
-          <a:bodyPr wrap="square" lIns="0" tIns="0" rIns="0" bIns="0" rtlCol="0" anchor="t"/>
-          <a:lstStyle/>
-          <a:p>
-            <a:pPr indent="0" marL="0">
-              <a:buNone/>
-            </a:pPr>
-            <a:r>
-              <a:rPr lang="en-US" sz="1300" b="1" dirty="0">
-                <a:solidFill>
-                  <a:srgbClr val="FFFFFF"/>
-                </a:solidFill>
-                <a:latin typeface="Calibri" pitchFamily="34" charset="0"/>
-                <a:ea typeface="Calibri" pitchFamily="34" charset="-122"/>
-                <a:cs typeface="Calibri" pitchFamily="34" charset="-120"/>
-              </a:rPr>
-              <a:t>README/公式サイトをグラフィカルに</a:t>
-            </a:r>
-            <a:endParaRPr lang="en-US" sz="1300" dirty="0"/>
-          </a:p>
-        </p:txBody>
-      </p:sp>
-      <p:sp>
-        <p:nvSpPr>
-          <p:cNvPr id="16" name="Text 14"/>
-          <p:cNvSpPr txBox="1"/>
-          <p:nvPr/>
-        </p:nvSpPr>
-        <p:spPr>
-          <a:xfrm>
-            <a:off x="4114800" y="3602736"/>
-            <a:ext cx="6858000" cy="777240"/>
-          </a:xfrm>
-          <a:prstGeom prst="rect">
-            <a:avLst/>
-          </a:prstGeom>
-          <a:noFill/>
-          <a:ln/>
-        </p:spPr>
-        <p:txBody>
-          <a:bodyPr wrap="square" lIns="0" tIns="0" rIns="0" bIns="0" rtlCol="0" anchor="ctr"/>
-          <a:lstStyle/>
-          <a:p>
-            <a:pPr indent="0" marL="0">
-              <a:buNone/>
-            </a:pPr>
-            <a:r>
-              <a:rPr lang="en-US" sz="1150" dirty="0">
-                <a:solidFill>
-                  <a:srgbClr val="AEB7C4"/>
-                </a:solidFill>
-                <a:latin typeface="Calibri" pitchFamily="34" charset="0"/>
-                <a:ea typeface="Calibri" pitchFamily="34" charset="-122"/>
-                <a:cs typeface="Calibri" pitchFamily="34" charset="-120"/>
-              </a:rPr>
-              <a:t>デモ・使い方が伝わるREADMEにする。GitHub Pages等で簡易な公式サイトを作るのも有効</a:t>
-            </a:r>
-            <a:endParaRPr lang="en-US" sz="1150" dirty="0"/>
-          </a:p>
-        </p:txBody>
-      </p:sp>
-      <p:sp>
-        <p:nvSpPr>
-          <p:cNvPr id="17" name="Shape 15"/>
-          <p:cNvSpPr/>
-          <p:nvPr/>
-        </p:nvSpPr>
-        <p:spPr>
-          <a:xfrm>
-            <a:off x="548640" y="4489704"/>
-            <a:ext cx="384048" cy="384048"/>
-          </a:xfrm>
-          <a:prstGeom prst="ellipse">
-            <a:avLst/>
-          </a:prstGeom>
-          <a:solidFill>
-            <a:srgbClr val="58D68D"/>
-          </a:solidFill>
-          <a:ln/>
-        </p:spPr>
-      </p:sp>
-      <p:sp>
-        <p:nvSpPr>
-          <p:cNvPr id="18" name="Text 16"/>
-          <p:cNvSpPr txBox="1"/>
-          <p:nvPr/>
-        </p:nvSpPr>
-        <p:spPr>
-          <a:xfrm>
-            <a:off x="548640" y="4489704"/>
-            <a:ext cx="384048" cy="384048"/>
-          </a:xfrm>
-          <a:prstGeom prst="rect">
-            <a:avLst/>
-          </a:prstGeom>
-          <a:noFill/>
-          <a:ln/>
-        </p:spPr>
-        <p:txBody>
-          <a:bodyPr wrap="square" lIns="0" tIns="0" rIns="0" bIns="0" rtlCol="0" anchor="ctr"/>
-          <a:lstStyle/>
-          <a:p>
-            <a:pPr algn="ctr" indent="0" marL="0">
-              <a:buNone/>
-            </a:pPr>
-            <a:r>
-              <a:rPr lang="en-US" sz="1300" b="1" dirty="0">
+              <a:t>Product Hunt</a:t>
+            </a:r>
+            <a:endParaRPr lang="en-US" sz="1250" dirty="0"/>
+          </a:p>
+        </p:txBody>
+      </p:sp>
+      <p:sp>
+        <p:nvSpPr>
+          <p:cNvPr id="20" name="Text 18"/>
+          <p:cNvSpPr txBox="1"/>
+          <p:nvPr/>
+        </p:nvSpPr>
+        <p:spPr>
+          <a:xfrm>
+            <a:off x="6309360" y="3657600"/>
+            <a:ext cx="4663440" cy="640080"/>
+          </a:xfrm>
+          <a:prstGeom prst="rect">
+            <a:avLst/>
+          </a:prstGeom>
+          <a:noFill/>
+          <a:ln/>
+        </p:spPr>
+        <p:txBody>
+          <a:bodyPr wrap="square" lIns="0" tIns="0" rIns="0" bIns="0" rtlCol="0" anchor="ctr"/>
+          <a:lstStyle/>
+          <a:p>
+            <a:pPr indent="0" marL="0">
+              <a:buNone/>
+            </a:pPr>
+            <a:r>
+              <a:rPr lang="en-US" sz="1050" dirty="0">
+                <a:solidFill>
+                  <a:srgbClr val="5B6472"/>
+                </a:solidFill>
+                <a:latin typeface="Calibri" pitchFamily="34" charset="0"/>
+                <a:ea typeface="Calibri" pitchFamily="34" charset="-122"/>
+                <a:cs typeface="Calibri" pitchFamily="34" charset="-120"/>
+              </a:rPr>
+              <a:t>AI関連プロダクトが多く、その他のプロダクトは埋もれやすい</a:t>
+            </a:r>
+            <a:endParaRPr lang="en-US" sz="1050" dirty="0"/>
+          </a:p>
+        </p:txBody>
+      </p:sp>
+      <p:sp>
+        <p:nvSpPr>
+          <p:cNvPr id="21" name="Text 19"/>
+          <p:cNvSpPr txBox="1"/>
+          <p:nvPr/>
+        </p:nvSpPr>
+        <p:spPr>
+          <a:xfrm>
+            <a:off x="6309360" y="4206240"/>
+            <a:ext cx="4663440" cy="274320"/>
+          </a:xfrm>
+          <a:prstGeom prst="rect">
+            <a:avLst/>
+          </a:prstGeom>
+          <a:noFill/>
+          <a:ln/>
+        </p:spPr>
+        <p:txBody>
+          <a:bodyPr wrap="square" lIns="0" tIns="0" rIns="0" bIns="0" rtlCol="0" anchor="ctr"/>
+          <a:lstStyle/>
+          <a:p>
+            <a:pPr indent="0" marL="0">
+              <a:buNone/>
+            </a:pPr>
+            <a:r>
+              <a:rPr lang="en-US" sz="1250" b="1" dirty="0">
                 <a:solidFill>
                   <a:srgbClr val="1A1F26"/>
                 </a:solidFill>
@@ -8505,109 +9400,11 @@
                 <a:ea typeface="Calibri" pitchFamily="34" charset="-122"/>
                 <a:cs typeface="Calibri" pitchFamily="34" charset="-120"/>
               </a:rPr>
-              <a:t>4</a:t>
-            </a:r>
-            <a:endParaRPr lang="en-US" sz="1300" dirty="0"/>
-          </a:p>
-        </p:txBody>
-      </p:sp>
-      <p:sp>
-        <p:nvSpPr>
-          <p:cNvPr id="19" name="Text 17"/>
-          <p:cNvSpPr txBox="1"/>
-          <p:nvPr/>
-        </p:nvSpPr>
-        <p:spPr>
-          <a:xfrm>
-            <a:off x="1097280" y="4443984"/>
-            <a:ext cx="2926080" cy="457200"/>
-          </a:xfrm>
-          <a:prstGeom prst="rect">
-            <a:avLst/>
-          </a:prstGeom>
-          <a:noFill/>
-          <a:ln/>
-        </p:spPr>
-        <p:txBody>
-          <a:bodyPr wrap="square" lIns="0" tIns="0" rIns="0" bIns="0" rtlCol="0" anchor="t"/>
-          <a:lstStyle/>
-          <a:p>
-            <a:pPr indent="0" marL="0">
-              <a:buNone/>
-            </a:pPr>
-            <a:r>
-              <a:rPr lang="en-US" sz="1300" b="1" dirty="0">
-                <a:solidFill>
-                  <a:srgbClr val="FFFFFF"/>
-                </a:solidFill>
-                <a:latin typeface="Calibri" pitchFamily="34" charset="0"/>
-                <a:ea typeface="Calibri" pitchFamily="34" charset="-122"/>
-                <a:cs typeface="Calibri" pitchFamily="34" charset="-120"/>
-              </a:rPr>
-              <a:t>告知する</a:t>
-            </a:r>
-            <a:endParaRPr lang="en-US" sz="1300" dirty="0"/>
-          </a:p>
-        </p:txBody>
-      </p:sp>
-      <p:sp>
-        <p:nvSpPr>
-          <p:cNvPr id="20" name="Text 18"/>
-          <p:cNvSpPr txBox="1"/>
-          <p:nvPr/>
-        </p:nvSpPr>
-        <p:spPr>
-          <a:xfrm>
-            <a:off x="4114800" y="4443984"/>
-            <a:ext cx="6858000" cy="777240"/>
-          </a:xfrm>
-          <a:prstGeom prst="rect">
-            <a:avLst/>
-          </a:prstGeom>
-          <a:noFill/>
-          <a:ln/>
-        </p:spPr>
-        <p:txBody>
-          <a:bodyPr wrap="square" lIns="0" tIns="0" rIns="0" bIns="0" rtlCol="0" anchor="ctr"/>
-          <a:lstStyle/>
-          <a:p>
-            <a:pPr indent="0" marL="0">
-              <a:buNone/>
-            </a:pPr>
-            <a:r>
-              <a:rPr lang="en-US" sz="1150" dirty="0">
-                <a:solidFill>
-                  <a:srgbClr val="AEB7C4"/>
-                </a:solidFill>
-                <a:latin typeface="Calibri" pitchFamily="34" charset="0"/>
-                <a:ea typeface="Calibri" pitchFamily="34" charset="-122"/>
-                <a:cs typeface="Calibri" pitchFamily="34" charset="-120"/>
-              </a:rPr>
-              <a:t>Product Hunt・Zenn・Qiita・Dev.to等で公開を告知する。ただし効果は一時的(数日)</a:t>
-            </a:r>
-            <a:endParaRPr lang="en-US" sz="1150" dirty="0"/>
-          </a:p>
-        </p:txBody>
-      </p:sp>
-      <p:sp>
-        <p:nvSpPr>
-          <p:cNvPr id="21" name="Shape 19"/>
-          <p:cNvSpPr/>
-          <p:nvPr/>
-        </p:nvSpPr>
-        <p:spPr>
-          <a:xfrm>
-            <a:off x="548640" y="5330952"/>
-            <a:ext cx="384048" cy="384048"/>
-          </a:xfrm>
-          <a:prstGeom prst="ellipse">
-            <a:avLst/>
-          </a:prstGeom>
-          <a:solidFill>
-            <a:srgbClr val="58D68D"/>
-          </a:solidFill>
-          <a:ln/>
-        </p:spPr>
+              <a:t>Awesomeリストへの追加PR</a:t>
+            </a:r>
+            <a:endParaRPr lang="en-US" sz="1250" dirty="0"/>
+          </a:p>
+        </p:txBody>
       </p:sp>
       <p:sp>
         <p:nvSpPr>
@@ -8617,24 +9414,63 @@
         </p:nvSpPr>
         <p:spPr>
           <a:xfrm>
-            <a:off x="548640" y="5330952"/>
-            <a:ext cx="384048" cy="384048"/>
-          </a:xfrm>
-          <a:prstGeom prst="rect">
-            <a:avLst/>
-          </a:prstGeom>
-          <a:noFill/>
-          <a:ln/>
-        </p:spPr>
-        <p:txBody>
-          <a:bodyPr wrap="square" lIns="0" tIns="0" rIns="0" bIns="0" rtlCol="0" anchor="ctr"/>
-          <a:lstStyle/>
-          <a:p>
-            <a:pPr algn="ctr" indent="0" marL="0">
-              <a:buNone/>
-            </a:pPr>
-            <a:r>
-              <a:rPr lang="en-US" sz="1300" b="1" dirty="0">
+            <a:off x="6309360" y="4480560"/>
+            <a:ext cx="4663440" cy="640080"/>
+          </a:xfrm>
+          <a:prstGeom prst="rect">
+            <a:avLst/>
+          </a:prstGeom>
+          <a:noFill/>
+          <a:ln/>
+        </p:spPr>
+        <p:txBody>
+          <a:bodyPr wrap="square" lIns="0" tIns="0" rIns="0" bIns="0" rtlCol="0" anchor="ctr"/>
+          <a:lstStyle/>
+          <a:p>
+            <a:pPr indent="0" marL="0">
+              <a:buNone/>
+            </a:pPr>
+            <a:r>
+              <a:rPr lang="en-US" sz="1050" dirty="0">
+                <a:solidFill>
+                  <a:srgbClr val="5B6472"/>
+                </a:solidFill>
+                <a:latin typeface="Calibri" pitchFamily="34" charset="0"/>
+                <a:ea typeface="Calibri" pitchFamily="34" charset="-122"/>
+                <a:cs typeface="Calibri" pitchFamily="34" charset="-120"/>
+              </a:rPr>
+              <a:t>掲載されても閲覧者自体が少ない</a:t>
+            </a:r>
+            <a:endParaRPr lang="en-US" sz="1050" dirty="0"/>
+          </a:p>
+        </p:txBody>
+      </p:sp>
+      <p:sp>
+        <p:nvSpPr>
+          <p:cNvPr id="23" name="Text 21"/>
+          <p:cNvSpPr txBox="1"/>
+          <p:nvPr/>
+        </p:nvSpPr>
+        <p:spPr>
+          <a:xfrm>
+            <a:off x="6309360" y="5029200"/>
+            <a:ext cx="4663440" cy="274320"/>
+          </a:xfrm>
+          <a:prstGeom prst="rect">
+            <a:avLst/>
+          </a:prstGeom>
+          <a:noFill/>
+          <a:ln/>
+        </p:spPr>
+        <p:txBody>
+          <a:bodyPr wrap="square" lIns="0" tIns="0" rIns="0" bIns="0" rtlCol="0" anchor="ctr"/>
+          <a:lstStyle/>
+          <a:p>
+            <a:pPr indent="0" marL="0">
+              <a:buNone/>
+            </a:pPr>
+            <a:r>
+              <a:rPr lang="en-US" sz="1250" b="1" dirty="0">
                 <a:solidFill>
                   <a:srgbClr val="1A1F26"/>
                 </a:solidFill>
@@ -8642,48 +9478,9 @@
                 <a:ea typeface="Calibri" pitchFamily="34" charset="-122"/>
                 <a:cs typeface="Calibri" pitchFamily="34" charset="-120"/>
               </a:rPr>
-              <a:t>5</a:t>
-            </a:r>
-            <a:endParaRPr lang="en-US" sz="1300" dirty="0"/>
-          </a:p>
-        </p:txBody>
-      </p:sp>
-      <p:sp>
-        <p:nvSpPr>
-          <p:cNvPr id="23" name="Text 21"/>
-          <p:cNvSpPr txBox="1"/>
-          <p:nvPr/>
-        </p:nvSpPr>
-        <p:spPr>
-          <a:xfrm>
-            <a:off x="1097280" y="5285232"/>
-            <a:ext cx="2926080" cy="457200"/>
-          </a:xfrm>
-          <a:prstGeom prst="rect">
-            <a:avLst/>
-          </a:prstGeom>
-          <a:noFill/>
-          <a:ln/>
-        </p:spPr>
-        <p:txBody>
-          <a:bodyPr wrap="square" lIns="0" tIns="0" rIns="0" bIns="0" rtlCol="0" anchor="t"/>
-          <a:lstStyle/>
-          <a:p>
-            <a:pPr indent="0" marL="0">
-              <a:buNone/>
-            </a:pPr>
-            <a:r>
-              <a:rPr lang="en-US" sz="1300" b="1" dirty="0">
-                <a:solidFill>
-                  <a:srgbClr val="FFFFFF"/>
-                </a:solidFill>
-                <a:latin typeface="Calibri" pitchFamily="34" charset="0"/>
-                <a:ea typeface="Calibri" pitchFamily="34" charset="-122"/>
-                <a:cs typeface="Calibri" pitchFamily="34" charset="-120"/>
-              </a:rPr>
-              <a:t>検索される記事を作る</a:t>
-            </a:r>
-            <a:endParaRPr lang="en-US" sz="1300" dirty="0"/>
+              <a:t>個人ブログ</a:t>
+            </a:r>
+            <a:endParaRPr lang="en-US" sz="1250" dirty="0"/>
           </a:p>
         </p:txBody>
       </p:sp>
@@ -8695,34 +9492,34 @@
         </p:nvSpPr>
         <p:spPr>
           <a:xfrm>
-            <a:off x="4114800" y="5285232"/>
-            <a:ext cx="6858000" cy="777240"/>
-          </a:xfrm>
-          <a:prstGeom prst="rect">
-            <a:avLst/>
-          </a:prstGeom>
-          <a:noFill/>
-          <a:ln/>
-        </p:spPr>
-        <p:txBody>
-          <a:bodyPr wrap="square" lIns="0" tIns="0" rIns="0" bIns="0" rtlCol="0" anchor="ctr"/>
-          <a:lstStyle/>
-          <a:p>
-            <a:pPr indent="0" marL="0">
-              <a:buNone/>
-            </a:pPr>
-            <a:r>
-              <a:rPr lang="en-US" sz="1150" dirty="0">
-                <a:solidFill>
-                  <a:srgbClr val="AEB7C4"/>
-                </a:solidFill>
-                <a:latin typeface="Calibri" pitchFamily="34" charset="0"/>
-                <a:ea typeface="Calibri" pitchFamily="34" charset="-122"/>
-                <a:cs typeface="Calibri" pitchFamily="34" charset="-120"/>
-              </a:rPr>
-              <a:t>想定ユーザーが検索するキーワードでブログ記事を書く。即効性は無いが継続的な流入源になる</a:t>
-            </a:r>
-            <a:endParaRPr lang="en-US" sz="1150" dirty="0"/>
+            <a:off x="6309360" y="5303520"/>
+            <a:ext cx="4663440" cy="640080"/>
+          </a:xfrm>
+          <a:prstGeom prst="rect">
+            <a:avLst/>
+          </a:prstGeom>
+          <a:noFill/>
+          <a:ln/>
+        </p:spPr>
+        <p:txBody>
+          <a:bodyPr wrap="square" lIns="0" tIns="0" rIns="0" bIns="0" rtlCol="0" anchor="ctr"/>
+          <a:lstStyle/>
+          <a:p>
+            <a:pPr indent="0" marL="0">
+              <a:buNone/>
+            </a:pPr>
+            <a:r>
+              <a:rPr lang="en-US" sz="1050" dirty="0">
+                <a:solidFill>
+                  <a:srgbClr val="5B6472"/>
+                </a:solidFill>
+                <a:latin typeface="Calibri" pitchFamily="34" charset="0"/>
+                <a:ea typeface="Calibri" pitchFamily="34" charset="-122"/>
+                <a:cs typeface="Calibri" pitchFamily="34" charset="-120"/>
+              </a:rPr>
+              <a:t>Qiita/Zenn等の媒体力があるプラットフォームでないと、Twitter投稿とあまり変わらない手応え</a:t>
+            </a:r>
+            <a:endParaRPr lang="en-US" sz="1050" dirty="0"/>
           </a:p>
         </p:txBody>
       </p:sp>
@@ -8753,13 +9550,13 @@
             <a:r>
               <a:rPr lang="en-US" sz="1000" i="1" dirty="0">
                 <a:solidFill>
-                  <a:srgbClr val="AEB7C4"/>
-                </a:solidFill>
-                <a:latin typeface="Calibri" pitchFamily="34" charset="0"/>
-                <a:ea typeface="Calibri" pitchFamily="34" charset="-122"/>
-                <a:cs typeface="Calibri" pitchFamily="34" charset="-120"/>
-              </a:rPr>
-              <a:t>出典: npmのPDF作成ライブラリ(labelmake)の開発者によるブログ記事(1事例の実体験)</a:t>
+                  <a:srgbClr val="5B6472"/>
+                </a:solidFill>
+                <a:latin typeface="Calibri" pitchFamily="34" charset="0"/>
+                <a:ea typeface="Calibri" pitchFamily="34" charset="-122"/>
+                <a:cs typeface="Calibri" pitchFamily="34" charset="-120"/>
+              </a:rPr>
+              <a:t>出典: 個人開発者によるOSSプロジェクト「Ephe」のブログ記事(1事例の実測値。分野・タイミングにより結果は変動しうる)</a:t>
             </a:r>
             <a:endParaRPr lang="en-US" sz="1000" dirty="0"/>
           </a:p>

</xml_diff>

<commit_message>
Add practical Hacker News how-to steps to GitHub strategy guide
Adds account creation, /newest, Show HN submission, and karma notes
as a hands-on follow-up to the channel effectiveness case study.

Co-Authored-By: Claude Sonnet 5 <noreply@anthropic.com>
Claude-Session: https://claude.ai/code/session_011KHa4MUwNn3SuV95WoncKQ
</commit_message>
<xml_diff>
--- a/github-strategy-guide.pptx
+++ b/github-strategy-guide.pptx
@@ -17,9 +17,10 @@
     <p:sldId id="265" r:id="rId11"/>
     <p:sldId id="266" r:id="rId12"/>
     <p:sldId id="267" r:id="rId13"/>
+    <p:sldId id="268" r:id="rId14"/>
   </p:sldIdLst>
   <p:notesMasterIdLst>
-    <p:notesMasterId r:id="rId14"/>
+    <p:notesMasterId r:id="rId15"/>
   </p:notesMasterIdLst>
   <p:sldSz cx="12192000" cy="6858000"/>
   <p:notesSz cx="6858000" cy="12192000"/>
@@ -801,6 +802,94 @@
             <a:fld id="{F7021451-1387-4CA6-816F-3879F97B5CBC}" type="slidenum">
               <a:rPr lang="en-US"/>
               <a:t>12</a:t>
+            </a:fld>
+            <a:endParaRPr lang="en-US"/>
+          </a:p>
+        </p:txBody>
+      </p:sp>
+    </p:spTree>
+    <p:extLst>
+      <p:ext uri="{BB962C8B-B14F-4D97-AF65-F5344CB8AC3E}">
+        <p14:creationId xmlns:p14="http://schemas.microsoft.com/office/powerpoint/2010/main" val="1024086991"/>
+      </p:ext>
+    </p:extLst>
+  </p:cSld>
+  <p:clrMapOvr>
+    <a:masterClrMapping/>
+  </p:clrMapOvr>
+</p:notes>
+</file>
+
+<file path=ppt/notesSlides/notesSlide13.xml><?xml version="1.0" encoding="utf-8"?>
+<p:notes xmlns:a="http://schemas.openxmlformats.org/drawingml/2006/main" xmlns:r="http://schemas.openxmlformats.org/officeDocument/2006/relationships" xmlns:p="http://schemas.openxmlformats.org/presentationml/2006/main">
+  <p:cSld>
+    <p:spTree>
+      <p:nvGrpSpPr>
+        <p:cNvPr id="1" name=""/>
+        <p:cNvGrpSpPr/>
+        <p:nvPr/>
+      </p:nvGrpSpPr>
+      <p:grpSpPr>
+        <a:xfrm>
+          <a:off x="0" y="0"/>
+          <a:ext cx="0" cy="0"/>
+          <a:chOff x="0" y="0"/>
+          <a:chExt cx="0" cy="0"/>
+        </a:xfrm>
+      </p:grpSpPr>
+      <p:sp>
+        <p:nvSpPr>
+          <p:cNvPr id="2" name="Slide Image Placeholder 1"/>
+          <p:cNvSpPr>
+            <a:spLocks noGrp="1" noRot="1" noChangeAspect="1"/>
+          </p:cNvSpPr>
+          <p:nvPr>
+            <p:ph type="sldImg"/>
+          </p:nvPr>
+        </p:nvSpPr>
+        <p:spPr/>
+      </p:sp>
+      <p:sp>
+        <p:nvSpPr>
+          <p:cNvPr id="3" name="Notes Placeholder 2"/>
+          <p:cNvSpPr>
+            <a:spLocks noGrp="1"/>
+          </p:cNvSpPr>
+          <p:nvPr>
+            <p:ph type="body" idx="1"/>
+          </p:nvPr>
+        </p:nvSpPr>
+        <p:spPr/>
+        <p:txBody>
+          <a:bodyPr/>
+          <a:lstStyle/>
+          <a:p>
+            <a:r>
+              <a:rPr lang="en-US" dirty="0"/>
+              <a:t/>
+            </a:r>
+            <a:endParaRPr lang="en-US" dirty="0"/>
+          </a:p>
+        </p:txBody>
+      </p:sp>
+      <p:sp>
+        <p:nvSpPr>
+          <p:cNvPr id="4" name="Slide Number Placeholder 3"/>
+          <p:cNvSpPr>
+            <a:spLocks noGrp="1"/>
+          </p:cNvSpPr>
+          <p:nvPr>
+            <p:ph type="sldNum" sz="quarter" idx="10"/>
+          </p:nvPr>
+        </p:nvSpPr>
+        <p:spPr/>
+        <p:txBody>
+          <a:bodyPr/>
+          <a:lstStyle/>
+          <a:p>
+            <a:fld id="{F7021451-1387-4CA6-816F-3879F97B5CBC}" type="slidenum">
+              <a:rPr lang="en-US"/>
+              <a:t>13</a:t>
             </a:fld>
             <a:endParaRPr lang="en-US"/>
           </a:p>
@@ -2980,6 +3069,692 @@
     <p:bg>
       <p:bgPr>
         <a:solidFill>
+          <a:srgbClr val="F5F6F8"/>
+        </a:solidFill>
+      </p:bgPr>
+    </p:bg>
+    <p:spTree>
+      <p:nvGrpSpPr>
+        <p:cNvPr id="1" name=""/>
+        <p:cNvGrpSpPr/>
+        <p:nvPr/>
+      </p:nvGrpSpPr>
+      <p:grpSpPr>
+        <a:xfrm>
+          <a:off x="0" y="0"/>
+          <a:ext cx="0" cy="0"/>
+          <a:chOff x="0" y="0"/>
+          <a:chExt cx="0" cy="0"/>
+        </a:xfrm>
+      </p:grpSpPr>
+      <p:sp>
+        <p:nvSpPr>
+          <p:cNvPr id="2" name="Text 0"/>
+          <p:cNvSpPr txBox="1"/>
+          <p:nvPr/>
+        </p:nvSpPr>
+        <p:spPr>
+          <a:xfrm>
+            <a:off x="548640" y="457200"/>
+            <a:ext cx="731520" cy="731520"/>
+          </a:xfrm>
+          <a:prstGeom prst="rect">
+            <a:avLst/>
+          </a:prstGeom>
+          <a:noFill/>
+          <a:ln/>
+        </p:spPr>
+        <p:txBody>
+          <a:bodyPr wrap="square" lIns="0" tIns="0" rIns="0" bIns="0" rtlCol="0" anchor="ctr"/>
+          <a:lstStyle/>
+          <a:p>
+            <a:pPr indent="0" marL="0">
+              <a:buNone/>
+            </a:pPr>
+            <a:r>
+              <a:rPr lang="en-US" sz="2800" b="1" dirty="0">
+                <a:solidFill>
+                  <a:srgbClr val="B084F5"/>
+                </a:solidFill>
+                <a:latin typeface="Cambria" pitchFamily="34" charset="0"/>
+                <a:ea typeface="Cambria" pitchFamily="34" charset="-122"/>
+                <a:cs typeface="Cambria" pitchFamily="34" charset="-120"/>
+              </a:rPr>
+              <a:t>5</a:t>
+            </a:r>
+            <a:endParaRPr lang="en-US" sz="2800" dirty="0"/>
+          </a:p>
+        </p:txBody>
+      </p:sp>
+      <p:sp>
+        <p:nvSpPr>
+          <p:cNvPr id="3" name="Text 1"/>
+          <p:cNvSpPr txBox="1"/>
+          <p:nvPr/>
+        </p:nvSpPr>
+        <p:spPr>
+          <a:xfrm>
+            <a:off x="1280160" y="502920"/>
+            <a:ext cx="9784080" cy="640080"/>
+          </a:xfrm>
+          <a:prstGeom prst="rect">
+            <a:avLst/>
+          </a:prstGeom>
+          <a:noFill/>
+          <a:ln/>
+        </p:spPr>
+        <p:txBody>
+          <a:bodyPr wrap="square" lIns="0" tIns="0" rIns="0" bIns="0" rtlCol="0" anchor="ctr"/>
+          <a:lstStyle/>
+          <a:p>
+            <a:pPr indent="0" marL="0">
+              <a:buNone/>
+            </a:pPr>
+            <a:r>
+              <a:rPr lang="en-US" sz="2600" b="1" dirty="0">
+                <a:solidFill>
+                  <a:srgbClr val="1A1F26"/>
+                </a:solidFill>
+                <a:latin typeface="Cambria" pitchFamily="34" charset="0"/>
+                <a:ea typeface="Cambria" pitchFamily="34" charset="-122"/>
+                <a:cs typeface="Cambria" pitchFamily="34" charset="-120"/>
+              </a:rPr>
+              <a:t>実践手順: Hacker Newsの使い方</a:t>
+            </a:r>
+            <a:endParaRPr lang="en-US" sz="2600" dirty="0"/>
+          </a:p>
+        </p:txBody>
+      </p:sp>
+      <p:sp>
+        <p:nvSpPr>
+          <p:cNvPr id="4" name="Text 2"/>
+          <p:cNvSpPr txBox="1"/>
+          <p:nvPr/>
+        </p:nvSpPr>
+        <p:spPr>
+          <a:xfrm>
+            <a:off x="548640" y="1417320"/>
+            <a:ext cx="10607040" cy="365760"/>
+          </a:xfrm>
+          <a:prstGeom prst="rect">
+            <a:avLst/>
+          </a:prstGeom>
+          <a:noFill/>
+          <a:ln/>
+        </p:spPr>
+        <p:txBody>
+          <a:bodyPr wrap="square" lIns="0" tIns="0" rIns="0" bIns="0" rtlCol="0" anchor="ctr"/>
+          <a:lstStyle/>
+          <a:p>
+            <a:pPr indent="0" marL="0">
+              <a:buNone/>
+            </a:pPr>
+            <a:r>
+              <a:rPr lang="en-US" sz="1250" i="1" dirty="0">
+                <a:solidFill>
+                  <a:srgbClr val="5B6472"/>
+                </a:solidFill>
+                <a:latin typeface="Calibri" pitchFamily="34" charset="0"/>
+                <a:ea typeface="Calibri" pitchFamily="34" charset="-122"/>
+                <a:cs typeface="Calibri" pitchFamily="34" charset="-120"/>
+              </a:rPr>
+              <a:t>最も効果があったチャネル(HN)を、実際にどう使うか</a:t>
+            </a:r>
+            <a:endParaRPr lang="en-US" sz="1250" dirty="0"/>
+          </a:p>
+        </p:txBody>
+      </p:sp>
+      <p:sp>
+        <p:nvSpPr>
+          <p:cNvPr id="5" name="Shape 3"/>
+          <p:cNvSpPr/>
+          <p:nvPr/>
+        </p:nvSpPr>
+        <p:spPr>
+          <a:xfrm>
+            <a:off x="548640" y="1920240"/>
+            <a:ext cx="10607040" cy="914400"/>
+          </a:xfrm>
+          <a:prstGeom prst="roundRect">
+            <a:avLst>
+              <a:gd name="adj" fmla="val 8000"/>
+            </a:avLst>
+          </a:prstGeom>
+          <a:solidFill>
+            <a:srgbClr val="FFFFFF"/>
+          </a:solidFill>
+          <a:ln w="12700">
+            <a:solidFill>
+              <a:srgbClr val="E3E6EA"/>
+            </a:solidFill>
+            <a:prstDash val="solid"/>
+          </a:ln>
+        </p:spPr>
+      </p:sp>
+      <p:sp>
+        <p:nvSpPr>
+          <p:cNvPr id="6" name="Text 4"/>
+          <p:cNvSpPr txBox="1"/>
+          <p:nvPr/>
+        </p:nvSpPr>
+        <p:spPr>
+          <a:xfrm>
+            <a:off x="822960" y="2039112"/>
+            <a:ext cx="2834640" cy="640080"/>
+          </a:xfrm>
+          <a:prstGeom prst="rect">
+            <a:avLst/>
+          </a:prstGeom>
+          <a:noFill/>
+          <a:ln/>
+        </p:spPr>
+        <p:txBody>
+          <a:bodyPr wrap="square" lIns="0" tIns="0" rIns="0" bIns="0" rtlCol="0" anchor="t"/>
+          <a:lstStyle/>
+          <a:p>
+            <a:pPr indent="0" marL="0">
+              <a:buNone/>
+            </a:pPr>
+            <a:r>
+              <a:rPr lang="en-US" sz="1350" b="1" dirty="0">
+                <a:solidFill>
+                  <a:srgbClr val="B084F5"/>
+                </a:solidFill>
+                <a:latin typeface="Calibri" pitchFamily="34" charset="0"/>
+                <a:ea typeface="Calibri" pitchFamily="34" charset="-122"/>
+                <a:cs typeface="Calibri" pitchFamily="34" charset="-120"/>
+              </a:rPr>
+              <a:t>① アカウント作成</a:t>
+            </a:r>
+            <a:endParaRPr lang="en-US" sz="1350" dirty="0"/>
+          </a:p>
+        </p:txBody>
+      </p:sp>
+      <p:sp>
+        <p:nvSpPr>
+          <p:cNvPr id="7" name="Text 5"/>
+          <p:cNvSpPr txBox="1"/>
+          <p:nvPr/>
+        </p:nvSpPr>
+        <p:spPr>
+          <a:xfrm>
+            <a:off x="3749040" y="2039112"/>
+            <a:ext cx="7315200" cy="685800"/>
+          </a:xfrm>
+          <a:prstGeom prst="rect">
+            <a:avLst/>
+          </a:prstGeom>
+          <a:noFill/>
+          <a:ln/>
+        </p:spPr>
+        <p:txBody>
+          <a:bodyPr wrap="square" lIns="0" tIns="0" rIns="0" bIns="0" rtlCol="0" anchor="ctr"/>
+          <a:lstStyle/>
+          <a:p>
+            <a:pPr indent="0" marL="0">
+              <a:buNone/>
+            </a:pPr>
+            <a:r>
+              <a:rPr lang="en-US" sz="1150" dirty="0">
+                <a:solidFill>
+                  <a:srgbClr val="5B6472"/>
+                </a:solidFill>
+                <a:latin typeface="Calibri" pitchFamily="34" charset="0"/>
+                <a:ea typeface="Calibri" pitchFamily="34" charset="-122"/>
+                <a:cs typeface="Calibri" pitchFamily="34" charset="-120"/>
+              </a:rPr>
+              <a:t>news.ycombinator.com/login → 「Create Account」。ユーザー名とパスワードのみ、メール登録不要</a:t>
+            </a:r>
+            <a:endParaRPr lang="en-US" sz="1150" dirty="0"/>
+          </a:p>
+        </p:txBody>
+      </p:sp>
+      <p:sp>
+        <p:nvSpPr>
+          <p:cNvPr id="8" name="Shape 6"/>
+          <p:cNvSpPr/>
+          <p:nvPr/>
+        </p:nvSpPr>
+        <p:spPr>
+          <a:xfrm>
+            <a:off x="548640" y="2971800"/>
+            <a:ext cx="10607040" cy="914400"/>
+          </a:xfrm>
+          <a:prstGeom prst="roundRect">
+            <a:avLst>
+              <a:gd name="adj" fmla="val 8000"/>
+            </a:avLst>
+          </a:prstGeom>
+          <a:solidFill>
+            <a:srgbClr val="FFFFFF"/>
+          </a:solidFill>
+          <a:ln w="12700">
+            <a:solidFill>
+              <a:srgbClr val="E3E6EA"/>
+            </a:solidFill>
+            <a:prstDash val="solid"/>
+          </a:ln>
+        </p:spPr>
+      </p:sp>
+      <p:sp>
+        <p:nvSpPr>
+          <p:cNvPr id="9" name="Text 7"/>
+          <p:cNvSpPr txBox="1"/>
+          <p:nvPr/>
+        </p:nvSpPr>
+        <p:spPr>
+          <a:xfrm>
+            <a:off x="822960" y="3090672"/>
+            <a:ext cx="2834640" cy="640080"/>
+          </a:xfrm>
+          <a:prstGeom prst="rect">
+            <a:avLst/>
+          </a:prstGeom>
+          <a:noFill/>
+          <a:ln/>
+        </p:spPr>
+        <p:txBody>
+          <a:bodyPr wrap="square" lIns="0" tIns="0" rIns="0" bIns="0" rtlCol="0" anchor="t"/>
+          <a:lstStyle/>
+          <a:p>
+            <a:pPr indent="0" marL="0">
+              <a:buNone/>
+            </a:pPr>
+            <a:r>
+              <a:rPr lang="en-US" sz="1350" b="1" dirty="0">
+                <a:solidFill>
+                  <a:srgbClr val="B084F5"/>
+                </a:solidFill>
+                <a:latin typeface="Calibri" pitchFamily="34" charset="0"/>
+                <a:ea typeface="Calibri" pitchFamily="34" charset="-122"/>
+                <a:cs typeface="Calibri" pitchFamily="34" charset="-120"/>
+              </a:rPr>
+              <a:t>② /newest を理解する</a:t>
+            </a:r>
+            <a:endParaRPr lang="en-US" sz="1350" dirty="0"/>
+          </a:p>
+        </p:txBody>
+      </p:sp>
+      <p:sp>
+        <p:nvSpPr>
+          <p:cNvPr id="10" name="Text 8"/>
+          <p:cNvSpPr txBox="1"/>
+          <p:nvPr/>
+        </p:nvSpPr>
+        <p:spPr>
+          <a:xfrm>
+            <a:off x="3749040" y="3090672"/>
+            <a:ext cx="7315200" cy="685800"/>
+          </a:xfrm>
+          <a:prstGeom prst="rect">
+            <a:avLst/>
+          </a:prstGeom>
+          <a:noFill/>
+          <a:ln/>
+        </p:spPr>
+        <p:txBody>
+          <a:bodyPr wrap="square" lIns="0" tIns="0" rIns="0" bIns="0" rtlCol="0" anchor="ctr"/>
+          <a:lstStyle/>
+          <a:p>
+            <a:pPr indent="0" marL="0">
+              <a:buNone/>
+            </a:pPr>
+            <a:r>
+              <a:rPr lang="en-US" sz="1150" dirty="0">
+                <a:solidFill>
+                  <a:srgbClr val="5B6472"/>
+                </a:solidFill>
+                <a:latin typeface="Calibri" pitchFamily="34" charset="0"/>
+                <a:ea typeface="Calibri" pitchFamily="34" charset="-122"/>
+                <a:cs typeface="Calibri" pitchFamily="34" charset="-120"/>
+              </a:rPr>
+              <a:t>news.ycombinator.com/newest は投稿順の新着一覧。ここでUpvoteを集めるとアルゴリズムでトップページ側へ浮上する</a:t>
+            </a:r>
+            <a:endParaRPr lang="en-US" sz="1150" dirty="0"/>
+          </a:p>
+        </p:txBody>
+      </p:sp>
+      <p:sp>
+        <p:nvSpPr>
+          <p:cNvPr id="11" name="Shape 9"/>
+          <p:cNvSpPr/>
+          <p:nvPr/>
+        </p:nvSpPr>
+        <p:spPr>
+          <a:xfrm>
+            <a:off x="548640" y="4023360"/>
+            <a:ext cx="10607040" cy="914400"/>
+          </a:xfrm>
+          <a:prstGeom prst="roundRect">
+            <a:avLst>
+              <a:gd name="adj" fmla="val 8000"/>
+            </a:avLst>
+          </a:prstGeom>
+          <a:solidFill>
+            <a:srgbClr val="FFFFFF"/>
+          </a:solidFill>
+          <a:ln w="12700">
+            <a:solidFill>
+              <a:srgbClr val="E3E6EA"/>
+            </a:solidFill>
+            <a:prstDash val="solid"/>
+          </a:ln>
+        </p:spPr>
+      </p:sp>
+      <p:sp>
+        <p:nvSpPr>
+          <p:cNvPr id="12" name="Text 10"/>
+          <p:cNvSpPr txBox="1"/>
+          <p:nvPr/>
+        </p:nvSpPr>
+        <p:spPr>
+          <a:xfrm>
+            <a:off x="822960" y="4142232"/>
+            <a:ext cx="2834640" cy="640080"/>
+          </a:xfrm>
+          <a:prstGeom prst="rect">
+            <a:avLst/>
+          </a:prstGeom>
+          <a:noFill/>
+          <a:ln/>
+        </p:spPr>
+        <p:txBody>
+          <a:bodyPr wrap="square" lIns="0" tIns="0" rIns="0" bIns="0" rtlCol="0" anchor="t"/>
+          <a:lstStyle/>
+          <a:p>
+            <a:pPr indent="0" marL="0">
+              <a:buNone/>
+            </a:pPr>
+            <a:r>
+              <a:rPr lang="en-US" sz="1350" b="1" dirty="0">
+                <a:solidFill>
+                  <a:srgbClr val="B084F5"/>
+                </a:solidFill>
+                <a:latin typeface="Calibri" pitchFamily="34" charset="0"/>
+                <a:ea typeface="Calibri" pitchFamily="34" charset="-122"/>
+                <a:cs typeface="Calibri" pitchFamily="34" charset="-120"/>
+              </a:rPr>
+              <a:t>③ Show HN: で投稿する</a:t>
+            </a:r>
+            <a:endParaRPr lang="en-US" sz="1350" dirty="0"/>
+          </a:p>
+        </p:txBody>
+      </p:sp>
+      <p:sp>
+        <p:nvSpPr>
+          <p:cNvPr id="13" name="Text 11"/>
+          <p:cNvSpPr txBox="1"/>
+          <p:nvPr/>
+        </p:nvSpPr>
+        <p:spPr>
+          <a:xfrm>
+            <a:off x="3749040" y="4142232"/>
+            <a:ext cx="7315200" cy="685800"/>
+          </a:xfrm>
+          <a:prstGeom prst="rect">
+            <a:avLst/>
+          </a:prstGeom>
+          <a:noFill/>
+          <a:ln/>
+        </p:spPr>
+        <p:txBody>
+          <a:bodyPr wrap="square" lIns="0" tIns="0" rIns="0" bIns="0" rtlCol="0" anchor="ctr"/>
+          <a:lstStyle/>
+          <a:p>
+            <a:pPr indent="0" marL="0">
+              <a:buNone/>
+            </a:pPr>
+            <a:r>
+              <a:rPr lang="en-US" sz="1150" dirty="0">
+                <a:solidFill>
+                  <a:srgbClr val="5B6472"/>
+                </a:solidFill>
+                <a:latin typeface="Calibri" pitchFamily="34" charset="0"/>
+                <a:ea typeface="Calibri" pitchFamily="34" charset="-122"/>
+                <a:cs typeface="Calibri" pitchFamily="34" charset="-120"/>
+              </a:rPr>
+              <a:t>submitページでタイトル先頭に「Show HN: 」を付けると、自作ツール専用の Show タブにも掲載される</a:t>
+            </a:r>
+            <a:endParaRPr lang="en-US" sz="1150" dirty="0"/>
+          </a:p>
+        </p:txBody>
+      </p:sp>
+      <p:sp>
+        <p:nvSpPr>
+          <p:cNvPr id="14" name="Shape 12"/>
+          <p:cNvSpPr/>
+          <p:nvPr/>
+        </p:nvSpPr>
+        <p:spPr>
+          <a:xfrm>
+            <a:off x="548640" y="5074920"/>
+            <a:ext cx="10607040" cy="914400"/>
+          </a:xfrm>
+          <a:prstGeom prst="roundRect">
+            <a:avLst>
+              <a:gd name="adj" fmla="val 8000"/>
+            </a:avLst>
+          </a:prstGeom>
+          <a:solidFill>
+            <a:srgbClr val="FFFFFF"/>
+          </a:solidFill>
+          <a:ln w="12700">
+            <a:solidFill>
+              <a:srgbClr val="E3E6EA"/>
+            </a:solidFill>
+            <a:prstDash val="solid"/>
+          </a:ln>
+        </p:spPr>
+      </p:sp>
+      <p:sp>
+        <p:nvSpPr>
+          <p:cNvPr id="15" name="Text 13"/>
+          <p:cNvSpPr txBox="1"/>
+          <p:nvPr/>
+        </p:nvSpPr>
+        <p:spPr>
+          <a:xfrm>
+            <a:off x="822960" y="5193792"/>
+            <a:ext cx="2834640" cy="640080"/>
+          </a:xfrm>
+          <a:prstGeom prst="rect">
+            <a:avLst/>
+          </a:prstGeom>
+          <a:noFill/>
+          <a:ln/>
+        </p:spPr>
+        <p:txBody>
+          <a:bodyPr wrap="square" lIns="0" tIns="0" rIns="0" bIns="0" rtlCol="0" anchor="t"/>
+          <a:lstStyle/>
+          <a:p>
+            <a:pPr indent="0" marL="0">
+              <a:buNone/>
+            </a:pPr>
+            <a:r>
+              <a:rPr lang="en-US" sz="1350" b="1" dirty="0">
+                <a:solidFill>
+                  <a:srgbClr val="B084F5"/>
+                </a:solidFill>
+                <a:latin typeface="Calibri" pitchFamily="34" charset="0"/>
+                <a:ea typeface="Calibri" pitchFamily="34" charset="-122"/>
+                <a:cs typeface="Calibri" pitchFamily="34" charset="-120"/>
+              </a:rPr>
+              <a:t>④ Karma(信頼度)を意識</a:t>
+            </a:r>
+            <a:endParaRPr lang="en-US" sz="1350" dirty="0"/>
+          </a:p>
+        </p:txBody>
+      </p:sp>
+      <p:sp>
+        <p:nvSpPr>
+          <p:cNvPr id="16" name="Text 14"/>
+          <p:cNvSpPr txBox="1"/>
+          <p:nvPr/>
+        </p:nvSpPr>
+        <p:spPr>
+          <a:xfrm>
+            <a:off x="3749040" y="5193792"/>
+            <a:ext cx="7315200" cy="685800"/>
+          </a:xfrm>
+          <a:prstGeom prst="rect">
+            <a:avLst/>
+          </a:prstGeom>
+          <a:noFill/>
+          <a:ln/>
+        </p:spPr>
+        <p:txBody>
+          <a:bodyPr wrap="square" lIns="0" tIns="0" rIns="0" bIns="0" rtlCol="0" anchor="ctr"/>
+          <a:lstStyle/>
+          <a:p>
+            <a:pPr indent="0" marL="0">
+              <a:buNone/>
+            </a:pPr>
+            <a:r>
+              <a:rPr lang="en-US" sz="1150" dirty="0">
+                <a:solidFill>
+                  <a:srgbClr val="5B6472"/>
+                </a:solidFill>
+                <a:latin typeface="Calibri" pitchFamily="34" charset="0"/>
+                <a:ea typeface="Calibri" pitchFamily="34" charset="-122"/>
+                <a:cs typeface="Calibri" pitchFamily="34" charset="-120"/>
+              </a:rPr>
+              <a:t>他人の投稿へのコメント・Upvoteで蓄積されるポイント制度。低いと表示・投稿頻度で不利になることがある</a:t>
+            </a:r>
+            <a:endParaRPr lang="en-US" sz="1150" dirty="0"/>
+          </a:p>
+        </p:txBody>
+      </p:sp>
+      <p:sp>
+        <p:nvSpPr>
+          <p:cNvPr id="17" name="Text 15"/>
+          <p:cNvSpPr txBox="1"/>
+          <p:nvPr/>
+        </p:nvSpPr>
+        <p:spPr>
+          <a:xfrm>
+            <a:off x="548640" y="5989320"/>
+            <a:ext cx="10607040" cy="365760"/>
+          </a:xfrm>
+          <a:prstGeom prst="rect">
+            <a:avLst/>
+          </a:prstGeom>
+          <a:noFill/>
+          <a:ln/>
+        </p:spPr>
+        <p:txBody>
+          <a:bodyPr wrap="square" lIns="0" tIns="0" rIns="0" bIns="0" rtlCol="0" anchor="ctr"/>
+          <a:lstStyle/>
+          <a:p>
+            <a:pPr indent="0" marL="0">
+              <a:buNone/>
+            </a:pPr>
+            <a:r>
+              <a:rPr lang="en-US" sz="1100" dirty="0">
+                <a:solidFill>
+                  <a:srgbClr val="5B6472"/>
+                </a:solidFill>
+                <a:latin typeface="Calibri" pitchFamily="34" charset="0"/>
+                <a:ea typeface="Calibri" pitchFamily="34" charset="-122"/>
+                <a:cs typeface="Calibri" pitchFamily="34" charset="-120"/>
+              </a:rPr>
+              <a:t>注意点: 短時間の連続投稿はスパム扱いされやすい。投稿タイミング(米国の朝〜昼にあたる時間帯)も反応に影響しやすいと言われる</a:t>
+            </a:r>
+            <a:endParaRPr lang="en-US" sz="1100" dirty="0"/>
+          </a:p>
+        </p:txBody>
+      </p:sp>
+      <p:sp>
+        <p:nvSpPr>
+          <p:cNvPr id="18" name="Text 16"/>
+          <p:cNvSpPr txBox="1"/>
+          <p:nvPr/>
+        </p:nvSpPr>
+        <p:spPr>
+          <a:xfrm>
+            <a:off x="548640" y="6400800"/>
+            <a:ext cx="10424160" cy="320040"/>
+          </a:xfrm>
+          <a:prstGeom prst="rect">
+            <a:avLst/>
+          </a:prstGeom>
+          <a:noFill/>
+          <a:ln/>
+        </p:spPr>
+        <p:txBody>
+          <a:bodyPr wrap="square" lIns="0" tIns="0" rIns="0" bIns="0" rtlCol="0" anchor="ctr"/>
+          <a:lstStyle/>
+          <a:p>
+            <a:pPr indent="0" marL="0">
+              <a:buNone/>
+            </a:pPr>
+            <a:r>
+              <a:rPr lang="en-US" sz="1000" i="1" dirty="0">
+                <a:solidFill>
+                  <a:srgbClr val="5B6472"/>
+                </a:solidFill>
+                <a:latin typeface="Calibri" pitchFamily="34" charset="0"/>
+                <a:ea typeface="Calibri" pitchFamily="34" charset="-122"/>
+                <a:cs typeface="Calibri" pitchFamily="34" charset="-120"/>
+              </a:rPr>
+              <a:t>出典: Hacker News公式の投稿・利用フロー、および個人開発者(Ephe)の実体験</a:t>
+            </a:r>
+            <a:endParaRPr lang="en-US" sz="1000" dirty="0"/>
+          </a:p>
+        </p:txBody>
+      </p:sp>
+      <p:sp>
+        <p:nvSpPr>
+          <p:cNvPr id="19" name="Text 17"/>
+          <p:cNvSpPr txBox="1"/>
+          <p:nvPr/>
+        </p:nvSpPr>
+        <p:spPr>
+          <a:xfrm>
+            <a:off x="11521440" y="6492240"/>
+            <a:ext cx="457200" cy="274320"/>
+          </a:xfrm>
+          <a:prstGeom prst="rect">
+            <a:avLst/>
+          </a:prstGeom>
+          <a:noFill/>
+          <a:ln/>
+        </p:spPr>
+        <p:txBody>
+          <a:bodyPr wrap="square" lIns="0" tIns="0" rIns="0" bIns="0" rtlCol="0" anchor="ctr"/>
+          <a:lstStyle/>
+          <a:p>
+            <a:pPr algn="r" indent="0" marL="0">
+              <a:buNone/>
+            </a:pPr>
+            <a:r>
+              <a:rPr lang="en-US" sz="1000" dirty="0">
+                <a:solidFill>
+                  <a:srgbClr val="5B6472"/>
+                </a:solidFill>
+                <a:latin typeface="Calibri" pitchFamily="34" charset="0"/>
+                <a:ea typeface="Calibri" pitchFamily="34" charset="-122"/>
+                <a:cs typeface="Calibri" pitchFamily="34" charset="-120"/>
+              </a:rPr>
+              <a:t>11</a:t>
+            </a:r>
+            <a:endParaRPr lang="en-US" sz="1000" dirty="0"/>
+          </a:p>
+        </p:txBody>
+      </p:sp>
+    </p:spTree>
+  </p:cSld>
+  <p:clrMapOvr>
+    <a:masterClrMapping/>
+  </p:clrMapOvr>
+</p:sld>
+</file>
+
+<file path=ppt/slides/slide12.xml><?xml version="1.0" encoding="utf-8"?>
+<p:sld xmlns:a="http://schemas.openxmlformats.org/drawingml/2006/main" xmlns:r="http://schemas.openxmlformats.org/officeDocument/2006/relationships" xmlns:p="http://schemas.openxmlformats.org/presentationml/2006/main">
+  <p:cSld name="Slide 12">
+    <p:bg>
+      <p:bgPr>
+        <a:solidFill>
           <a:srgbClr val="1A1F26"/>
         </a:solidFill>
       </p:bgPr>
@@ -3409,7 +4184,7 @@
                 <a:ea typeface="Calibri" pitchFamily="34" charset="-122"/>
                 <a:cs typeface="Calibri" pitchFamily="34" charset="-120"/>
               </a:rPr>
-              <a:t>11</a:t>
+              <a:t>12</a:t>
             </a:r>
             <a:endParaRPr lang="en-US" sz="1000" dirty="0"/>
           </a:p>
@@ -3423,9 +4198,9 @@
 </p:sld>
 </file>
 
-<file path=ppt/slides/slide12.xml><?xml version="1.0" encoding="utf-8"?>
+<file path=ppt/slides/slide13.xml><?xml version="1.0" encoding="utf-8"?>
 <p:sld xmlns:a="http://schemas.openxmlformats.org/drawingml/2006/main" xmlns:r="http://schemas.openxmlformats.org/officeDocument/2006/relationships" xmlns:p="http://schemas.openxmlformats.org/presentationml/2006/main">
-  <p:cSld name="Slide 12">
+  <p:cSld name="Slide 13">
     <p:bg>
       <p:bgPr>
         <a:solidFill>
@@ -3904,7 +4679,7 @@
                 <a:ea typeface="Calibri" pitchFamily="34" charset="-122"/>
                 <a:cs typeface="Calibri" pitchFamily="34" charset="-120"/>
               </a:rPr>
-              <a:t>12</a:t>
+              <a:t>13</a:t>
             </a:r>
             <a:endParaRPr lang="en-US" sz="1000" dirty="0"/>
           </a:p>

</xml_diff>

<commit_message>
Clarify GitHub URL submission is manual-only on Hacker News
Explains that pasting a GitHub repo URL into the HN submit form
needs no special integration, while automated/API-based submission
is not officially supported.

Co-Authored-By: Claude Sonnet 5 <noreply@anthropic.com>
Claude-Session: https://claude.ai/code/session_011KHa4MUwNn3SuV95WoncKQ
</commit_message>
<xml_diff>
--- a/github-strategy-guide.pptx
+++ b/github-strategy-guide.pptx
@@ -3213,11 +3213,11 @@
         <p:spPr>
           <a:xfrm>
             <a:off x="548640" y="1920240"/>
-            <a:ext cx="10607040" cy="914400"/>
+            <a:ext cx="10607040" cy="777240"/>
           </a:xfrm>
           <a:prstGeom prst="roundRect">
             <a:avLst>
-              <a:gd name="adj" fmla="val 8000"/>
+              <a:gd name="adj" fmla="val 9412"/>
             </a:avLst>
           </a:prstGeom>
           <a:solidFill>
@@ -3239,8 +3239,8 @@
         </p:nvSpPr>
         <p:spPr>
           <a:xfrm>
-            <a:off x="822960" y="2039112"/>
-            <a:ext cx="2834640" cy="640080"/>
+            <a:off x="822960" y="2011680"/>
+            <a:ext cx="2834640" cy="594360"/>
           </a:xfrm>
           <a:prstGeom prst="rect">
             <a:avLst/>
@@ -3256,7 +3256,7 @@
               <a:buNone/>
             </a:pPr>
             <a:r>
-              <a:rPr lang="en-US" sz="1350" b="1" dirty="0">
+              <a:rPr lang="en-US" sz="1300" b="1" dirty="0">
                 <a:solidFill>
                   <a:srgbClr val="B084F5"/>
                 </a:solidFill>
@@ -3266,7 +3266,7 @@
               </a:rPr>
               <a:t>① アカウント作成</a:t>
             </a:r>
-            <a:endParaRPr lang="en-US" sz="1350" dirty="0"/>
+            <a:endParaRPr lang="en-US" sz="1300" dirty="0"/>
           </a:p>
         </p:txBody>
       </p:sp>
@@ -3278,24 +3278,24 @@
         </p:nvSpPr>
         <p:spPr>
           <a:xfrm>
-            <a:off x="3749040" y="2039112"/>
-            <a:ext cx="7315200" cy="685800"/>
-          </a:xfrm>
-          <a:prstGeom prst="rect">
-            <a:avLst/>
-          </a:prstGeom>
-          <a:noFill/>
-          <a:ln/>
-        </p:spPr>
-        <p:txBody>
-          <a:bodyPr wrap="square" lIns="0" tIns="0" rIns="0" bIns="0" rtlCol="0" anchor="ctr"/>
-          <a:lstStyle/>
-          <a:p>
-            <a:pPr indent="0" marL="0">
-              <a:buNone/>
-            </a:pPr>
-            <a:r>
-              <a:rPr lang="en-US" sz="1150" dirty="0">
+            <a:off x="3749040" y="2011680"/>
+            <a:ext cx="7315200" cy="594360"/>
+          </a:xfrm>
+          <a:prstGeom prst="rect">
+            <a:avLst/>
+          </a:prstGeom>
+          <a:noFill/>
+          <a:ln/>
+        </p:spPr>
+        <p:txBody>
+          <a:bodyPr wrap="square" lIns="0" tIns="0" rIns="0" bIns="0" rtlCol="0" anchor="ctr"/>
+          <a:lstStyle/>
+          <a:p>
+            <a:pPr indent="0" marL="0">
+              <a:buNone/>
+            </a:pPr>
+            <a:r>
+              <a:rPr lang="en-US" sz="1050" dirty="0">
                 <a:solidFill>
                   <a:srgbClr val="5B6472"/>
                 </a:solidFill>
@@ -3305,7 +3305,7 @@
               </a:rPr>
               <a:t>news.ycombinator.com/login → 「Create Account」。ユーザー名とパスワードのみ、メール登録不要</a:t>
             </a:r>
-            <a:endParaRPr lang="en-US" sz="1150" dirty="0"/>
+            <a:endParaRPr lang="en-US" sz="1050" dirty="0"/>
           </a:p>
         </p:txBody>
       </p:sp>
@@ -3317,12 +3317,12 @@
         </p:nvSpPr>
         <p:spPr>
           <a:xfrm>
-            <a:off x="548640" y="2971800"/>
-            <a:ext cx="10607040" cy="914400"/>
+            <a:off x="548640" y="2834640"/>
+            <a:ext cx="10607040" cy="777240"/>
           </a:xfrm>
           <a:prstGeom prst="roundRect">
             <a:avLst>
-              <a:gd name="adj" fmla="val 8000"/>
+              <a:gd name="adj" fmla="val 9412"/>
             </a:avLst>
           </a:prstGeom>
           <a:solidFill>
@@ -3344,8 +3344,8 @@
         </p:nvSpPr>
         <p:spPr>
           <a:xfrm>
-            <a:off x="822960" y="3090672"/>
-            <a:ext cx="2834640" cy="640080"/>
+            <a:off x="822960" y="2926080"/>
+            <a:ext cx="2834640" cy="594360"/>
           </a:xfrm>
           <a:prstGeom prst="rect">
             <a:avLst/>
@@ -3361,7 +3361,7 @@
               <a:buNone/>
             </a:pPr>
             <a:r>
-              <a:rPr lang="en-US" sz="1350" b="1" dirty="0">
+              <a:rPr lang="en-US" sz="1300" b="1" dirty="0">
                 <a:solidFill>
                   <a:srgbClr val="B084F5"/>
                 </a:solidFill>
@@ -3371,7 +3371,7 @@
               </a:rPr>
               <a:t>② /newest を理解する</a:t>
             </a:r>
-            <a:endParaRPr lang="en-US" sz="1350" dirty="0"/>
+            <a:endParaRPr lang="en-US" sz="1300" dirty="0"/>
           </a:p>
         </p:txBody>
       </p:sp>
@@ -3383,24 +3383,24 @@
         </p:nvSpPr>
         <p:spPr>
           <a:xfrm>
-            <a:off x="3749040" y="3090672"/>
-            <a:ext cx="7315200" cy="685800"/>
-          </a:xfrm>
-          <a:prstGeom prst="rect">
-            <a:avLst/>
-          </a:prstGeom>
-          <a:noFill/>
-          <a:ln/>
-        </p:spPr>
-        <p:txBody>
-          <a:bodyPr wrap="square" lIns="0" tIns="0" rIns="0" bIns="0" rtlCol="0" anchor="ctr"/>
-          <a:lstStyle/>
-          <a:p>
-            <a:pPr indent="0" marL="0">
-              <a:buNone/>
-            </a:pPr>
-            <a:r>
-              <a:rPr lang="en-US" sz="1150" dirty="0">
+            <a:off x="3749040" y="2926080"/>
+            <a:ext cx="7315200" cy="594360"/>
+          </a:xfrm>
+          <a:prstGeom prst="rect">
+            <a:avLst/>
+          </a:prstGeom>
+          <a:noFill/>
+          <a:ln/>
+        </p:spPr>
+        <p:txBody>
+          <a:bodyPr wrap="square" lIns="0" tIns="0" rIns="0" bIns="0" rtlCol="0" anchor="ctr"/>
+          <a:lstStyle/>
+          <a:p>
+            <a:pPr indent="0" marL="0">
+              <a:buNone/>
+            </a:pPr>
+            <a:r>
+              <a:rPr lang="en-US" sz="1050" dirty="0">
                 <a:solidFill>
                   <a:srgbClr val="5B6472"/>
                 </a:solidFill>
@@ -3410,7 +3410,7 @@
               </a:rPr>
               <a:t>news.ycombinator.com/newest は投稿順の新着一覧。ここでUpvoteを集めるとアルゴリズムでトップページ側へ浮上する</a:t>
             </a:r>
-            <a:endParaRPr lang="en-US" sz="1150" dirty="0"/>
+            <a:endParaRPr lang="en-US" sz="1050" dirty="0"/>
           </a:p>
         </p:txBody>
       </p:sp>
@@ -3422,12 +3422,12 @@
         </p:nvSpPr>
         <p:spPr>
           <a:xfrm>
-            <a:off x="548640" y="4023360"/>
-            <a:ext cx="10607040" cy="914400"/>
+            <a:off x="548640" y="3749040"/>
+            <a:ext cx="10607040" cy="777240"/>
           </a:xfrm>
           <a:prstGeom prst="roundRect">
             <a:avLst>
-              <a:gd name="adj" fmla="val 8000"/>
+              <a:gd name="adj" fmla="val 9412"/>
             </a:avLst>
           </a:prstGeom>
           <a:solidFill>
@@ -3449,8 +3449,8 @@
         </p:nvSpPr>
         <p:spPr>
           <a:xfrm>
-            <a:off x="822960" y="4142232"/>
-            <a:ext cx="2834640" cy="640080"/>
+            <a:off x="822960" y="3840480"/>
+            <a:ext cx="2834640" cy="594360"/>
           </a:xfrm>
           <a:prstGeom prst="rect">
             <a:avLst/>
@@ -3466,7 +3466,7 @@
               <a:buNone/>
             </a:pPr>
             <a:r>
-              <a:rPr lang="en-US" sz="1350" b="1" dirty="0">
+              <a:rPr lang="en-US" sz="1300" b="1" dirty="0">
                 <a:solidFill>
                   <a:srgbClr val="B084F5"/>
                 </a:solidFill>
@@ -3474,9 +3474,9 @@
                 <a:ea typeface="Calibri" pitchFamily="34" charset="-122"/>
                 <a:cs typeface="Calibri" pitchFamily="34" charset="-120"/>
               </a:rPr>
-              <a:t>③ Show HN: で投稿する</a:t>
-            </a:r>
-            <a:endParaRPr lang="en-US" sz="1350" dirty="0"/>
+              <a:t>③ URLをそのまま貼って投稿</a:t>
+            </a:r>
+            <a:endParaRPr lang="en-US" sz="1300" dirty="0"/>
           </a:p>
         </p:txBody>
       </p:sp>
@@ -3488,24 +3488,24 @@
         </p:nvSpPr>
         <p:spPr>
           <a:xfrm>
-            <a:off x="3749040" y="4142232"/>
-            <a:ext cx="7315200" cy="685800"/>
-          </a:xfrm>
-          <a:prstGeom prst="rect">
-            <a:avLst/>
-          </a:prstGeom>
-          <a:noFill/>
-          <a:ln/>
-        </p:spPr>
-        <p:txBody>
-          <a:bodyPr wrap="square" lIns="0" tIns="0" rIns="0" bIns="0" rtlCol="0" anchor="ctr"/>
-          <a:lstStyle/>
-          <a:p>
-            <a:pPr indent="0" marL="0">
-              <a:buNone/>
-            </a:pPr>
-            <a:r>
-              <a:rPr lang="en-US" sz="1150" dirty="0">
+            <a:off x="3749040" y="3840480"/>
+            <a:ext cx="7315200" cy="594360"/>
+          </a:xfrm>
+          <a:prstGeom prst="rect">
+            <a:avLst/>
+          </a:prstGeom>
+          <a:noFill/>
+          <a:ln/>
+        </p:spPr>
+        <p:txBody>
+          <a:bodyPr wrap="square" lIns="0" tIns="0" rIns="0" bIns="0" rtlCol="0" anchor="ctr"/>
+          <a:lstStyle/>
+          <a:p>
+            <a:pPr indent="0" marL="0">
+              <a:buNone/>
+            </a:pPr>
+            <a:r>
+              <a:rPr lang="en-US" sz="1050" dirty="0">
                 <a:solidFill>
                   <a:srgbClr val="5B6472"/>
                 </a:solidFill>
@@ -3513,9 +3513,9 @@
                 <a:ea typeface="Calibri" pitchFamily="34" charset="-122"/>
                 <a:cs typeface="Calibri" pitchFamily="34" charset="-120"/>
               </a:rPr>
-              <a:t>submitページでタイトル先頭に「Show HN: 」を付けると、自作ツール専用の Show タブにも掲載される</a:t>
-            </a:r>
-            <a:endParaRPr lang="en-US" sz="1150" dirty="0"/>
+              <a:t>submitページの「URL」欄にGitHubリポジトリのURLをそのまま貼るだけでよい(特別な連携・認証設定は不要)。Titleは先頭に「Show HN: 」を付けると自作ツール専用のShowタブにも掲載される</a:t>
+            </a:r>
+            <a:endParaRPr lang="en-US" sz="1050" dirty="0"/>
           </a:p>
         </p:txBody>
       </p:sp>
@@ -3527,12 +3527,12 @@
         </p:nvSpPr>
         <p:spPr>
           <a:xfrm>
-            <a:off x="548640" y="5074920"/>
-            <a:ext cx="10607040" cy="914400"/>
+            <a:off x="548640" y="4663440"/>
+            <a:ext cx="10607040" cy="777240"/>
           </a:xfrm>
           <a:prstGeom prst="roundRect">
             <a:avLst>
-              <a:gd name="adj" fmla="val 8000"/>
+              <a:gd name="adj" fmla="val 9412"/>
             </a:avLst>
           </a:prstGeom>
           <a:solidFill>
@@ -3554,8 +3554,8 @@
         </p:nvSpPr>
         <p:spPr>
           <a:xfrm>
-            <a:off x="822960" y="5193792"/>
-            <a:ext cx="2834640" cy="640080"/>
+            <a:off x="822960" y="4754880"/>
+            <a:ext cx="2834640" cy="594360"/>
           </a:xfrm>
           <a:prstGeom prst="rect">
             <a:avLst/>
@@ -3571,7 +3571,7 @@
               <a:buNone/>
             </a:pPr>
             <a:r>
-              <a:rPr lang="en-US" sz="1350" b="1" dirty="0">
+              <a:rPr lang="en-US" sz="1300" b="1" dirty="0">
                 <a:solidFill>
                   <a:srgbClr val="B084F5"/>
                 </a:solidFill>
@@ -3581,7 +3581,7 @@
               </a:rPr>
               <a:t>④ Karma(信頼度)を意識</a:t>
             </a:r>
-            <a:endParaRPr lang="en-US" sz="1350" dirty="0"/>
+            <a:endParaRPr lang="en-US" sz="1300" dirty="0"/>
           </a:p>
         </p:txBody>
       </p:sp>
@@ -3593,24 +3593,24 @@
         </p:nvSpPr>
         <p:spPr>
           <a:xfrm>
-            <a:off x="3749040" y="5193792"/>
-            <a:ext cx="7315200" cy="685800"/>
-          </a:xfrm>
-          <a:prstGeom prst="rect">
-            <a:avLst/>
-          </a:prstGeom>
-          <a:noFill/>
-          <a:ln/>
-        </p:spPr>
-        <p:txBody>
-          <a:bodyPr wrap="square" lIns="0" tIns="0" rIns="0" bIns="0" rtlCol="0" anchor="ctr"/>
-          <a:lstStyle/>
-          <a:p>
-            <a:pPr indent="0" marL="0">
-              <a:buNone/>
-            </a:pPr>
-            <a:r>
-              <a:rPr lang="en-US" sz="1150" dirty="0">
+            <a:off x="3749040" y="4754880"/>
+            <a:ext cx="7315200" cy="594360"/>
+          </a:xfrm>
+          <a:prstGeom prst="rect">
+            <a:avLst/>
+          </a:prstGeom>
+          <a:noFill/>
+          <a:ln/>
+        </p:spPr>
+        <p:txBody>
+          <a:bodyPr wrap="square" lIns="0" tIns="0" rIns="0" bIns="0" rtlCol="0" anchor="ctr"/>
+          <a:lstStyle/>
+          <a:p>
+            <a:pPr indent="0" marL="0">
+              <a:buNone/>
+            </a:pPr>
+            <a:r>
+              <a:rPr lang="en-US" sz="1050" dirty="0">
                 <a:solidFill>
                   <a:srgbClr val="5B6472"/>
                 </a:solidFill>
@@ -3620,44 +3620,68 @@
               </a:rPr>
               <a:t>他人の投稿へのコメント・Upvoteで蓄積されるポイント制度。低いと表示・投稿頻度で不利になることがある</a:t>
             </a:r>
-            <a:endParaRPr lang="en-US" sz="1150" dirty="0"/>
-          </a:p>
-        </p:txBody>
-      </p:sp>
-      <p:sp>
-        <p:nvSpPr>
-          <p:cNvPr id="17" name="Text 15"/>
-          <p:cNvSpPr txBox="1"/>
-          <p:nvPr/>
-        </p:nvSpPr>
-        <p:spPr>
-          <a:xfrm>
-            <a:off x="548640" y="5989320"/>
-            <a:ext cx="10607040" cy="365760"/>
-          </a:xfrm>
-          <a:prstGeom prst="rect">
-            <a:avLst/>
-          </a:prstGeom>
-          <a:noFill/>
-          <a:ln/>
-        </p:spPr>
-        <p:txBody>
-          <a:bodyPr wrap="square" lIns="0" tIns="0" rIns="0" bIns="0" rtlCol="0" anchor="ctr"/>
-          <a:lstStyle/>
-          <a:p>
-            <a:pPr indent="0" marL="0">
-              <a:buNone/>
-            </a:pPr>
-            <a:r>
-              <a:rPr lang="en-US" sz="1100" dirty="0">
-                <a:solidFill>
-                  <a:srgbClr val="5B6472"/>
-                </a:solidFill>
-                <a:latin typeface="Calibri" pitchFamily="34" charset="0"/>
-                <a:ea typeface="Calibri" pitchFamily="34" charset="-122"/>
-                <a:cs typeface="Calibri" pitchFamily="34" charset="-120"/>
-              </a:rPr>
-              <a:t>注意点: 短時間の連続投稿はスパム扱いされやすい。投稿タイミング(米国の朝〜昼にあたる時間帯)も反応に影響しやすいと言われる</a:t>
+            <a:endParaRPr lang="en-US" sz="1050" dirty="0"/>
+          </a:p>
+        </p:txBody>
+      </p:sp>
+      <p:sp>
+        <p:nvSpPr>
+          <p:cNvPr id="17" name="Shape 15"/>
+          <p:cNvSpPr/>
+          <p:nvPr/>
+        </p:nvSpPr>
+        <p:spPr>
+          <a:xfrm>
+            <a:off x="548640" y="5623560"/>
+            <a:ext cx="10607040" cy="594360"/>
+          </a:xfrm>
+          <a:prstGeom prst="roundRect">
+            <a:avLst>
+              <a:gd name="adj" fmla="val 12308"/>
+            </a:avLst>
+          </a:prstGeom>
+          <a:solidFill>
+            <a:srgbClr val="B084F5">
+              <a:alpha val="12000"/>
+            </a:srgbClr>
+          </a:solidFill>
+          <a:ln/>
+        </p:spPr>
+      </p:sp>
+      <p:sp>
+        <p:nvSpPr>
+          <p:cNvPr id="18" name="Text 16"/>
+          <p:cNvSpPr txBox="1"/>
+          <p:nvPr/>
+        </p:nvSpPr>
+        <p:spPr>
+          <a:xfrm>
+            <a:off x="822960" y="5696712"/>
+            <a:ext cx="10058400" cy="457200"/>
+          </a:xfrm>
+          <a:prstGeom prst="rect">
+            <a:avLst/>
+          </a:prstGeom>
+          <a:noFill/>
+          <a:ln/>
+        </p:spPr>
+        <p:txBody>
+          <a:bodyPr wrap="square" lIns="0" tIns="0" rIns="0" bIns="0" rtlCol="0" anchor="ctr"/>
+          <a:lstStyle/>
+          <a:p>
+            <a:pPr indent="0" marL="0">
+              <a:buNone/>
+            </a:pPr>
+            <a:r>
+              <a:rPr lang="en-US" sz="1100" b="1" dirty="0">
+                <a:solidFill>
+                  <a:srgbClr val="1A1F26"/>
+                </a:solidFill>
+                <a:latin typeface="Calibri" pitchFamily="34" charset="0"/>
+                <a:ea typeface="Calibri" pitchFamily="34" charset="-122"/>
+                <a:cs typeface="Calibri" pitchFamily="34" charset="-120"/>
+              </a:rPr>
+              <a:t>手動投稿は簡単/自動投稿は非対応: URLを貼るだけの手動投稿にハードルは無い。一方、GitHub Actions等からのAPI経由の自動投稿はHNが公式提供しておらず、規約上も推奨されない</a:t>
             </a:r>
             <a:endParaRPr lang="en-US" sz="1100" dirty="0"/>
           </a:p>
@@ -3665,7 +3689,7 @@
       </p:sp>
       <p:sp>
         <p:nvSpPr>
-          <p:cNvPr id="18" name="Text 16"/>
+          <p:cNvPr id="19" name="Text 17"/>
           <p:cNvSpPr txBox="1"/>
           <p:nvPr/>
         </p:nvSpPr>
@@ -3704,7 +3728,7 @@
       </p:sp>
       <p:sp>
         <p:nvSpPr>
-          <p:cNvPr id="19" name="Text 17"/>
+          <p:cNvPr id="20" name="Text 18"/>
           <p:cNvSpPr txBox="1"/>
           <p:nvPr/>
         </p:nvSpPr>

</xml_diff>